<commit_message>
Make EN deck white-dominant
Convert the cover, innovations, and closing slides from navy to white
backgrounds; switch text to dark ink, cards to light panels, and add
teal check icons / accents so contrast holds on white. Navy is now
reserved for the before/after side panel on slide 3 only.

Co-Authored-By: Claude Opus 4.8 (1M context) <noreply@anthropic.com>
</commit_message>
<xml_diff>
--- a/ppt/AML-System-Walkthrough-Legal-EN.pptx
+++ b/ppt/AML-System-Walkthrough-Legal-EN.pptx
@@ -1391,7 +1391,7 @@
     <p:bg>
       <p:bgPr>
         <a:solidFill>
-          <a:srgbClr val="102C3A"/>
+          <a:srgbClr val="FFFFFF"/>
         </a:solidFill>
       </p:bgPr>
     </p:bg>
@@ -1417,8 +1417,52 @@
         </p:nvSpPr>
         <p:spPr>
           <a:xfrm>
+            <a:off x="8534095" y="-2377440"/>
+            <a:ext cx="5943600" cy="5943600"/>
+          </a:xfrm>
+          <a:prstGeom prst="ellipse">
+            <a:avLst/>
+          </a:prstGeom>
+          <a:solidFill>
+            <a:srgbClr val="1BA39C">
+              <a:alpha val="8000"/>
+            </a:srgbClr>
+          </a:solidFill>
+          <a:ln/>
+        </p:spPr>
+      </p:sp>
+      <p:sp>
+        <p:nvSpPr>
+          <p:cNvPr id="3" name="Shape 1"/>
+          <p:cNvSpPr/>
+          <p:nvPr/>
+        </p:nvSpPr>
+        <p:spPr>
+          <a:xfrm>
+            <a:off x="9997135" y="2560320"/>
+            <a:ext cx="4572000" cy="4572000"/>
+          </a:xfrm>
+          <a:prstGeom prst="ellipse">
+            <a:avLst/>
+          </a:prstGeom>
+          <a:solidFill>
+            <a:srgbClr val="1BA39C">
+              <a:alpha val="5000"/>
+            </a:srgbClr>
+          </a:solidFill>
+          <a:ln/>
+        </p:spPr>
+      </p:sp>
+      <p:sp>
+        <p:nvSpPr>
+          <p:cNvPr id="4" name="Shape 2"/>
+          <p:cNvSpPr/>
+          <p:nvPr/>
+        </p:nvSpPr>
+        <p:spPr>
+          <a:xfrm>
             <a:off x="0" y="0"/>
-            <a:ext cx="12191695" cy="164592"/>
+            <a:ext cx="256032" cy="6858000"/>
           </a:xfrm>
           <a:prstGeom prst="rect">
             <a:avLst/>
@@ -1431,50 +1475,6 @@
       </p:sp>
       <p:sp>
         <p:nvSpPr>
-          <p:cNvPr id="3" name="Shape 1"/>
-          <p:cNvSpPr/>
-          <p:nvPr/>
-        </p:nvSpPr>
-        <p:spPr>
-          <a:xfrm>
-            <a:off x="8351215" y="-2194560"/>
-            <a:ext cx="5943600" cy="5943600"/>
-          </a:xfrm>
-          <a:prstGeom prst="ellipse">
-            <a:avLst/>
-          </a:prstGeom>
-          <a:solidFill>
-            <a:srgbClr val="37B7AD">
-              <a:alpha val="18000"/>
-            </a:srgbClr>
-          </a:solidFill>
-          <a:ln/>
-        </p:spPr>
-      </p:sp>
-      <p:sp>
-        <p:nvSpPr>
-          <p:cNvPr id="4" name="Shape 2"/>
-          <p:cNvSpPr/>
-          <p:nvPr/>
-        </p:nvSpPr>
-        <p:spPr>
-          <a:xfrm>
-            <a:off x="9814255" y="2377440"/>
-            <a:ext cx="4572000" cy="4572000"/>
-          </a:xfrm>
-          <a:prstGeom prst="ellipse">
-            <a:avLst/>
-          </a:prstGeom>
-          <a:solidFill>
-            <a:srgbClr val="1BA39C">
-              <a:alpha val="12000"/>
-            </a:srgbClr>
-          </a:solidFill>
-          <a:ln/>
-        </p:spPr>
-      </p:sp>
-      <p:sp>
-        <p:nvSpPr>
           <p:cNvPr id="5" name="Text 3"/>
           <p:cNvSpPr/>
           <p:nvPr/>
@@ -1504,7 +1504,7 @@
             <a:r>
               <a:rPr lang="en-US" sz="4000" b="1" dirty="0">
                 <a:solidFill>
-                  <a:srgbClr val="102C3A"/>
+                  <a:srgbClr val="FFFFFF"/>
                 </a:solidFill>
                 <a:latin typeface="Calibri" pitchFamily="34" charset="0"/>
                 <a:ea typeface="Calibri" pitchFamily="34" charset="-122"/>
@@ -1543,7 +1543,7 @@
             <a:r>
               <a:rPr lang="en-US" sz="4000" b="1" dirty="0">
                 <a:solidFill>
-                  <a:srgbClr val="FFFFFF"/>
+                  <a:srgbClr val="17313F"/>
                 </a:solidFill>
                 <a:latin typeface="Calibri" pitchFamily="34" charset="0"/>
                 <a:ea typeface="Calibri" pitchFamily="34" charset="-122"/>
@@ -1580,9 +1580,9 @@
               <a:buNone/>
             </a:pPr>
             <a:r>
-              <a:rPr lang="en-US" sz="1900" dirty="0">
-                <a:solidFill>
-                  <a:srgbClr val="AECDD6"/>
+              <a:rPr lang="en-US" sz="1900" b="1" dirty="0">
+                <a:solidFill>
+                  <a:srgbClr val="1BA39C"/>
                 </a:solidFill>
                 <a:latin typeface="Calibri" pitchFamily="34" charset="0"/>
                 <a:ea typeface="Calibri" pitchFamily="34" charset="-122"/>
@@ -1621,7 +1621,7 @@
             <a:r>
               <a:rPr lang="en-US" sz="1400" dirty="0">
                 <a:solidFill>
-                  <a:srgbClr val="8FB2BD"/>
+                  <a:srgbClr val="71838F"/>
                 </a:solidFill>
                 <a:latin typeface="Calibri" pitchFamily="34" charset="0"/>
                 <a:ea typeface="Calibri" pitchFamily="34" charset="-122"/>
@@ -4568,7 +4568,7 @@
     <p:bg>
       <p:bgPr>
         <a:solidFill>
-          <a:srgbClr val="102C3A"/>
+          <a:srgbClr val="FFFFFF"/>
         </a:solidFill>
       </p:bgPr>
     </p:bg>
@@ -4588,23 +4588,42 @@
       </p:grpSpPr>
       <p:sp>
         <p:nvSpPr>
-          <p:cNvPr id="2" name="Shape 0"/>
-          <p:cNvSpPr/>
-          <p:nvPr/>
-        </p:nvSpPr>
-        <p:spPr>
-          <a:xfrm>
-            <a:off x="0" y="0"/>
-            <a:ext cx="12191695" cy="128016"/>
-          </a:xfrm>
-          <a:prstGeom prst="rect">
-            <a:avLst/>
-          </a:prstGeom>
-          <a:solidFill>
-            <a:srgbClr val="1BA39C"/>
-          </a:solidFill>
-          <a:ln/>
-        </p:spPr>
+          <p:cNvPr id="2" name="Text 0"/>
+          <p:cNvSpPr/>
+          <p:nvPr/>
+        </p:nvSpPr>
+        <p:spPr>
+          <a:xfrm>
+            <a:off x="548640" y="457200"/>
+            <a:ext cx="9144000" cy="274320"/>
+          </a:xfrm>
+          <a:prstGeom prst="rect">
+            <a:avLst/>
+          </a:prstGeom>
+          <a:noFill/>
+          <a:ln/>
+        </p:spPr>
+        <p:txBody>
+          <a:bodyPr wrap="square" rtlCol="0" anchor="ctr"/>
+          <a:lstStyle/>
+          <a:p>
+            <a:pPr indent="0" marL="0">
+              <a:buNone/>
+            </a:pPr>
+            <a:r>
+              <a:rPr lang="en-US" sz="1200" b="1" spc="200" kern="0" dirty="0">
+                <a:solidFill>
+                  <a:srgbClr val="1BA39C"/>
+                </a:solidFill>
+                <a:latin typeface="Calibri" pitchFamily="34" charset="0"/>
+                <a:ea typeface="Calibri" pitchFamily="34" charset="-122"/>
+                <a:cs typeface="Calibri" pitchFamily="34" charset="-120"/>
+              </a:rPr>
+              <a:t>THREE CORE INNOVATIONS</a:t>
+            </a:r>
+            <a:endParaRPr lang="en-US" sz="1200" dirty="0"/>
+          </a:p>
+        </p:txBody>
       </p:sp>
       <p:sp>
         <p:nvSpPr>
@@ -4614,47 +4633,8 @@
         </p:nvSpPr>
         <p:spPr>
           <a:xfrm>
-            <a:off x="548640" y="502920"/>
-            <a:ext cx="8229600" cy="365760"/>
-          </a:xfrm>
-          <a:prstGeom prst="rect">
-            <a:avLst/>
-          </a:prstGeom>
-          <a:noFill/>
-          <a:ln/>
-        </p:spPr>
-        <p:txBody>
-          <a:bodyPr wrap="square" rtlCol="0" anchor="ctr"/>
-          <a:lstStyle/>
-          <a:p>
-            <a:pPr indent="0" marL="0">
-              <a:buNone/>
-            </a:pPr>
-            <a:r>
-              <a:rPr lang="en-US" sz="1300" b="1" spc="200" kern="0" dirty="0">
-                <a:solidFill>
-                  <a:srgbClr val="37B7AD"/>
-                </a:solidFill>
-                <a:latin typeface="Calibri" pitchFamily="34" charset="0"/>
-                <a:ea typeface="Calibri" pitchFamily="34" charset="-122"/>
-                <a:cs typeface="Calibri" pitchFamily="34" charset="-120"/>
-              </a:rPr>
-              <a:t>THREE CORE INNOVATIONS</a:t>
-            </a:r>
-            <a:endParaRPr lang="en-US" sz="1300" dirty="0"/>
-          </a:p>
-        </p:txBody>
-      </p:sp>
-      <p:sp>
-        <p:nvSpPr>
-          <p:cNvPr id="4" name="Text 2"/>
-          <p:cNvSpPr/>
-          <p:nvPr/>
-        </p:nvSpPr>
-        <p:spPr>
-          <a:xfrm>
-            <a:off x="548640" y="914400"/>
-            <a:ext cx="10972800" cy="822960"/>
+            <a:off x="548640" y="749808"/>
+            <a:ext cx="11064240" cy="822960"/>
           </a:xfrm>
           <a:prstGeom prst="rect">
             <a:avLst/>
@@ -4672,7 +4652,7 @@
             <a:r>
               <a:rPr lang="en-US" sz="3000" b="1" dirty="0">
                 <a:solidFill>
-                  <a:srgbClr val="FFFFFF"/>
+                  <a:srgbClr val="17313F"/>
                 </a:solidFill>
                 <a:latin typeface="Calibri" pitchFamily="34" charset="0"/>
                 <a:ea typeface="Calibri" pitchFamily="34" charset="-122"/>
@@ -4686,7 +4666,7 @@
       </p:sp>
       <p:sp>
         <p:nvSpPr>
-          <p:cNvPr id="5" name="Shape 3"/>
+          <p:cNvPr id="4" name="Shape 2"/>
           <p:cNvSpPr/>
           <p:nvPr/>
         </p:nvSpPr>
@@ -4701,19 +4681,26 @@
             </a:avLst>
           </a:prstGeom>
           <a:solidFill>
-            <a:srgbClr val="16384A"/>
+            <a:srgbClr val="F4FAFB"/>
           </a:solidFill>
           <a:ln w="12700">
             <a:solidFill>
-              <a:srgbClr val="29516A"/>
+              <a:srgbClr val="DCE8EE"/>
             </a:solidFill>
             <a:prstDash val="solid"/>
           </a:ln>
-        </p:spPr>
-      </p:sp>
-      <p:sp>
-        <p:nvSpPr>
-          <p:cNvPr id="6" name="Shape 4"/>
+          <a:effectLst>
+            <a:outerShdw sx="100000" sy="100000" kx="0" ky="0" algn="bl" rotWithShape="0" blurRad="114300" dist="38100" dir="8100000">
+              <a:srgbClr val="0B1F2A">
+                <a:alpha val="16000"/>
+              </a:srgbClr>
+            </a:outerShdw>
+          </a:effectLst>
+        </p:spPr>
+      </p:sp>
+      <p:sp>
+        <p:nvSpPr>
+          <p:cNvPr id="5" name="Shape 3"/>
           <p:cNvSpPr/>
           <p:nvPr/>
         </p:nvSpPr>
@@ -4733,7 +4720,7 @@
       </p:sp>
       <p:pic>
         <p:nvPicPr>
-          <p:cNvPr id="7" name="Image 0" descr="preencoded.png">    </p:cNvPr>
+          <p:cNvPr id="6" name="Image 0" descr="preencoded.png">    </p:cNvPr>
           <p:cNvPicPr>
             <a:picLocks noChangeAspect="1"/>
           </p:cNvPicPr>
@@ -4757,7 +4744,7 @@
       </p:pic>
       <p:sp>
         <p:nvSpPr>
-          <p:cNvPr id="8" name="Text 5"/>
+          <p:cNvPr id="7" name="Text 4"/>
           <p:cNvSpPr/>
           <p:nvPr/>
         </p:nvSpPr>
@@ -4782,7 +4769,7 @@
             <a:r>
               <a:rPr lang="en-US" sz="3400" b="1" dirty="0">
                 <a:solidFill>
-                  <a:srgbClr val="29516A"/>
+                  <a:srgbClr val="CFE0E6"/>
                 </a:solidFill>
                 <a:latin typeface="Calibri" pitchFamily="34" charset="0"/>
                 <a:ea typeface="Calibri" pitchFamily="34" charset="-122"/>
@@ -4796,7 +4783,7 @@
       </p:sp>
       <p:sp>
         <p:nvSpPr>
-          <p:cNvPr id="9" name="Text 6"/>
+          <p:cNvPr id="8" name="Text 5"/>
           <p:cNvSpPr/>
           <p:nvPr/>
         </p:nvSpPr>
@@ -4824,7 +4811,7 @@
             <a:r>
               <a:rPr lang="en-US" sz="1700" b="1" dirty="0">
                 <a:solidFill>
-                  <a:srgbClr val="FFFFFF"/>
+                  <a:srgbClr val="17313F"/>
                 </a:solidFill>
                 <a:latin typeface="Calibri" pitchFamily="34" charset="0"/>
                 <a:ea typeface="Calibri" pitchFamily="34" charset="-122"/>
@@ -4838,7 +4825,7 @@
       </p:sp>
       <p:sp>
         <p:nvSpPr>
-          <p:cNvPr id="10" name="Text 7"/>
+          <p:cNvPr id="9" name="Text 6"/>
           <p:cNvSpPr/>
           <p:nvPr/>
         </p:nvSpPr>
@@ -4866,7 +4853,7 @@
             <a:r>
               <a:rPr lang="en-US" sz="1250" dirty="0">
                 <a:solidFill>
-                  <a:srgbClr val="AECDD6"/>
+                  <a:srgbClr val="71838F"/>
                 </a:solidFill>
                 <a:latin typeface="Calibri" pitchFamily="34" charset="0"/>
                 <a:ea typeface="Calibri" pitchFamily="34" charset="-122"/>
@@ -4880,7 +4867,7 @@
       </p:sp>
       <p:sp>
         <p:nvSpPr>
-          <p:cNvPr id="11" name="Shape 8"/>
+          <p:cNvPr id="10" name="Shape 7"/>
           <p:cNvSpPr/>
           <p:nvPr/>
         </p:nvSpPr>
@@ -4895,19 +4882,26 @@
             </a:avLst>
           </a:prstGeom>
           <a:solidFill>
-            <a:srgbClr val="16384A"/>
+            <a:srgbClr val="F4FAFB"/>
           </a:solidFill>
           <a:ln w="12700">
             <a:solidFill>
-              <a:srgbClr val="29516A"/>
+              <a:srgbClr val="DCE8EE"/>
             </a:solidFill>
             <a:prstDash val="solid"/>
           </a:ln>
-        </p:spPr>
-      </p:sp>
-      <p:sp>
-        <p:nvSpPr>
-          <p:cNvPr id="12" name="Shape 9"/>
+          <a:effectLst>
+            <a:outerShdw sx="100000" sy="100000" kx="0" ky="0" algn="bl" rotWithShape="0" blurRad="114300" dist="38100" dir="8100000">
+              <a:srgbClr val="0B1F2A">
+                <a:alpha val="16000"/>
+              </a:srgbClr>
+            </a:outerShdw>
+          </a:effectLst>
+        </p:spPr>
+      </p:sp>
+      <p:sp>
+        <p:nvSpPr>
+          <p:cNvPr id="11" name="Shape 8"/>
           <p:cNvSpPr/>
           <p:nvPr/>
         </p:nvSpPr>
@@ -4927,7 +4921,7 @@
       </p:sp>
       <p:pic>
         <p:nvPicPr>
-          <p:cNvPr id="13" name="Image 1" descr="preencoded.png">    </p:cNvPr>
+          <p:cNvPr id="12" name="Image 1" descr="preencoded.png">    </p:cNvPr>
           <p:cNvPicPr>
             <a:picLocks noChangeAspect="1"/>
           </p:cNvPicPr>
@@ -4951,7 +4945,7 @@
       </p:pic>
       <p:sp>
         <p:nvSpPr>
-          <p:cNvPr id="14" name="Text 10"/>
+          <p:cNvPr id="13" name="Text 9"/>
           <p:cNvSpPr/>
           <p:nvPr/>
         </p:nvSpPr>
@@ -4976,7 +4970,7 @@
             <a:r>
               <a:rPr lang="en-US" sz="3400" b="1" dirty="0">
                 <a:solidFill>
-                  <a:srgbClr val="29516A"/>
+                  <a:srgbClr val="CFE0E6"/>
                 </a:solidFill>
                 <a:latin typeface="Calibri" pitchFamily="34" charset="0"/>
                 <a:ea typeface="Calibri" pitchFamily="34" charset="-122"/>
@@ -4990,7 +4984,7 @@
       </p:sp>
       <p:sp>
         <p:nvSpPr>
-          <p:cNvPr id="15" name="Text 11"/>
+          <p:cNvPr id="14" name="Text 10"/>
           <p:cNvSpPr/>
           <p:nvPr/>
         </p:nvSpPr>
@@ -5018,7 +5012,7 @@
             <a:r>
               <a:rPr lang="en-US" sz="1700" b="1" dirty="0">
                 <a:solidFill>
-                  <a:srgbClr val="FFFFFF"/>
+                  <a:srgbClr val="17313F"/>
                 </a:solidFill>
                 <a:latin typeface="Calibri" pitchFamily="34" charset="0"/>
                 <a:ea typeface="Calibri" pitchFamily="34" charset="-122"/>
@@ -5032,7 +5026,7 @@
       </p:sp>
       <p:sp>
         <p:nvSpPr>
-          <p:cNvPr id="16" name="Text 12"/>
+          <p:cNvPr id="15" name="Text 11"/>
           <p:cNvSpPr/>
           <p:nvPr/>
         </p:nvSpPr>
@@ -5060,7 +5054,7 @@
             <a:r>
               <a:rPr lang="en-US" sz="1250" dirty="0">
                 <a:solidFill>
-                  <a:srgbClr val="AECDD6"/>
+                  <a:srgbClr val="71838F"/>
                 </a:solidFill>
                 <a:latin typeface="Calibri" pitchFamily="34" charset="0"/>
                 <a:ea typeface="Calibri" pitchFamily="34" charset="-122"/>
@@ -5074,7 +5068,7 @@
       </p:sp>
       <p:sp>
         <p:nvSpPr>
-          <p:cNvPr id="17" name="Shape 13"/>
+          <p:cNvPr id="16" name="Shape 12"/>
           <p:cNvSpPr/>
           <p:nvPr/>
         </p:nvSpPr>
@@ -5089,19 +5083,26 @@
             </a:avLst>
           </a:prstGeom>
           <a:solidFill>
-            <a:srgbClr val="16384A"/>
+            <a:srgbClr val="F4FAFB"/>
           </a:solidFill>
           <a:ln w="12700">
             <a:solidFill>
-              <a:srgbClr val="29516A"/>
+              <a:srgbClr val="DCE8EE"/>
             </a:solidFill>
             <a:prstDash val="solid"/>
           </a:ln>
-        </p:spPr>
-      </p:sp>
-      <p:sp>
-        <p:nvSpPr>
-          <p:cNvPr id="18" name="Shape 14"/>
+          <a:effectLst>
+            <a:outerShdw sx="100000" sy="100000" kx="0" ky="0" algn="bl" rotWithShape="0" blurRad="114300" dist="38100" dir="8100000">
+              <a:srgbClr val="0B1F2A">
+                <a:alpha val="16000"/>
+              </a:srgbClr>
+            </a:outerShdw>
+          </a:effectLst>
+        </p:spPr>
+      </p:sp>
+      <p:sp>
+        <p:nvSpPr>
+          <p:cNvPr id="17" name="Shape 13"/>
           <p:cNvSpPr/>
           <p:nvPr/>
         </p:nvSpPr>
@@ -5121,7 +5122,7 @@
       </p:sp>
       <p:pic>
         <p:nvPicPr>
-          <p:cNvPr id="19" name="Image 2" descr="preencoded.png">    </p:cNvPr>
+          <p:cNvPr id="18" name="Image 2" descr="preencoded.png">    </p:cNvPr>
           <p:cNvPicPr>
             <a:picLocks noChangeAspect="1"/>
           </p:cNvPicPr>
@@ -5145,7 +5146,7 @@
       </p:pic>
       <p:sp>
         <p:nvSpPr>
-          <p:cNvPr id="20" name="Text 15"/>
+          <p:cNvPr id="19" name="Text 14"/>
           <p:cNvSpPr/>
           <p:nvPr/>
         </p:nvSpPr>
@@ -5170,7 +5171,7 @@
             <a:r>
               <a:rPr lang="en-US" sz="3400" b="1" dirty="0">
                 <a:solidFill>
-                  <a:srgbClr val="29516A"/>
+                  <a:srgbClr val="CFE0E6"/>
                 </a:solidFill>
                 <a:latin typeface="Calibri" pitchFamily="34" charset="0"/>
                 <a:ea typeface="Calibri" pitchFamily="34" charset="-122"/>
@@ -5184,7 +5185,7 @@
       </p:sp>
       <p:sp>
         <p:nvSpPr>
-          <p:cNvPr id="21" name="Text 16"/>
+          <p:cNvPr id="20" name="Text 15"/>
           <p:cNvSpPr/>
           <p:nvPr/>
         </p:nvSpPr>
@@ -5212,7 +5213,7 @@
             <a:r>
               <a:rPr lang="en-US" sz="1700" b="1" dirty="0">
                 <a:solidFill>
-                  <a:srgbClr val="FFFFFF"/>
+                  <a:srgbClr val="17313F"/>
                 </a:solidFill>
                 <a:latin typeface="Calibri" pitchFamily="34" charset="0"/>
                 <a:ea typeface="Calibri" pitchFamily="34" charset="-122"/>
@@ -5226,7 +5227,7 @@
       </p:sp>
       <p:sp>
         <p:nvSpPr>
-          <p:cNvPr id="22" name="Text 17"/>
+          <p:cNvPr id="21" name="Text 16"/>
           <p:cNvSpPr/>
           <p:nvPr/>
         </p:nvSpPr>
@@ -5254,7 +5255,7 @@
             <a:r>
               <a:rPr lang="en-US" sz="1250" dirty="0">
                 <a:solidFill>
-                  <a:srgbClr val="AECDD6"/>
+                  <a:srgbClr val="71838F"/>
                 </a:solidFill>
                 <a:latin typeface="Calibri" pitchFamily="34" charset="0"/>
                 <a:ea typeface="Calibri" pitchFamily="34" charset="-122"/>
@@ -5268,7 +5269,7 @@
       </p:sp>
       <p:sp>
         <p:nvSpPr>
-          <p:cNvPr id="23" name="Text 18"/>
+          <p:cNvPr id="22" name="Text 17"/>
           <p:cNvSpPr/>
           <p:nvPr/>
         </p:nvSpPr>
@@ -5307,7 +5308,7 @@
       </p:sp>
       <p:sp>
         <p:nvSpPr>
-          <p:cNvPr id="24" name="Text 19"/>
+          <p:cNvPr id="23" name="Text 18"/>
           <p:cNvSpPr/>
           <p:nvPr/>
         </p:nvSpPr>
@@ -6387,7 +6388,7 @@
     <p:bg>
       <p:bgPr>
         <a:solidFill>
-          <a:srgbClr val="102C3A"/>
+          <a:srgbClr val="FFFFFF"/>
         </a:solidFill>
       </p:bgPr>
     </p:bg>
@@ -6413,27 +6414,7 @@
         </p:nvSpPr>
         <p:spPr>
           <a:xfrm>
-            <a:off x="0" y="0"/>
-            <a:ext cx="12191695" cy="128016"/>
-          </a:xfrm>
-          <a:prstGeom prst="rect">
-            <a:avLst/>
-          </a:prstGeom>
-          <a:solidFill>
-            <a:srgbClr val="1BA39C"/>
-          </a:solidFill>
-          <a:ln/>
-        </p:spPr>
-      </p:sp>
-      <p:sp>
-        <p:nvSpPr>
-          <p:cNvPr id="3" name="Shape 1"/>
-          <p:cNvSpPr/>
-          <p:nvPr/>
-        </p:nvSpPr>
-        <p:spPr>
-          <a:xfrm>
-            <a:off x="-1828800" y="4114800"/>
+            <a:off x="-2011680" y="4206240"/>
             <a:ext cx="5486400" cy="5486400"/>
           </a:xfrm>
           <a:prstGeom prst="ellipse">
@@ -6441,7 +6422,7 @@
           </a:prstGeom>
           <a:solidFill>
             <a:srgbClr val="1BA39C">
-              <a:alpha val="12000"/>
+              <a:alpha val="6000"/>
             </a:srgbClr>
           </a:solidFill>
           <a:ln/>
@@ -6449,40 +6430,79 @@
       </p:sp>
       <p:sp>
         <p:nvSpPr>
+          <p:cNvPr id="3" name="Text 1"/>
+          <p:cNvSpPr/>
+          <p:nvPr/>
+        </p:nvSpPr>
+        <p:spPr>
+          <a:xfrm>
+            <a:off x="548640" y="457200"/>
+            <a:ext cx="9144000" cy="274320"/>
+          </a:xfrm>
+          <a:prstGeom prst="rect">
+            <a:avLst/>
+          </a:prstGeom>
+          <a:noFill/>
+          <a:ln/>
+        </p:spPr>
+        <p:txBody>
+          <a:bodyPr wrap="square" rtlCol="0" anchor="ctr"/>
+          <a:lstStyle/>
+          <a:p>
+            <a:pPr indent="0" marL="0">
+              <a:buNone/>
+            </a:pPr>
+            <a:r>
+              <a:rPr lang="en-US" sz="1200" b="1" spc="200" kern="0" dirty="0">
+                <a:solidFill>
+                  <a:srgbClr val="1BA39C"/>
+                </a:solidFill>
+                <a:latin typeface="Calibri" pitchFamily="34" charset="0"/>
+                <a:ea typeface="Calibri" pitchFamily="34" charset="-122"/>
+                <a:cs typeface="Calibri" pitchFamily="34" charset="-120"/>
+              </a:rPr>
+              <a:t>IN ONE SENTENCE</a:t>
+            </a:r>
+            <a:endParaRPr lang="en-US" sz="1200" dirty="0"/>
+          </a:p>
+        </p:txBody>
+      </p:sp>
+      <p:sp>
+        <p:nvSpPr>
           <p:cNvPr id="4" name="Text 2"/>
           <p:cNvSpPr/>
           <p:nvPr/>
         </p:nvSpPr>
         <p:spPr>
           <a:xfrm>
-            <a:off x="548640" y="640080"/>
-            <a:ext cx="8229600" cy="365760"/>
-          </a:xfrm>
-          <a:prstGeom prst="rect">
-            <a:avLst/>
-          </a:prstGeom>
-          <a:noFill/>
-          <a:ln/>
-        </p:spPr>
-        <p:txBody>
-          <a:bodyPr wrap="square" rtlCol="0" anchor="ctr"/>
-          <a:lstStyle/>
-          <a:p>
-            <a:pPr indent="0" marL="0">
-              <a:buNone/>
-            </a:pPr>
-            <a:r>
-              <a:rPr lang="en-US" sz="1300" b="1" spc="200" kern="0" dirty="0">
-                <a:solidFill>
-                  <a:srgbClr val="37B7AD"/>
-                </a:solidFill>
-                <a:latin typeface="Calibri" pitchFamily="34" charset="0"/>
-                <a:ea typeface="Calibri" pitchFamily="34" charset="-122"/>
-                <a:cs typeface="Calibri" pitchFamily="34" charset="-120"/>
-              </a:rPr>
-              <a:t>IN ONE SENTENCE</a:t>
-            </a:r>
-            <a:endParaRPr lang="en-US" sz="1300" dirty="0"/>
+            <a:off x="548640" y="749808"/>
+            <a:ext cx="11155680" cy="914400"/>
+          </a:xfrm>
+          <a:prstGeom prst="rect">
+            <a:avLst/>
+          </a:prstGeom>
+          <a:noFill/>
+          <a:ln/>
+        </p:spPr>
+        <p:txBody>
+          <a:bodyPr wrap="square" rtlCol="0" anchor="ctr"/>
+          <a:lstStyle/>
+          <a:p>
+            <a:pPr indent="0" marL="0">
+              <a:buNone/>
+            </a:pPr>
+            <a:r>
+              <a:rPr lang="en-US" sz="2900" b="1" dirty="0">
+                <a:solidFill>
+                  <a:srgbClr val="17313F"/>
+                </a:solidFill>
+                <a:latin typeface="Calibri" pitchFamily="34" charset="0"/>
+                <a:ea typeface="Calibri" pitchFamily="34" charset="-122"/>
+                <a:cs typeface="Calibri" pitchFamily="34" charset="-120"/>
+              </a:rPr>
+              <a:t>Surface the high-value alerts, and keep getting sharper</a:t>
+            </a:r>
+            <a:endParaRPr lang="en-US" sz="2900" dirty="0"/>
           </a:p>
         </p:txBody>
       </p:sp>
@@ -6494,47 +6514,8 @@
         </p:nvSpPr>
         <p:spPr>
           <a:xfrm>
-            <a:off x="548640" y="1051560"/>
-            <a:ext cx="11155680" cy="914400"/>
-          </a:xfrm>
-          <a:prstGeom prst="rect">
-            <a:avLst/>
-          </a:prstGeom>
-          <a:noFill/>
-          <a:ln/>
-        </p:spPr>
-        <p:txBody>
-          <a:bodyPr wrap="square" rtlCol="0" anchor="ctr"/>
-          <a:lstStyle/>
-          <a:p>
-            <a:pPr indent="0" marL="0">
-              <a:buNone/>
-            </a:pPr>
-            <a:r>
-              <a:rPr lang="en-US" sz="2900" b="1" dirty="0">
-                <a:solidFill>
-                  <a:srgbClr val="FFFFFF"/>
-                </a:solidFill>
-                <a:latin typeface="Calibri" pitchFamily="34" charset="0"/>
-                <a:ea typeface="Calibri" pitchFamily="34" charset="-122"/>
-                <a:cs typeface="Calibri" pitchFamily="34" charset="-120"/>
-              </a:rPr>
-              <a:t>Surface the high-value alerts, and keep getting sharper</a:t>
-            </a:r>
-            <a:endParaRPr lang="en-US" sz="2900" dirty="0"/>
-          </a:p>
-        </p:txBody>
-      </p:sp>
-      <p:sp>
-        <p:nvSpPr>
-          <p:cNvPr id="6" name="Text 4"/>
-          <p:cNvSpPr/>
-          <p:nvPr/>
-        </p:nvSpPr>
-        <p:spPr>
-          <a:xfrm>
-            <a:off x="566928" y="2286000"/>
-            <a:ext cx="10698480" cy="1280160"/>
+            <a:off x="566928" y="2011680"/>
+            <a:ext cx="10881360" cy="1280160"/>
           </a:xfrm>
           <a:prstGeom prst="rect">
             <a:avLst/>
@@ -6555,7 +6536,7 @@
             <a:r>
               <a:rPr lang="en-US" sz="1500" dirty="0">
                 <a:solidFill>
-                  <a:srgbClr val="DDEBEF"/>
+                  <a:srgbClr val="17313F"/>
                 </a:solidFill>
                 <a:latin typeface="Calibri" pitchFamily="34" charset="0"/>
                 <a:ea typeface="Calibri" pitchFamily="34" charset="-122"/>
@@ -6569,13 +6550,13 @@
       </p:sp>
       <p:sp>
         <p:nvSpPr>
-          <p:cNvPr id="7" name="Text 5"/>
-          <p:cNvSpPr/>
-          <p:nvPr/>
-        </p:nvSpPr>
-        <p:spPr>
-          <a:xfrm>
-            <a:off x="548640" y="3657600"/>
+          <p:cNvPr id="6" name="Text 4"/>
+          <p:cNvSpPr/>
+          <p:nvPr/>
+        </p:nvSpPr>
+        <p:spPr>
+          <a:xfrm>
+            <a:off x="548640" y="3566160"/>
             <a:ext cx="8229600" cy="320040"/>
           </a:xfrm>
           <a:prstGeom prst="rect">
@@ -6594,7 +6575,7 @@
             <a:r>
               <a:rPr lang="en-US" sz="1300" b="1" spc="100" kern="0" dirty="0">
                 <a:solidFill>
-                  <a:srgbClr val="37B7AD"/>
+                  <a:srgbClr val="1BA39C"/>
                 </a:solidFill>
                 <a:latin typeface="Calibri" pitchFamily="34" charset="0"/>
                 <a:ea typeface="Calibri" pitchFamily="34" charset="-122"/>
@@ -6608,7 +6589,7 @@
       </p:sp>
       <p:pic>
         <p:nvPicPr>
-          <p:cNvPr id="8" name="Image 0" descr="preencoded.png">    </p:cNvPr>
+          <p:cNvPr id="7" name="Image 0" descr="preencoded.png">    </p:cNvPr>
           <p:cNvPicPr>
             <a:picLocks noChangeAspect="1"/>
           </p:cNvPicPr>
@@ -6622,7 +6603,7 @@
         </p:blipFill>
         <p:spPr>
           <a:xfrm>
-            <a:off x="548640" y="4041648"/>
+            <a:off x="548640" y="3995928"/>
             <a:ext cx="274320" cy="274320"/>
           </a:xfrm>
           <a:prstGeom prst="rect">
@@ -6632,13 +6613,13 @@
       </p:pic>
       <p:sp>
         <p:nvSpPr>
-          <p:cNvPr id="9" name="Text 6"/>
-          <p:cNvSpPr/>
-          <p:nvPr/>
-        </p:nvSpPr>
-        <p:spPr>
-          <a:xfrm>
-            <a:off x="932688" y="3977640"/>
+          <p:cNvPr id="8" name="Text 5"/>
+          <p:cNvSpPr/>
+          <p:nvPr/>
+        </p:nvSpPr>
+        <p:spPr>
+          <a:xfrm>
+            <a:off x="932688" y="3931920"/>
             <a:ext cx="5212080" cy="411480"/>
           </a:xfrm>
           <a:prstGeom prst="rect">
@@ -6657,7 +6638,7 @@
             <a:r>
               <a:rPr lang="en-US" sz="1250" dirty="0">
                 <a:solidFill>
-                  <a:srgbClr val="DDEBEF"/>
+                  <a:srgbClr val="17313F"/>
                 </a:solidFill>
                 <a:latin typeface="Calibri" pitchFamily="34" charset="0"/>
                 <a:ea typeface="Calibri" pitchFamily="34" charset="-122"/>
@@ -6671,7 +6652,7 @@
       </p:sp>
       <p:pic>
         <p:nvPicPr>
-          <p:cNvPr id="10" name="Image 1" descr="preencoded.png">    </p:cNvPr>
+          <p:cNvPr id="9" name="Image 1" descr="preencoded.png">    </p:cNvPr>
           <p:cNvPicPr>
             <a:picLocks noChangeAspect="1"/>
           </p:cNvPicPr>
@@ -6685,7 +6666,7 @@
         </p:blipFill>
         <p:spPr>
           <a:xfrm>
-            <a:off x="6172200" y="4041648"/>
+            <a:off x="6172200" y="3995928"/>
             <a:ext cx="274320" cy="274320"/>
           </a:xfrm>
           <a:prstGeom prst="rect">
@@ -6695,13 +6676,13 @@
       </p:pic>
       <p:sp>
         <p:nvSpPr>
-          <p:cNvPr id="11" name="Text 7"/>
-          <p:cNvSpPr/>
-          <p:nvPr/>
-        </p:nvSpPr>
-        <p:spPr>
-          <a:xfrm>
-            <a:off x="6556248" y="3977640"/>
+          <p:cNvPr id="10" name="Text 6"/>
+          <p:cNvSpPr/>
+          <p:nvPr/>
+        </p:nvSpPr>
+        <p:spPr>
+          <a:xfrm>
+            <a:off x="6556248" y="3931920"/>
             <a:ext cx="5212080" cy="411480"/>
           </a:xfrm>
           <a:prstGeom prst="rect">
@@ -6720,7 +6701,7 @@
             <a:r>
               <a:rPr lang="en-US" sz="1250" dirty="0">
                 <a:solidFill>
-                  <a:srgbClr val="DDEBEF"/>
+                  <a:srgbClr val="17313F"/>
                 </a:solidFill>
                 <a:latin typeface="Calibri" pitchFamily="34" charset="0"/>
                 <a:ea typeface="Calibri" pitchFamily="34" charset="-122"/>
@@ -6734,7 +6715,7 @@
       </p:sp>
       <p:pic>
         <p:nvPicPr>
-          <p:cNvPr id="12" name="Image 2" descr="preencoded.png">    </p:cNvPr>
+          <p:cNvPr id="11" name="Image 2" descr="preencoded.png">    </p:cNvPr>
           <p:cNvPicPr>
             <a:picLocks noChangeAspect="1"/>
           </p:cNvPicPr>
@@ -6748,7 +6729,7 @@
         </p:blipFill>
         <p:spPr>
           <a:xfrm>
-            <a:off x="548640" y="4608576"/>
+            <a:off x="548640" y="4599432"/>
             <a:ext cx="274320" cy="274320"/>
           </a:xfrm>
           <a:prstGeom prst="rect">
@@ -6758,13 +6739,13 @@
       </p:pic>
       <p:sp>
         <p:nvSpPr>
-          <p:cNvPr id="13" name="Text 8"/>
-          <p:cNvSpPr/>
-          <p:nvPr/>
-        </p:nvSpPr>
-        <p:spPr>
-          <a:xfrm>
-            <a:off x="932688" y="4544568"/>
+          <p:cNvPr id="12" name="Text 7"/>
+          <p:cNvSpPr/>
+          <p:nvPr/>
+        </p:nvSpPr>
+        <p:spPr>
+          <a:xfrm>
+            <a:off x="932688" y="4535424"/>
             <a:ext cx="5212080" cy="411480"/>
           </a:xfrm>
           <a:prstGeom prst="rect">
@@ -6783,7 +6764,7 @@
             <a:r>
               <a:rPr lang="en-US" sz="1250" dirty="0">
                 <a:solidFill>
-                  <a:srgbClr val="DDEBEF"/>
+                  <a:srgbClr val="17313F"/>
                 </a:solidFill>
                 <a:latin typeface="Calibri" pitchFamily="34" charset="0"/>
                 <a:ea typeface="Calibri" pitchFamily="34" charset="-122"/>
@@ -6797,7 +6778,7 @@
       </p:sp>
       <p:pic>
         <p:nvPicPr>
-          <p:cNvPr id="14" name="Image 3" descr="preencoded.png">    </p:cNvPr>
+          <p:cNvPr id="13" name="Image 3" descr="preencoded.png">    </p:cNvPr>
           <p:cNvPicPr>
             <a:picLocks noChangeAspect="1"/>
           </p:cNvPicPr>
@@ -6811,7 +6792,7 @@
         </p:blipFill>
         <p:spPr>
           <a:xfrm>
-            <a:off x="6172200" y="4608576"/>
+            <a:off x="6172200" y="4599432"/>
             <a:ext cx="274320" cy="274320"/>
           </a:xfrm>
           <a:prstGeom prst="rect">
@@ -6821,13 +6802,13 @@
       </p:pic>
       <p:sp>
         <p:nvSpPr>
-          <p:cNvPr id="15" name="Text 9"/>
-          <p:cNvSpPr/>
-          <p:nvPr/>
-        </p:nvSpPr>
-        <p:spPr>
-          <a:xfrm>
-            <a:off x="6556248" y="4544568"/>
+          <p:cNvPr id="14" name="Text 8"/>
+          <p:cNvSpPr/>
+          <p:nvPr/>
+        </p:nvSpPr>
+        <p:spPr>
+          <a:xfrm>
+            <a:off x="6556248" y="4535424"/>
             <a:ext cx="5212080" cy="411480"/>
           </a:xfrm>
           <a:prstGeom prst="rect">
@@ -6846,7 +6827,7 @@
             <a:r>
               <a:rPr lang="en-US" sz="1250" dirty="0">
                 <a:solidFill>
-                  <a:srgbClr val="DDEBEF"/>
+                  <a:srgbClr val="17313F"/>
                 </a:solidFill>
                 <a:latin typeface="Calibri" pitchFamily="34" charset="0"/>
                 <a:ea typeface="Calibri" pitchFamily="34" charset="-122"/>
@@ -6860,38 +6841,79 @@
       </p:sp>
       <p:sp>
         <p:nvSpPr>
+          <p:cNvPr id="15" name="Shape 9"/>
+          <p:cNvSpPr/>
+          <p:nvPr/>
+        </p:nvSpPr>
+        <p:spPr>
+          <a:xfrm>
+            <a:off x="548640" y="5440680"/>
+            <a:ext cx="11091672" cy="566928"/>
+          </a:xfrm>
+          <a:prstGeom prst="roundRect">
+            <a:avLst>
+              <a:gd name="adj" fmla="val 16129"/>
+            </a:avLst>
+          </a:prstGeom>
+          <a:solidFill>
+            <a:srgbClr val="F4FAFB"/>
+          </a:solidFill>
+          <a:ln w="12700">
+            <a:solidFill>
+              <a:srgbClr val="DCE8EE"/>
+            </a:solidFill>
+            <a:prstDash val="solid"/>
+          </a:ln>
+        </p:spPr>
+      </p:sp>
+      <p:sp>
+        <p:nvSpPr>
           <p:cNvPr id="16" name="Text 10"/>
           <p:cNvSpPr/>
           <p:nvPr/>
         </p:nvSpPr>
         <p:spPr>
           <a:xfrm>
-            <a:off x="548640" y="5486400"/>
-            <a:ext cx="11155680" cy="365760"/>
-          </a:xfrm>
-          <a:prstGeom prst="rect">
-            <a:avLst/>
-          </a:prstGeom>
-          <a:noFill/>
-          <a:ln/>
-        </p:spPr>
-        <p:txBody>
-          <a:bodyPr wrap="square" rtlCol="0" anchor="ctr"/>
-          <a:lstStyle/>
-          <a:p>
+            <a:off x="777240" y="5440680"/>
+            <a:ext cx="10698480" cy="566928"/>
+          </a:xfrm>
+          <a:prstGeom prst="rect">
+            <a:avLst/>
+          </a:prstGeom>
+          <a:noFill/>
+          <a:ln/>
+        </p:spPr>
+        <p:txBody>
+          <a:bodyPr wrap="square" rtlCol="0" anchor="ctr"/>
+          <a:lstStyle/>
+          <a:p>
+            <a:pPr indent="0" marL="0">
+              <a:buNone/>
+            </a:pPr>
+            <a:r>
+              <a:rPr lang="en-US" sz="1200" b="1" dirty="0">
+                <a:solidFill>
+                  <a:srgbClr val="1BA39C"/>
+                </a:solidFill>
+                <a:latin typeface="Calibri" pitchFamily="34" charset="0"/>
+                <a:ea typeface="Calibri" pitchFamily="34" charset="-122"/>
+                <a:cs typeface="Calibri" pitchFamily="34" charset="-120"/>
+              </a:rPr>
+              <a:t>Next: </a:t>
+            </a:r>
             <a:pPr indent="0" marL="0">
               <a:buNone/>
             </a:pPr>
             <a:r>
               <a:rPr lang="en-US" sz="1200" dirty="0">
                 <a:solidFill>
-                  <a:srgbClr val="8FB2BD"/>
-                </a:solidFill>
-                <a:latin typeface="Calibri" pitchFamily="34" charset="0"/>
-                <a:ea typeface="Calibri" pitchFamily="34" charset="-122"/>
-                <a:cs typeface="Calibri" pitchFamily="34" charset="-120"/>
-              </a:rPr>
-              <a:t>Next: real data sources (Qichacha / Tianyancha / Dow Jones) · deploy the Hermes Agent framework · integrate the payment system</a:t>
+                  <a:srgbClr val="17313F"/>
+                </a:solidFill>
+                <a:latin typeface="Calibri" pitchFamily="34" charset="0"/>
+                <a:ea typeface="Calibri" pitchFamily="34" charset="-122"/>
+                <a:cs typeface="Calibri" pitchFamily="34" charset="-120"/>
+              </a:rPr>
+              <a:t>real data sources (Qichacha / Tianyancha / Dow Jones) · deploy the Hermes Agent framework · integrate the payment system</a:t>
             </a:r>
             <a:endParaRPr lang="en-US" sz="1200" dirty="0"/>
           </a:p>
@@ -6905,7 +6927,7 @@
         </p:nvSpPr>
         <p:spPr>
           <a:xfrm>
-            <a:off x="548640" y="6355080"/>
+            <a:off x="548640" y="6263640"/>
             <a:ext cx="10972800" cy="320040"/>
           </a:xfrm>
           <a:prstGeom prst="rect">
@@ -6924,7 +6946,7 @@
             <a:r>
               <a:rPr lang="en-US" sz="1000" i="1" dirty="0">
                 <a:solidFill>
-                  <a:srgbClr val="6E92A0"/>
+                  <a:srgbClr val="71838F"/>
                 </a:solidFill>
                 <a:latin typeface="Calibri" pitchFamily="34" charset="0"/>
                 <a:ea typeface="Calibri" pitchFamily="34" charset="-122"/>

</xml_diff>

<commit_message>
Add end-to-end flow diagram slide (EN deck)
New slide 5: a 5-stage horizontal flow — Payments In → Detect + Tier
→ Investigate → Confirm → Evolve — with a continuous-feedback loop bar
(confirmations recalibrate tiering and promote validated new signals,
gated by calibration + approval). Subsequent slides renumbered (8 total).

Co-Authored-By: Claude Opus 4.8 (1M context) <noreply@anthropic.com>
</commit_message>
<xml_diff>
--- a/ppt/AML-System-Walkthrough-Legal-EN.pptx
+++ b/ppt/AML-System-Walkthrough-Legal-EN.pptx
@@ -12,9 +12,10 @@
     <p:sldId id="260" r:id="rId6"/>
     <p:sldId id="261" r:id="rId7"/>
     <p:sldId id="262" r:id="rId8"/>
+    <p:sldId id="263" r:id="rId9"/>
   </p:sldIdLst>
   <p:notesMasterIdLst>
-    <p:notesMasterId r:id="rId9"/>
+    <p:notesMasterId r:id="rId10"/>
   </p:notesMasterIdLst>
   <p:sldSz cx="12191695" cy="6858000"/>
   <p:notesSz cx="6858000" cy="12191695"/>
@@ -1060,6 +1061,94 @@
             <a:fld id="{F7021451-1387-4CA6-816F-3879F97B5CBC}" type="slidenum">
               <a:rPr lang="en-US"/>
               <a:t>7</a:t>
+            </a:fld>
+            <a:endParaRPr lang="en-US"/>
+          </a:p>
+        </p:txBody>
+      </p:sp>
+    </p:spTree>
+    <p:extLst>
+      <p:ext uri="{BB962C8B-B14F-4D97-AF65-F5344CB8AC3E}">
+        <p14:creationId xmlns:p14="http://schemas.microsoft.com/office/powerpoint/2010/main" val="1024086991"/>
+      </p:ext>
+    </p:extLst>
+  </p:cSld>
+  <p:clrMapOvr>
+    <a:masterClrMapping/>
+  </p:clrMapOvr>
+</p:notes>
+</file>
+
+<file path=ppt/notesSlides/notesSlide8.xml><?xml version="1.0" encoding="utf-8"?>
+<p:notes xmlns:a="http://schemas.openxmlformats.org/drawingml/2006/main" xmlns:r="http://schemas.openxmlformats.org/officeDocument/2006/relationships" xmlns:p="http://schemas.openxmlformats.org/presentationml/2006/main">
+  <p:cSld>
+    <p:spTree>
+      <p:nvGrpSpPr>
+        <p:cNvPr id="1" name=""/>
+        <p:cNvGrpSpPr/>
+        <p:nvPr/>
+      </p:nvGrpSpPr>
+      <p:grpSpPr>
+        <a:xfrm>
+          <a:off x="0" y="0"/>
+          <a:ext cx="0" cy="0"/>
+          <a:chOff x="0" y="0"/>
+          <a:chExt cx="0" cy="0"/>
+        </a:xfrm>
+      </p:grpSpPr>
+      <p:sp>
+        <p:nvSpPr>
+          <p:cNvPr id="2" name="Slide Image Placeholder 1"/>
+          <p:cNvSpPr>
+            <a:spLocks noGrp="1" noRot="1" noChangeAspect="1"/>
+          </p:cNvSpPr>
+          <p:nvPr>
+            <p:ph type="sldImg"/>
+          </p:nvPr>
+        </p:nvSpPr>
+        <p:spPr/>
+      </p:sp>
+      <p:sp>
+        <p:nvSpPr>
+          <p:cNvPr id="3" name="Notes Placeholder 2"/>
+          <p:cNvSpPr>
+            <a:spLocks noGrp="1"/>
+          </p:cNvSpPr>
+          <p:nvPr>
+            <p:ph type="body" idx="1"/>
+          </p:nvPr>
+        </p:nvSpPr>
+        <p:spPr/>
+        <p:txBody>
+          <a:bodyPr/>
+          <a:lstStyle/>
+          <a:p>
+            <a:r>
+              <a:rPr lang="en-US" dirty="0"/>
+              <a:t/>
+            </a:r>
+            <a:endParaRPr lang="en-US" dirty="0"/>
+          </a:p>
+        </p:txBody>
+      </p:sp>
+      <p:sp>
+        <p:nvSpPr>
+          <p:cNvPr id="4" name="Slide Number Placeholder 3"/>
+          <p:cNvSpPr>
+            <a:spLocks noGrp="1"/>
+          </p:cNvSpPr>
+          <p:nvPr>
+            <p:ph type="sldNum" sz="quarter" idx="10"/>
+          </p:nvPr>
+        </p:nvSpPr>
+        <p:spPr/>
+        <p:txBody>
+          <a:bodyPr/>
+          <a:lstStyle/>
+          <a:p>
+            <a:fld id="{F7021451-1387-4CA6-816F-3879F97B5CBC}" type="slidenum">
+              <a:rPr lang="en-US"/>
+              <a:t>8</a:t>
             </a:fld>
             <a:endParaRPr lang="en-US"/>
           </a:p>
@@ -4619,7 +4708,7 @@
                 <a:ea typeface="Calibri" pitchFamily="34" charset="-122"/>
                 <a:cs typeface="Calibri" pitchFamily="34" charset="-120"/>
               </a:rPr>
-              <a:t>THREE CORE INNOVATIONS</a:t>
+              <a:t>END-TO-END FLOW</a:t>
             </a:r>
             <a:endParaRPr lang="en-US" sz="1200" dirty="0"/>
           </a:p>
@@ -4658,7 +4747,7 @@
                 <a:ea typeface="Calibri" pitchFamily="34" charset="-122"/>
                 <a:cs typeface="Calibri" pitchFamily="34" charset="-120"/>
               </a:rPr>
-              <a:t>From static rules to an evolving assistant</a:t>
+              <a:t>How a payment flows through the system</a:t>
             </a:r>
             <a:endParaRPr lang="en-US" sz="3000" dirty="0"/>
           </a:p>
@@ -4672,12 +4761,12 @@
         </p:nvSpPr>
         <p:spPr>
           <a:xfrm>
-            <a:off x="548640" y="2148840"/>
-            <a:ext cx="3474720" cy="3383280"/>
+            <a:off x="548640" y="2286000"/>
+            <a:ext cx="1965960" cy="2331720"/>
           </a:xfrm>
           <a:prstGeom prst="roundRect">
             <a:avLst>
-              <a:gd name="adj" fmla="val 3784"/>
+              <a:gd name="adj" fmla="val 5581"/>
             </a:avLst>
           </a:prstGeom>
           <a:solidFill>
@@ -4706,8 +4795,8 @@
         </p:nvSpPr>
         <p:spPr>
           <a:xfrm>
-            <a:off x="868680" y="2468880"/>
-            <a:ext cx="868680" cy="868680"/>
+            <a:off x="1143000" y="2542032"/>
+            <a:ext cx="777240" cy="777240"/>
           </a:xfrm>
           <a:prstGeom prst="ellipse">
             <a:avLst/>
@@ -4734,8 +4823,8 @@
         </p:blipFill>
         <p:spPr>
           <a:xfrm>
-            <a:off x="1069848" y="2670048"/>
-            <a:ext cx="466344" cy="466344"/>
+            <a:off x="1335024" y="2734056"/>
+            <a:ext cx="393192" cy="393192"/>
           </a:xfrm>
           <a:prstGeom prst="rect">
             <a:avLst/>
@@ -4750,34 +4839,34 @@
         </p:nvSpPr>
         <p:spPr>
           <a:xfrm>
-            <a:off x="2834640" y="2423160"/>
-            <a:ext cx="1005840" cy="640080"/>
-          </a:xfrm>
-          <a:prstGeom prst="rect">
-            <a:avLst/>
-          </a:prstGeom>
-          <a:noFill/>
-          <a:ln/>
-        </p:spPr>
-        <p:txBody>
-          <a:bodyPr wrap="square" rtlCol="0" anchor="ctr"/>
-          <a:lstStyle/>
-          <a:p>
-            <a:pPr algn="r" indent="0" marL="0">
-              <a:buNone/>
-            </a:pPr>
-            <a:r>
-              <a:rPr lang="en-US" sz="3400" b="1" dirty="0">
-                <a:solidFill>
-                  <a:srgbClr val="CFE0E6"/>
-                </a:solidFill>
-                <a:latin typeface="Calibri" pitchFamily="34" charset="0"/>
-                <a:ea typeface="Calibri" pitchFamily="34" charset="-122"/>
-                <a:cs typeface="Calibri" pitchFamily="34" charset="-120"/>
-              </a:rPr>
-              <a:t>01</a:t>
-            </a:r>
-            <a:endParaRPr lang="en-US" sz="3400" dirty="0"/>
+            <a:off x="640080" y="3456432"/>
+            <a:ext cx="1783080" cy="365760"/>
+          </a:xfrm>
+          <a:prstGeom prst="rect">
+            <a:avLst/>
+          </a:prstGeom>
+          <a:noFill/>
+          <a:ln/>
+        </p:spPr>
+        <p:txBody>
+          <a:bodyPr wrap="square" rtlCol="0" anchor="ctr"/>
+          <a:lstStyle/>
+          <a:p>
+            <a:pPr algn="ctr" indent="0" marL="0">
+              <a:buNone/>
+            </a:pPr>
+            <a:r>
+              <a:rPr lang="en-US" sz="1400" b="1" dirty="0">
+                <a:solidFill>
+                  <a:srgbClr val="17313F"/>
+                </a:solidFill>
+                <a:latin typeface="Calibri" pitchFamily="34" charset="0"/>
+                <a:ea typeface="Calibri" pitchFamily="34" charset="-122"/>
+                <a:cs typeface="Calibri" pitchFamily="34" charset="-120"/>
+              </a:rPr>
+              <a:t>1. Payments In</a:t>
+            </a:r>
+            <a:endParaRPr lang="en-US" sz="1400" dirty="0"/>
           </a:p>
         </p:txBody>
       </p:sp>
@@ -4789,69 +4878,47 @@
         </p:nvSpPr>
         <p:spPr>
           <a:xfrm>
-            <a:off x="868680" y="3520440"/>
-            <a:ext cx="2971800" cy="777240"/>
-          </a:xfrm>
-          <a:prstGeom prst="rect">
-            <a:avLst/>
-          </a:prstGeom>
-          <a:noFill/>
-          <a:ln/>
-        </p:spPr>
-        <p:txBody>
-          <a:bodyPr wrap="square" rtlCol="0" anchor="ctr"/>
-          <a:lstStyle/>
-          <a:p>
-            <a:pPr indent="0" marL="0">
+            <a:off x="640080" y="3858768"/>
+            <a:ext cx="1783080" cy="640080"/>
+          </a:xfrm>
+          <a:prstGeom prst="rect">
+            <a:avLst/>
+          </a:prstGeom>
+          <a:noFill/>
+          <a:ln/>
+        </p:spPr>
+        <p:txBody>
+          <a:bodyPr wrap="square" rtlCol="0" anchor="ctr"/>
+          <a:lstStyle/>
+          <a:p>
+            <a:pPr algn="ctr" indent="0" marL="0">
               <a:lnSpc>
-                <a:spcPct val="100000"/>
+                <a:spcPct val="105000"/>
               </a:lnSpc>
               <a:buNone/>
             </a:pPr>
             <a:r>
-              <a:rPr lang="en-US" sz="1700" b="1" dirty="0">
-                <a:solidFill>
-                  <a:srgbClr val="17313F"/>
-                </a:solidFill>
-                <a:latin typeface="Calibri" pitchFamily="34" charset="0"/>
-                <a:ea typeface="Calibri" pitchFamily="34" charset="-122"/>
-                <a:cs typeface="Calibri" pitchFamily="34" charset="-120"/>
-              </a:rPr>
-              <a:t>AI Investigation Agent</a:t>
-            </a:r>
-            <a:endParaRPr lang="en-US" sz="1700" dirty="0"/>
-          </a:p>
-        </p:txBody>
-      </p:sp>
-      <p:sp>
-        <p:nvSpPr>
-          <p:cNvPr id="9" name="Text 6"/>
-          <p:cNvSpPr/>
-          <p:nvPr/>
-        </p:nvSpPr>
-        <p:spPr>
-          <a:xfrm>
-            <a:off x="886968" y="4297680"/>
-            <a:ext cx="2971800" cy="1188720"/>
-          </a:xfrm>
-          <a:prstGeom prst="rect">
-            <a:avLst/>
-          </a:prstGeom>
-          <a:noFill/>
-          <a:ln/>
-        </p:spPr>
-        <p:txBody>
-          <a:bodyPr wrap="square" rtlCol="0" anchor="ctr"/>
-          <a:lstStyle/>
-          <a:p>
-            <a:pPr indent="0" marL="0">
+              <a:rPr lang="en-US" sz="1050" dirty="0">
+                <a:solidFill>
+                  <a:srgbClr val="71838F"/>
+                </a:solidFill>
+                <a:latin typeface="Calibri" pitchFamily="34" charset="0"/>
+                <a:ea typeface="Calibri" pitchFamily="34" charset="-122"/>
+                <a:cs typeface="Calibri" pitchFamily="34" charset="-120"/>
+              </a:rPr>
+              <a:t>~10K/day</a:t>
+            </a:r>
+            <a:endParaRPr lang="en-US" sz="1050" dirty="0"/>
+          </a:p>
+          <a:p>
+            <a:pPr algn="ctr" indent="0" marL="0">
               <a:lnSpc>
-                <a:spcPct val="122000"/>
+                <a:spcPct val="105000"/>
               </a:lnSpc>
               <a:buNone/>
             </a:pPr>
             <a:r>
-              <a:rPr lang="en-US" sz="1250" dirty="0">
+              <a:rPr lang="en-US" sz="1050" dirty="0">
                 <a:solidFill>
                   <a:srgbClr val="71838F"/>
                 </a:solidFill>
@@ -4859,26 +4926,50 @@
                 <a:ea typeface="Calibri" pitchFamily="34" charset="-122"/>
                 <a:cs typeface="Calibri" pitchFamily="34" charset="-120"/>
               </a:rPr>
-              <a:t>Auto multi-source evidence (Qichacha / Tianyancha / Dow Jones) cuts each case from an hour to minutes; humans make the final call.</a:t>
-            </a:r>
-            <a:endParaRPr lang="en-US" sz="1250" dirty="0"/>
-          </a:p>
-        </p:txBody>
-      </p:sp>
-      <p:sp>
-        <p:nvSpPr>
-          <p:cNvPr id="10" name="Shape 7"/>
-          <p:cNvSpPr/>
-          <p:nvPr/>
-        </p:nvSpPr>
-        <p:spPr>
-          <a:xfrm>
-            <a:off x="4315968" y="2148840"/>
-            <a:ext cx="3474720" cy="3383280"/>
+              <a:t>Ariba · LGAP · S4</a:t>
+            </a:r>
+            <a:endParaRPr lang="en-US" sz="1050" dirty="0"/>
+          </a:p>
+        </p:txBody>
+      </p:sp>
+      <p:pic>
+        <p:nvPicPr>
+          <p:cNvPr id="9" name="Image 1" descr="preencoded.png">    </p:cNvPr>
+          <p:cNvPicPr>
+            <a:picLocks noChangeAspect="1"/>
+          </p:cNvPicPr>
+          <p:nvPr/>
+        </p:nvPicPr>
+        <p:blipFill>
+          <a:blip r:embed="rId2"/>
+          <a:stretch>
+            <a:fillRect/>
+          </a:stretch>
+        </p:blipFill>
+        <p:spPr>
+          <a:xfrm>
+            <a:off x="2551176" y="3323844"/>
+            <a:ext cx="256032" cy="256032"/>
+          </a:xfrm>
+          <a:prstGeom prst="rect">
+            <a:avLst/>
+          </a:prstGeom>
+        </p:spPr>
+      </p:pic>
+      <p:sp>
+        <p:nvSpPr>
+          <p:cNvPr id="10" name="Shape 6"/>
+          <p:cNvSpPr/>
+          <p:nvPr/>
+        </p:nvSpPr>
+        <p:spPr>
+          <a:xfrm>
+            <a:off x="2830068" y="2286000"/>
+            <a:ext cx="1965960" cy="2331720"/>
           </a:xfrm>
           <a:prstGeom prst="roundRect">
             <a:avLst>
-              <a:gd name="adj" fmla="val 3784"/>
+              <a:gd name="adj" fmla="val 5581"/>
             </a:avLst>
           </a:prstGeom>
           <a:solidFill>
@@ -4901,14 +4992,14 @@
       </p:sp>
       <p:sp>
         <p:nvSpPr>
-          <p:cNvPr id="11" name="Shape 8"/>
-          <p:cNvSpPr/>
-          <p:nvPr/>
-        </p:nvSpPr>
-        <p:spPr>
-          <a:xfrm>
-            <a:off x="4636008" y="2468880"/>
-            <a:ext cx="868680" cy="868680"/>
+          <p:cNvPr id="11" name="Shape 7"/>
+          <p:cNvSpPr/>
+          <p:nvPr/>
+        </p:nvSpPr>
+        <p:spPr>
+          <a:xfrm>
+            <a:off x="3424428" y="2542032"/>
+            <a:ext cx="777240" cy="777240"/>
           </a:xfrm>
           <a:prstGeom prst="ellipse">
             <a:avLst/>
@@ -4921,22 +5012,22 @@
       </p:sp>
       <p:pic>
         <p:nvPicPr>
-          <p:cNvPr id="12" name="Image 1" descr="preencoded.png">    </p:cNvPr>
+          <p:cNvPr id="12" name="Image 2" descr="preencoded.png">    </p:cNvPr>
           <p:cNvPicPr>
             <a:picLocks noChangeAspect="1"/>
           </p:cNvPicPr>
           <p:nvPr/>
         </p:nvPicPr>
         <p:blipFill>
-          <a:blip r:embed="rId2"/>
+          <a:blip r:embed="rId3"/>
           <a:stretch>
             <a:fillRect/>
           </a:stretch>
         </p:blipFill>
         <p:spPr>
           <a:xfrm>
-            <a:off x="4837176" y="2670048"/>
-            <a:ext cx="466344" cy="466344"/>
+            <a:off x="3616452" y="2734056"/>
+            <a:ext cx="393192" cy="393192"/>
           </a:xfrm>
           <a:prstGeom prst="rect">
             <a:avLst/>
@@ -4945,114 +5036,92 @@
       </p:pic>
       <p:sp>
         <p:nvSpPr>
-          <p:cNvPr id="13" name="Text 9"/>
-          <p:cNvSpPr/>
-          <p:nvPr/>
-        </p:nvSpPr>
-        <p:spPr>
-          <a:xfrm>
-            <a:off x="6601968" y="2423160"/>
-            <a:ext cx="1005840" cy="640080"/>
-          </a:xfrm>
-          <a:prstGeom prst="rect">
-            <a:avLst/>
-          </a:prstGeom>
-          <a:noFill/>
-          <a:ln/>
-        </p:spPr>
-        <p:txBody>
-          <a:bodyPr wrap="square" rtlCol="0" anchor="ctr"/>
-          <a:lstStyle/>
-          <a:p>
-            <a:pPr algn="r" indent="0" marL="0">
-              <a:buNone/>
-            </a:pPr>
-            <a:r>
-              <a:rPr lang="en-US" sz="3400" b="1" dirty="0">
-                <a:solidFill>
-                  <a:srgbClr val="CFE0E6"/>
-                </a:solidFill>
-                <a:latin typeface="Calibri" pitchFamily="34" charset="0"/>
-                <a:ea typeface="Calibri" pitchFamily="34" charset="-122"/>
-                <a:cs typeface="Calibri" pitchFamily="34" charset="-120"/>
-              </a:rPr>
-              <a:t>02</a:t>
-            </a:r>
-            <a:endParaRPr lang="en-US" sz="3400" dirty="0"/>
-          </a:p>
-        </p:txBody>
-      </p:sp>
-      <p:sp>
-        <p:nvSpPr>
-          <p:cNvPr id="14" name="Text 10"/>
-          <p:cNvSpPr/>
-          <p:nvPr/>
-        </p:nvSpPr>
-        <p:spPr>
-          <a:xfrm>
-            <a:off x="4636008" y="3520440"/>
-            <a:ext cx="2971800" cy="777240"/>
-          </a:xfrm>
-          <a:prstGeom prst="rect">
-            <a:avLst/>
-          </a:prstGeom>
-          <a:noFill/>
-          <a:ln/>
-        </p:spPr>
-        <p:txBody>
-          <a:bodyPr wrap="square" rtlCol="0" anchor="ctr"/>
-          <a:lstStyle/>
-          <a:p>
-            <a:pPr indent="0" marL="0">
+          <p:cNvPr id="13" name="Text 8"/>
+          <p:cNvSpPr/>
+          <p:nvPr/>
+        </p:nvSpPr>
+        <p:spPr>
+          <a:xfrm>
+            <a:off x="2921508" y="3456432"/>
+            <a:ext cx="1783080" cy="365760"/>
+          </a:xfrm>
+          <a:prstGeom prst="rect">
+            <a:avLst/>
+          </a:prstGeom>
+          <a:noFill/>
+          <a:ln/>
+        </p:spPr>
+        <p:txBody>
+          <a:bodyPr wrap="square" rtlCol="0" anchor="ctr"/>
+          <a:lstStyle/>
+          <a:p>
+            <a:pPr algn="ctr" indent="0" marL="0">
+              <a:buNone/>
+            </a:pPr>
+            <a:r>
+              <a:rPr lang="en-US" sz="1400" b="1" dirty="0">
+                <a:solidFill>
+                  <a:srgbClr val="17313F"/>
+                </a:solidFill>
+                <a:latin typeface="Calibri" pitchFamily="34" charset="0"/>
+                <a:ea typeface="Calibri" pitchFamily="34" charset="-122"/>
+                <a:cs typeface="Calibri" pitchFamily="34" charset="-120"/>
+              </a:rPr>
+              <a:t>2. Detect + Tier</a:t>
+            </a:r>
+            <a:endParaRPr lang="en-US" sz="1400" dirty="0"/>
+          </a:p>
+        </p:txBody>
+      </p:sp>
+      <p:sp>
+        <p:nvSpPr>
+          <p:cNvPr id="14" name="Text 9"/>
+          <p:cNvSpPr/>
+          <p:nvPr/>
+        </p:nvSpPr>
+        <p:spPr>
+          <a:xfrm>
+            <a:off x="2921508" y="3858768"/>
+            <a:ext cx="1783080" cy="640080"/>
+          </a:xfrm>
+          <a:prstGeom prst="rect">
+            <a:avLst/>
+          </a:prstGeom>
+          <a:noFill/>
+          <a:ln/>
+        </p:spPr>
+        <p:txBody>
+          <a:bodyPr wrap="square" rtlCol="0" anchor="ctr"/>
+          <a:lstStyle/>
+          <a:p>
+            <a:pPr algn="ctr" indent="0" marL="0">
               <a:lnSpc>
-                <a:spcPct val="100000"/>
+                <a:spcPct val="105000"/>
               </a:lnSpc>
               <a:buNone/>
             </a:pPr>
             <a:r>
-              <a:rPr lang="en-US" sz="1700" b="1" dirty="0">
-                <a:solidFill>
-                  <a:srgbClr val="17313F"/>
-                </a:solidFill>
-                <a:latin typeface="Calibri" pitchFamily="34" charset="0"/>
-                <a:ea typeface="Calibri" pitchFamily="34" charset="-122"/>
-                <a:cs typeface="Calibri" pitchFamily="34" charset="-120"/>
-              </a:rPr>
-              <a:t>Self-Evolution</a:t>
-            </a:r>
-            <a:endParaRPr lang="en-US" sz="1700" dirty="0"/>
-          </a:p>
-        </p:txBody>
-      </p:sp>
-      <p:sp>
-        <p:nvSpPr>
-          <p:cNvPr id="15" name="Text 11"/>
-          <p:cNvSpPr/>
-          <p:nvPr/>
-        </p:nvSpPr>
-        <p:spPr>
-          <a:xfrm>
-            <a:off x="4654296" y="4297680"/>
-            <a:ext cx="2971800" cy="1188720"/>
-          </a:xfrm>
-          <a:prstGeom prst="rect">
-            <a:avLst/>
-          </a:prstGeom>
-          <a:noFill/>
-          <a:ln/>
-        </p:spPr>
-        <p:txBody>
-          <a:bodyPr wrap="square" rtlCol="0" anchor="ctr"/>
-          <a:lstStyle/>
-          <a:p>
-            <a:pPr indent="0" marL="0">
+              <a:rPr lang="en-US" sz="1050" dirty="0">
+                <a:solidFill>
+                  <a:srgbClr val="71838F"/>
+                </a:solidFill>
+                <a:latin typeface="Calibri" pitchFamily="34" charset="0"/>
+                <a:ea typeface="Calibri" pitchFamily="34" charset="-122"/>
+                <a:cs typeface="Calibri" pitchFamily="34" charset="-120"/>
+              </a:rPr>
+              <a:t>Dual entry →</a:t>
+            </a:r>
+            <a:endParaRPr lang="en-US" sz="1050" dirty="0"/>
+          </a:p>
+          <a:p>
+            <a:pPr algn="ctr" indent="0" marL="0">
               <a:lnSpc>
-                <a:spcPct val="122000"/>
+                <a:spcPct val="105000"/>
               </a:lnSpc>
               <a:buNone/>
             </a:pPr>
             <a:r>
-              <a:rPr lang="en-US" sz="1250" dirty="0">
+              <a:rPr lang="en-US" sz="1050" dirty="0">
                 <a:solidFill>
                   <a:srgbClr val="71838F"/>
                 </a:solidFill>
@@ -5060,26 +5129,50 @@
                 <a:ea typeface="Calibri" pitchFamily="34" charset="-122"/>
                 <a:cs typeface="Calibri" pitchFamily="34" charset="-120"/>
               </a:rPr>
-              <a:t>The agent discovers new signals not yet in the rule set — but they enter only as candidates, taking effect after calibration + approval.</a:t>
-            </a:r>
-            <a:endParaRPr lang="en-US" sz="1250" dirty="0"/>
-          </a:p>
-        </p:txBody>
-      </p:sp>
-      <p:sp>
-        <p:nvSpPr>
-          <p:cNvPr id="16" name="Shape 12"/>
-          <p:cNvSpPr/>
-          <p:nvPr/>
-        </p:nvSpPr>
-        <p:spPr>
-          <a:xfrm>
-            <a:off x="8083296" y="2148840"/>
-            <a:ext cx="3474720" cy="3383280"/>
+              <a:t>T1 / T2 / T3</a:t>
+            </a:r>
+            <a:endParaRPr lang="en-US" sz="1050" dirty="0"/>
+          </a:p>
+        </p:txBody>
+      </p:sp>
+      <p:pic>
+        <p:nvPicPr>
+          <p:cNvPr id="15" name="Image 3" descr="preencoded.png">    </p:cNvPr>
+          <p:cNvPicPr>
+            <a:picLocks noChangeAspect="1"/>
+          </p:cNvPicPr>
+          <p:nvPr/>
+        </p:nvPicPr>
+        <p:blipFill>
+          <a:blip r:embed="rId4"/>
+          <a:stretch>
+            <a:fillRect/>
+          </a:stretch>
+        </p:blipFill>
+        <p:spPr>
+          <a:xfrm>
+            <a:off x="4832604" y="3323844"/>
+            <a:ext cx="256032" cy="256032"/>
+          </a:xfrm>
+          <a:prstGeom prst="rect">
+            <a:avLst/>
+          </a:prstGeom>
+        </p:spPr>
+      </p:pic>
+      <p:sp>
+        <p:nvSpPr>
+          <p:cNvPr id="16" name="Shape 10"/>
+          <p:cNvSpPr/>
+          <p:nvPr/>
+        </p:nvSpPr>
+        <p:spPr>
+          <a:xfrm>
+            <a:off x="5111496" y="2286000"/>
+            <a:ext cx="1965960" cy="2331720"/>
           </a:xfrm>
           <a:prstGeom prst="roundRect">
             <a:avLst>
-              <a:gd name="adj" fmla="val 3784"/>
+              <a:gd name="adj" fmla="val 5581"/>
             </a:avLst>
           </a:prstGeom>
           <a:solidFill>
@@ -5102,14 +5195,14 @@
       </p:sp>
       <p:sp>
         <p:nvSpPr>
-          <p:cNvPr id="17" name="Shape 13"/>
-          <p:cNvSpPr/>
-          <p:nvPr/>
-        </p:nvSpPr>
-        <p:spPr>
-          <a:xfrm>
-            <a:off x="8403336" y="2468880"/>
-            <a:ext cx="868680" cy="868680"/>
+          <p:cNvPr id="17" name="Shape 11"/>
+          <p:cNvSpPr/>
+          <p:nvPr/>
+        </p:nvSpPr>
+        <p:spPr>
+          <a:xfrm>
+            <a:off x="5705856" y="2542032"/>
+            <a:ext cx="777240" cy="777240"/>
           </a:xfrm>
           <a:prstGeom prst="ellipse">
             <a:avLst/>
@@ -5122,22 +5215,22 @@
       </p:sp>
       <p:pic>
         <p:nvPicPr>
-          <p:cNvPr id="18" name="Image 2" descr="preencoded.png">    </p:cNvPr>
+          <p:cNvPr id="18" name="Image 4" descr="preencoded.png">    </p:cNvPr>
           <p:cNvPicPr>
             <a:picLocks noChangeAspect="1"/>
           </p:cNvPicPr>
           <p:nvPr/>
         </p:nvPicPr>
         <p:blipFill>
-          <a:blip r:embed="rId3"/>
+          <a:blip r:embed="rId5"/>
           <a:stretch>
             <a:fillRect/>
           </a:stretch>
         </p:blipFill>
         <p:spPr>
           <a:xfrm>
-            <a:off x="8604504" y="2670048"/>
-            <a:ext cx="466344" cy="466344"/>
+            <a:off x="5897880" y="2734056"/>
+            <a:ext cx="393192" cy="393192"/>
           </a:xfrm>
           <a:prstGeom prst="rect">
             <a:avLst/>
@@ -5146,53 +5239,596 @@
       </p:pic>
       <p:sp>
         <p:nvSpPr>
-          <p:cNvPr id="19" name="Text 14"/>
-          <p:cNvSpPr/>
-          <p:nvPr/>
-        </p:nvSpPr>
-        <p:spPr>
-          <a:xfrm>
-            <a:off x="10369296" y="2423160"/>
-            <a:ext cx="1005840" cy="640080"/>
-          </a:xfrm>
-          <a:prstGeom prst="rect">
-            <a:avLst/>
-          </a:prstGeom>
-          <a:noFill/>
-          <a:ln/>
-        </p:spPr>
-        <p:txBody>
-          <a:bodyPr wrap="square" rtlCol="0" anchor="ctr"/>
-          <a:lstStyle/>
-          <a:p>
-            <a:pPr algn="r" indent="0" marL="0">
-              <a:buNone/>
-            </a:pPr>
-            <a:r>
-              <a:rPr lang="en-US" sz="3400" b="1" dirty="0">
-                <a:solidFill>
-                  <a:srgbClr val="CFE0E6"/>
-                </a:solidFill>
-                <a:latin typeface="Calibri" pitchFamily="34" charset="0"/>
-                <a:ea typeface="Calibri" pitchFamily="34" charset="-122"/>
-                <a:cs typeface="Calibri" pitchFamily="34" charset="-120"/>
-              </a:rPr>
-              <a:t>03</a:t>
-            </a:r>
-            <a:endParaRPr lang="en-US" sz="3400" dirty="0"/>
-          </a:p>
-        </p:txBody>
-      </p:sp>
-      <p:sp>
-        <p:nvSpPr>
-          <p:cNvPr id="20" name="Text 15"/>
-          <p:cNvSpPr/>
-          <p:nvPr/>
-        </p:nvSpPr>
-        <p:spPr>
-          <a:xfrm>
-            <a:off x="8403336" y="3520440"/>
-            <a:ext cx="2971800" cy="777240"/>
+          <p:cNvPr id="19" name="Text 12"/>
+          <p:cNvSpPr/>
+          <p:nvPr/>
+        </p:nvSpPr>
+        <p:spPr>
+          <a:xfrm>
+            <a:off x="5202936" y="3456432"/>
+            <a:ext cx="1783080" cy="365760"/>
+          </a:xfrm>
+          <a:prstGeom prst="rect">
+            <a:avLst/>
+          </a:prstGeom>
+          <a:noFill/>
+          <a:ln/>
+        </p:spPr>
+        <p:txBody>
+          <a:bodyPr wrap="square" rtlCol="0" anchor="ctr"/>
+          <a:lstStyle/>
+          <a:p>
+            <a:pPr algn="ctr" indent="0" marL="0">
+              <a:buNone/>
+            </a:pPr>
+            <a:r>
+              <a:rPr lang="en-US" sz="1400" b="1" dirty="0">
+                <a:solidFill>
+                  <a:srgbClr val="17313F"/>
+                </a:solidFill>
+                <a:latin typeface="Calibri" pitchFamily="34" charset="0"/>
+                <a:ea typeface="Calibri" pitchFamily="34" charset="-122"/>
+                <a:cs typeface="Calibri" pitchFamily="34" charset="-120"/>
+              </a:rPr>
+              <a:t>3. Investigate</a:t>
+            </a:r>
+            <a:endParaRPr lang="en-US" sz="1400" dirty="0"/>
+          </a:p>
+        </p:txBody>
+      </p:sp>
+      <p:sp>
+        <p:nvSpPr>
+          <p:cNvPr id="20" name="Text 13"/>
+          <p:cNvSpPr/>
+          <p:nvPr/>
+        </p:nvSpPr>
+        <p:spPr>
+          <a:xfrm>
+            <a:off x="5202936" y="3858768"/>
+            <a:ext cx="1783080" cy="640080"/>
+          </a:xfrm>
+          <a:prstGeom prst="rect">
+            <a:avLst/>
+          </a:prstGeom>
+          <a:noFill/>
+          <a:ln/>
+        </p:spPr>
+        <p:txBody>
+          <a:bodyPr wrap="square" rtlCol="0" anchor="ctr"/>
+          <a:lstStyle/>
+          <a:p>
+            <a:pPr algn="ctr" indent="0" marL="0">
+              <a:lnSpc>
+                <a:spcPct val="105000"/>
+              </a:lnSpc>
+              <a:buNone/>
+            </a:pPr>
+            <a:r>
+              <a:rPr lang="en-US" sz="1050" dirty="0">
+                <a:solidFill>
+                  <a:srgbClr val="71838F"/>
+                </a:solidFill>
+                <a:latin typeface="Calibri" pitchFamily="34" charset="0"/>
+                <a:ea typeface="Calibri" pitchFamily="34" charset="-122"/>
+                <a:cs typeface="Calibri" pitchFamily="34" charset="-120"/>
+              </a:rPr>
+              <a:t>AI multi-source</a:t>
+            </a:r>
+            <a:endParaRPr lang="en-US" sz="1050" dirty="0"/>
+          </a:p>
+          <a:p>
+            <a:pPr algn="ctr" indent="0" marL="0">
+              <a:lnSpc>
+                <a:spcPct val="105000"/>
+              </a:lnSpc>
+              <a:buNone/>
+            </a:pPr>
+            <a:r>
+              <a:rPr lang="en-US" sz="1050" dirty="0">
+                <a:solidFill>
+                  <a:srgbClr val="71838F"/>
+                </a:solidFill>
+                <a:latin typeface="Calibri" pitchFamily="34" charset="0"/>
+                <a:ea typeface="Calibri" pitchFamily="34" charset="-122"/>
+                <a:cs typeface="Calibri" pitchFamily="34" charset="-120"/>
+              </a:rPr>
+              <a:t>evidence pack</a:t>
+            </a:r>
+            <a:endParaRPr lang="en-US" sz="1050" dirty="0"/>
+          </a:p>
+        </p:txBody>
+      </p:sp>
+      <p:pic>
+        <p:nvPicPr>
+          <p:cNvPr id="21" name="Image 5" descr="preencoded.png">    </p:cNvPr>
+          <p:cNvPicPr>
+            <a:picLocks noChangeAspect="1"/>
+          </p:cNvPicPr>
+          <p:nvPr/>
+        </p:nvPicPr>
+        <p:blipFill>
+          <a:blip r:embed="rId6"/>
+          <a:stretch>
+            <a:fillRect/>
+          </a:stretch>
+        </p:blipFill>
+        <p:spPr>
+          <a:xfrm>
+            <a:off x="7114032" y="3323844"/>
+            <a:ext cx="256032" cy="256032"/>
+          </a:xfrm>
+          <a:prstGeom prst="rect">
+            <a:avLst/>
+          </a:prstGeom>
+        </p:spPr>
+      </p:pic>
+      <p:sp>
+        <p:nvSpPr>
+          <p:cNvPr id="22" name="Shape 14"/>
+          <p:cNvSpPr/>
+          <p:nvPr/>
+        </p:nvSpPr>
+        <p:spPr>
+          <a:xfrm>
+            <a:off x="7392924" y="2286000"/>
+            <a:ext cx="1965960" cy="2331720"/>
+          </a:xfrm>
+          <a:prstGeom prst="roundRect">
+            <a:avLst>
+              <a:gd name="adj" fmla="val 5581"/>
+            </a:avLst>
+          </a:prstGeom>
+          <a:solidFill>
+            <a:srgbClr val="F4FAFB"/>
+          </a:solidFill>
+          <a:ln w="12700">
+            <a:solidFill>
+              <a:srgbClr val="DCE8EE"/>
+            </a:solidFill>
+            <a:prstDash val="solid"/>
+          </a:ln>
+          <a:effectLst>
+            <a:outerShdw sx="100000" sy="100000" kx="0" ky="0" algn="bl" rotWithShape="0" blurRad="114300" dist="38100" dir="8100000">
+              <a:srgbClr val="0B1F2A">
+                <a:alpha val="16000"/>
+              </a:srgbClr>
+            </a:outerShdw>
+          </a:effectLst>
+        </p:spPr>
+      </p:sp>
+      <p:sp>
+        <p:nvSpPr>
+          <p:cNvPr id="23" name="Shape 15"/>
+          <p:cNvSpPr/>
+          <p:nvPr/>
+        </p:nvSpPr>
+        <p:spPr>
+          <a:xfrm>
+            <a:off x="7987284" y="2542032"/>
+            <a:ext cx="777240" cy="777240"/>
+          </a:xfrm>
+          <a:prstGeom prst="ellipse">
+            <a:avLst/>
+          </a:prstGeom>
+          <a:solidFill>
+            <a:srgbClr val="1BA39C"/>
+          </a:solidFill>
+          <a:ln/>
+        </p:spPr>
+      </p:sp>
+      <p:pic>
+        <p:nvPicPr>
+          <p:cNvPr id="24" name="Image 6" descr="preencoded.png">    </p:cNvPr>
+          <p:cNvPicPr>
+            <a:picLocks noChangeAspect="1"/>
+          </p:cNvPicPr>
+          <p:nvPr/>
+        </p:nvPicPr>
+        <p:blipFill>
+          <a:blip r:embed="rId7"/>
+          <a:stretch>
+            <a:fillRect/>
+          </a:stretch>
+        </p:blipFill>
+        <p:spPr>
+          <a:xfrm>
+            <a:off x="8179308" y="2734056"/>
+            <a:ext cx="393192" cy="393192"/>
+          </a:xfrm>
+          <a:prstGeom prst="rect">
+            <a:avLst/>
+          </a:prstGeom>
+        </p:spPr>
+      </p:pic>
+      <p:sp>
+        <p:nvSpPr>
+          <p:cNvPr id="25" name="Text 16"/>
+          <p:cNvSpPr/>
+          <p:nvPr/>
+        </p:nvSpPr>
+        <p:spPr>
+          <a:xfrm>
+            <a:off x="7484364" y="3456432"/>
+            <a:ext cx="1783080" cy="365760"/>
+          </a:xfrm>
+          <a:prstGeom prst="rect">
+            <a:avLst/>
+          </a:prstGeom>
+          <a:noFill/>
+          <a:ln/>
+        </p:spPr>
+        <p:txBody>
+          <a:bodyPr wrap="square" rtlCol="0" anchor="ctr"/>
+          <a:lstStyle/>
+          <a:p>
+            <a:pPr algn="ctr" indent="0" marL="0">
+              <a:buNone/>
+            </a:pPr>
+            <a:r>
+              <a:rPr lang="en-US" sz="1400" b="1" dirty="0">
+                <a:solidFill>
+                  <a:srgbClr val="17313F"/>
+                </a:solidFill>
+                <a:latin typeface="Calibri" pitchFamily="34" charset="0"/>
+                <a:ea typeface="Calibri" pitchFamily="34" charset="-122"/>
+                <a:cs typeface="Calibri" pitchFamily="34" charset="-120"/>
+              </a:rPr>
+              <a:t>4. Confirm</a:t>
+            </a:r>
+            <a:endParaRPr lang="en-US" sz="1400" dirty="0"/>
+          </a:p>
+        </p:txBody>
+      </p:sp>
+      <p:sp>
+        <p:nvSpPr>
+          <p:cNvPr id="26" name="Text 17"/>
+          <p:cNvSpPr/>
+          <p:nvPr/>
+        </p:nvSpPr>
+        <p:spPr>
+          <a:xfrm>
+            <a:off x="7484364" y="3858768"/>
+            <a:ext cx="1783080" cy="640080"/>
+          </a:xfrm>
+          <a:prstGeom prst="rect">
+            <a:avLst/>
+          </a:prstGeom>
+          <a:noFill/>
+          <a:ln/>
+        </p:spPr>
+        <p:txBody>
+          <a:bodyPr wrap="square" rtlCol="0" anchor="ctr"/>
+          <a:lstStyle/>
+          <a:p>
+            <a:pPr algn="ctr" indent="0" marL="0">
+              <a:lnSpc>
+                <a:spcPct val="105000"/>
+              </a:lnSpc>
+              <a:buNone/>
+            </a:pPr>
+            <a:r>
+              <a:rPr lang="en-US" sz="1050" dirty="0">
+                <a:solidFill>
+                  <a:srgbClr val="71838F"/>
+                </a:solidFill>
+                <a:latin typeface="Calibri" pitchFamily="34" charset="0"/>
+                <a:ea typeface="Calibri" pitchFamily="34" charset="-122"/>
+                <a:cs typeface="Calibri" pitchFamily="34" charset="-120"/>
+              </a:rPr>
+              <a:t>Legal reviews</a:t>
+            </a:r>
+            <a:endParaRPr lang="en-US" sz="1050" dirty="0"/>
+          </a:p>
+          <a:p>
+            <a:pPr algn="ctr" indent="0" marL="0">
+              <a:lnSpc>
+                <a:spcPct val="105000"/>
+              </a:lnSpc>
+              <a:buNone/>
+            </a:pPr>
+            <a:r>
+              <a:rPr lang="en-US" sz="1050" dirty="0">
+                <a:solidFill>
+                  <a:srgbClr val="71838F"/>
+                </a:solidFill>
+                <a:latin typeface="Calibri" pitchFamily="34" charset="0"/>
+                <a:ea typeface="Calibri" pitchFamily="34" charset="-122"/>
+                <a:cs typeface="Calibri" pitchFamily="34" charset="-120"/>
+              </a:rPr>
+              <a:t>&amp; decides</a:t>
+            </a:r>
+            <a:endParaRPr lang="en-US" sz="1050" dirty="0"/>
+          </a:p>
+        </p:txBody>
+      </p:sp>
+      <p:pic>
+        <p:nvPicPr>
+          <p:cNvPr id="27" name="Image 7" descr="preencoded.png">    </p:cNvPr>
+          <p:cNvPicPr>
+            <a:picLocks noChangeAspect="1"/>
+          </p:cNvPicPr>
+          <p:nvPr/>
+        </p:nvPicPr>
+        <p:blipFill>
+          <a:blip r:embed="rId8"/>
+          <a:stretch>
+            <a:fillRect/>
+          </a:stretch>
+        </p:blipFill>
+        <p:spPr>
+          <a:xfrm>
+            <a:off x="9395460" y="3323844"/>
+            <a:ext cx="256032" cy="256032"/>
+          </a:xfrm>
+          <a:prstGeom prst="rect">
+            <a:avLst/>
+          </a:prstGeom>
+        </p:spPr>
+      </p:pic>
+      <p:sp>
+        <p:nvSpPr>
+          <p:cNvPr id="28" name="Shape 18"/>
+          <p:cNvSpPr/>
+          <p:nvPr/>
+        </p:nvSpPr>
+        <p:spPr>
+          <a:xfrm>
+            <a:off x="9674352" y="2286000"/>
+            <a:ext cx="1965960" cy="2331720"/>
+          </a:xfrm>
+          <a:prstGeom prst="roundRect">
+            <a:avLst>
+              <a:gd name="adj" fmla="val 5581"/>
+            </a:avLst>
+          </a:prstGeom>
+          <a:solidFill>
+            <a:srgbClr val="F4FAFB"/>
+          </a:solidFill>
+          <a:ln w="12700">
+            <a:solidFill>
+              <a:srgbClr val="DCE8EE"/>
+            </a:solidFill>
+            <a:prstDash val="solid"/>
+          </a:ln>
+          <a:effectLst>
+            <a:outerShdw sx="100000" sy="100000" kx="0" ky="0" algn="bl" rotWithShape="0" blurRad="114300" dist="38100" dir="8100000">
+              <a:srgbClr val="0B1F2A">
+                <a:alpha val="16000"/>
+              </a:srgbClr>
+            </a:outerShdw>
+          </a:effectLst>
+        </p:spPr>
+      </p:sp>
+      <p:sp>
+        <p:nvSpPr>
+          <p:cNvPr id="29" name="Shape 19"/>
+          <p:cNvSpPr/>
+          <p:nvPr/>
+        </p:nvSpPr>
+        <p:spPr>
+          <a:xfrm>
+            <a:off x="10268712" y="2542032"/>
+            <a:ext cx="777240" cy="777240"/>
+          </a:xfrm>
+          <a:prstGeom prst="ellipse">
+            <a:avLst/>
+          </a:prstGeom>
+          <a:solidFill>
+            <a:srgbClr val="1BA39C"/>
+          </a:solidFill>
+          <a:ln/>
+        </p:spPr>
+      </p:sp>
+      <p:pic>
+        <p:nvPicPr>
+          <p:cNvPr id="30" name="Image 8" descr="preencoded.png">    </p:cNvPr>
+          <p:cNvPicPr>
+            <a:picLocks noChangeAspect="1"/>
+          </p:cNvPicPr>
+          <p:nvPr/>
+        </p:nvPicPr>
+        <p:blipFill>
+          <a:blip r:embed="rId9"/>
+          <a:stretch>
+            <a:fillRect/>
+          </a:stretch>
+        </p:blipFill>
+        <p:spPr>
+          <a:xfrm>
+            <a:off x="10460736" y="2734056"/>
+            <a:ext cx="393192" cy="393192"/>
+          </a:xfrm>
+          <a:prstGeom prst="rect">
+            <a:avLst/>
+          </a:prstGeom>
+        </p:spPr>
+      </p:pic>
+      <p:sp>
+        <p:nvSpPr>
+          <p:cNvPr id="31" name="Text 20"/>
+          <p:cNvSpPr/>
+          <p:nvPr/>
+        </p:nvSpPr>
+        <p:spPr>
+          <a:xfrm>
+            <a:off x="9765792" y="3456432"/>
+            <a:ext cx="1783080" cy="365760"/>
+          </a:xfrm>
+          <a:prstGeom prst="rect">
+            <a:avLst/>
+          </a:prstGeom>
+          <a:noFill/>
+          <a:ln/>
+        </p:spPr>
+        <p:txBody>
+          <a:bodyPr wrap="square" rtlCol="0" anchor="ctr"/>
+          <a:lstStyle/>
+          <a:p>
+            <a:pPr algn="ctr" indent="0" marL="0">
+              <a:buNone/>
+            </a:pPr>
+            <a:r>
+              <a:rPr lang="en-US" sz="1400" b="1" dirty="0">
+                <a:solidFill>
+                  <a:srgbClr val="17313F"/>
+                </a:solidFill>
+                <a:latin typeface="Calibri" pitchFamily="34" charset="0"/>
+                <a:ea typeface="Calibri" pitchFamily="34" charset="-122"/>
+                <a:cs typeface="Calibri" pitchFamily="34" charset="-120"/>
+              </a:rPr>
+              <a:t>5. Evolve</a:t>
+            </a:r>
+            <a:endParaRPr lang="en-US" sz="1400" dirty="0"/>
+          </a:p>
+        </p:txBody>
+      </p:sp>
+      <p:sp>
+        <p:nvSpPr>
+          <p:cNvPr id="32" name="Text 21"/>
+          <p:cNvSpPr/>
+          <p:nvPr/>
+        </p:nvSpPr>
+        <p:spPr>
+          <a:xfrm>
+            <a:off x="9765792" y="3858768"/>
+            <a:ext cx="1783080" cy="640080"/>
+          </a:xfrm>
+          <a:prstGeom prst="rect">
+            <a:avLst/>
+          </a:prstGeom>
+          <a:noFill/>
+          <a:ln/>
+        </p:spPr>
+        <p:txBody>
+          <a:bodyPr wrap="square" rtlCol="0" anchor="ctr"/>
+          <a:lstStyle/>
+          <a:p>
+            <a:pPr algn="ctr" indent="0" marL="0">
+              <a:lnSpc>
+                <a:spcPct val="105000"/>
+              </a:lnSpc>
+              <a:buNone/>
+            </a:pPr>
+            <a:r>
+              <a:rPr lang="en-US" sz="1050" dirty="0">
+                <a:solidFill>
+                  <a:srgbClr val="71838F"/>
+                </a:solidFill>
+                <a:latin typeface="Calibri" pitchFamily="34" charset="0"/>
+                <a:ea typeface="Calibri" pitchFamily="34" charset="-122"/>
+                <a:cs typeface="Calibri" pitchFamily="34" charset="-120"/>
+              </a:rPr>
+              <a:t>Calibrate PPV ·</a:t>
+            </a:r>
+            <a:endParaRPr lang="en-US" sz="1050" dirty="0"/>
+          </a:p>
+          <a:p>
+            <a:pPr algn="ctr" indent="0" marL="0">
+              <a:lnSpc>
+                <a:spcPct val="105000"/>
+              </a:lnSpc>
+              <a:buNone/>
+            </a:pPr>
+            <a:r>
+              <a:rPr lang="en-US" sz="1050" dirty="0">
+                <a:solidFill>
+                  <a:srgbClr val="71838F"/>
+                </a:solidFill>
+                <a:latin typeface="Calibri" pitchFamily="34" charset="0"/>
+                <a:ea typeface="Calibri" pitchFamily="34" charset="-122"/>
+                <a:cs typeface="Calibri" pitchFamily="34" charset="-120"/>
+              </a:rPr>
+              <a:t>discover new signals</a:t>
+            </a:r>
+            <a:endParaRPr lang="en-US" sz="1050" dirty="0"/>
+          </a:p>
+        </p:txBody>
+      </p:sp>
+      <p:sp>
+        <p:nvSpPr>
+          <p:cNvPr id="33" name="Shape 22"/>
+          <p:cNvSpPr/>
+          <p:nvPr/>
+        </p:nvSpPr>
+        <p:spPr>
+          <a:xfrm>
+            <a:off x="548640" y="5074920"/>
+            <a:ext cx="11091672" cy="868680"/>
+          </a:xfrm>
+          <a:prstGeom prst="roundRect">
+            <a:avLst>
+              <a:gd name="adj" fmla="val 12632"/>
+            </a:avLst>
+          </a:prstGeom>
+          <a:solidFill>
+            <a:srgbClr val="F4FAFB"/>
+          </a:solidFill>
+          <a:ln w="15240">
+            <a:solidFill>
+              <a:srgbClr val="1BA39C"/>
+            </a:solidFill>
+            <a:prstDash val="dash"/>
+          </a:ln>
+        </p:spPr>
+      </p:sp>
+      <p:pic>
+        <p:nvPicPr>
+          <p:cNvPr id="34" name="Image 9" descr="preencoded.png">    </p:cNvPr>
+          <p:cNvPicPr>
+            <a:picLocks noChangeAspect="1"/>
+          </p:cNvPicPr>
+          <p:nvPr/>
+        </p:nvPicPr>
+        <p:blipFill>
+          <a:blip r:embed="rId10"/>
+          <a:stretch>
+            <a:fillRect/>
+          </a:stretch>
+        </p:blipFill>
+        <p:spPr>
+          <a:xfrm flipH="1">
+            <a:off x="841248" y="5358384"/>
+            <a:ext cx="310896" cy="310896"/>
+          </a:xfrm>
+          <a:prstGeom prst="rect">
+            <a:avLst/>
+          </a:prstGeom>
+        </p:spPr>
+      </p:pic>
+      <p:pic>
+        <p:nvPicPr>
+          <p:cNvPr id="35" name="Image 10" descr="preencoded.png">    </p:cNvPr>
+          <p:cNvPicPr>
+            <a:picLocks noChangeAspect="1"/>
+          </p:cNvPicPr>
+          <p:nvPr/>
+        </p:nvPicPr>
+        <p:blipFill>
+          <a:blip r:embed="rId11"/>
+          <a:stretch>
+            <a:fillRect/>
+          </a:stretch>
+        </p:blipFill>
+        <p:spPr>
+          <a:xfrm>
+            <a:off x="1298448" y="5349240"/>
+            <a:ext cx="329184" cy="329184"/>
+          </a:xfrm>
+          <a:prstGeom prst="rect">
+            <a:avLst/>
+          </a:prstGeom>
+        </p:spPr>
+      </p:pic>
+      <p:sp>
+        <p:nvSpPr>
+          <p:cNvPr id="36" name="Text 23"/>
+          <p:cNvSpPr/>
+          <p:nvPr/>
+        </p:nvSpPr>
+        <p:spPr>
+          <a:xfrm>
+            <a:off x="1783080" y="5120640"/>
+            <a:ext cx="9692640" cy="777240"/>
           </a:xfrm>
           <a:prstGeom prst="rect">
             <a:avLst/>
@@ -5206,70 +5842,45 @@
           <a:p>
             <a:pPr indent="0" marL="0">
               <a:lnSpc>
-                <a:spcPct val="100000"/>
+                <a:spcPct val="110000"/>
               </a:lnSpc>
               <a:buNone/>
             </a:pPr>
             <a:r>
-              <a:rPr lang="en-US" sz="1700" b="1" dirty="0">
-                <a:solidFill>
-                  <a:srgbClr val="17313F"/>
-                </a:solidFill>
-                <a:latin typeface="Calibri" pitchFamily="34" charset="0"/>
-                <a:ea typeface="Calibri" pitchFamily="34" charset="-122"/>
-                <a:cs typeface="Calibri" pitchFamily="34" charset="-120"/>
-              </a:rPr>
-              <a:t>Signal Ledger + Calibration</a:t>
-            </a:r>
-            <a:endParaRPr lang="en-US" sz="1700" dirty="0"/>
-          </a:p>
-        </p:txBody>
-      </p:sp>
-      <p:sp>
-        <p:nvSpPr>
-          <p:cNvPr id="21" name="Text 16"/>
-          <p:cNvSpPr/>
-          <p:nvPr/>
-        </p:nvSpPr>
-        <p:spPr>
-          <a:xfrm>
-            <a:off x="8421624" y="4297680"/>
-            <a:ext cx="2971800" cy="1188720"/>
-          </a:xfrm>
-          <a:prstGeom prst="rect">
-            <a:avLst/>
-          </a:prstGeom>
-          <a:noFill/>
-          <a:ln/>
-        </p:spPr>
-        <p:txBody>
-          <a:bodyPr wrap="square" rtlCol="0" anchor="ctr"/>
-          <a:lstStyle/>
-          <a:p>
+              <a:rPr lang="en-US" sz="1300" b="1" dirty="0">
+                <a:solidFill>
+                  <a:srgbClr val="1BA39C"/>
+                </a:solidFill>
+                <a:latin typeface="Calibri" pitchFamily="34" charset="0"/>
+                <a:ea typeface="Calibri" pitchFamily="34" charset="-122"/>
+                <a:cs typeface="Calibri" pitchFamily="34" charset="-120"/>
+              </a:rPr>
+              <a:t>Continuous loop: </a:t>
+            </a:r>
             <a:pPr indent="0" marL="0">
               <a:lnSpc>
-                <a:spcPct val="122000"/>
+                <a:spcPct val="110000"/>
               </a:lnSpc>
               <a:buNone/>
             </a:pPr>
             <a:r>
-              <a:rPr lang="en-US" sz="1250" dirty="0">
-                <a:solidFill>
-                  <a:srgbClr val="71838F"/>
-                </a:solidFill>
-                <a:latin typeface="Calibri" pitchFamily="34" charset="0"/>
-                <a:ea typeface="Calibri" pitchFamily="34" charset="-122"/>
-                <a:cs typeface="Calibri" pitchFamily="34" charset="-120"/>
-              </a:rPr>
-              <a:t>Each signal is promoted / demoted by its real hit rate, not gut feel; every change is auditable.</a:t>
-            </a:r>
-            <a:endParaRPr lang="en-US" sz="1250" dirty="0"/>
-          </a:p>
-        </p:txBody>
-      </p:sp>
-      <p:sp>
-        <p:nvSpPr>
-          <p:cNvPr id="22" name="Text 17"/>
+              <a:rPr lang="en-US" sz="1300" dirty="0">
+                <a:solidFill>
+                  <a:srgbClr val="17313F"/>
+                </a:solidFill>
+                <a:latin typeface="Calibri" pitchFamily="34" charset="0"/>
+                <a:ea typeface="Calibri" pitchFamily="34" charset="-122"/>
+                <a:cs typeface="Calibri" pitchFamily="34" charset="-120"/>
+              </a:rPr>
+              <a:t>every confirmation recalibrates tiering and promotes validated new signals — all gated by statistical calibration + human approval.</a:t>
+            </a:r>
+            <a:endParaRPr lang="en-US" sz="1300" dirty="0"/>
+          </a:p>
+        </p:txBody>
+      </p:sp>
+      <p:sp>
+        <p:nvSpPr>
+          <p:cNvPr id="37" name="Text 24"/>
           <p:cNvSpPr/>
           <p:nvPr/>
         </p:nvSpPr>
@@ -5308,7 +5919,7 @@
       </p:sp>
       <p:sp>
         <p:nvSpPr>
-          <p:cNvPr id="23" name="Text 18"/>
+          <p:cNvPr id="38" name="Text 25"/>
           <p:cNvSpPr/>
           <p:nvPr/>
         </p:nvSpPr>
@@ -5410,7 +6021,7 @@
                 <a:ea typeface="Calibri" pitchFamily="34" charset="-122"/>
                 <a:cs typeface="Calibri" pitchFamily="34" charset="-120"/>
               </a:rPr>
-              <a:t>SPOTLIGHT · SELF-EVOLUTION (HERMES AGENT)</a:t>
+              <a:t>THREE CORE INNOVATIONS</a:t>
             </a:r>
             <a:endParaRPr lang="en-US" sz="1200" dirty="0"/>
           </a:p>
@@ -5449,7 +6060,7 @@
                 <a:ea typeface="Calibri" pitchFamily="34" charset="-122"/>
                 <a:cs typeface="Calibri" pitchFamily="34" charset="-120"/>
               </a:rPr>
-              <a:t>The system discovers new risks — but tiering stays gated</a:t>
+              <a:t>From static rules to an evolving assistant</a:t>
             </a:r>
             <a:endParaRPr lang="en-US" sz="3000" dirty="0"/>
           </a:p>
@@ -5457,80 +6068,48 @@
       </p:sp>
       <p:sp>
         <p:nvSpPr>
-          <p:cNvPr id="4" name="Text 2"/>
-          <p:cNvSpPr/>
-          <p:nvPr/>
-        </p:nvSpPr>
-        <p:spPr>
-          <a:xfrm>
-            <a:off x="548640" y="1600200"/>
-            <a:ext cx="10972800" cy="457200"/>
-          </a:xfrm>
-          <a:prstGeom prst="rect">
-            <a:avLst/>
-          </a:prstGeom>
-          <a:noFill/>
-          <a:ln/>
-        </p:spPr>
-        <p:txBody>
-          <a:bodyPr wrap="square" rtlCol="0" anchor="ctr"/>
-          <a:lstStyle/>
-          <a:p>
-            <a:pPr indent="0" marL="0">
-              <a:buNone/>
-            </a:pPr>
-            <a:r>
-              <a:rPr lang="en-US" sz="1400" dirty="0">
-                <a:solidFill>
-                  <a:srgbClr val="71838F"/>
-                </a:solidFill>
-                <a:latin typeface="Calibri" pitchFamily="34" charset="0"/>
-                <a:ea typeface="Calibri" pitchFamily="34" charset="-122"/>
-                <a:cs typeface="Calibri" pitchFamily="34" charset="-120"/>
-              </a:rPr>
-              <a:t>Signals used to be predefined by Legal from experience; now the agent proposes new hypotheses from accumulated cases.</a:t>
-            </a:r>
-            <a:endParaRPr lang="en-US" sz="1400" dirty="0"/>
-          </a:p>
-        </p:txBody>
-      </p:sp>
-      <p:sp>
-        <p:nvSpPr>
-          <p:cNvPr id="5" name="Shape 3"/>
-          <p:cNvSpPr/>
-          <p:nvPr/>
-        </p:nvSpPr>
-        <p:spPr>
-          <a:xfrm>
-            <a:off x="548640" y="2286000"/>
-            <a:ext cx="2468880" cy="1828800"/>
+          <p:cNvPr id="4" name="Shape 2"/>
+          <p:cNvSpPr/>
+          <p:nvPr/>
+        </p:nvSpPr>
+        <p:spPr>
+          <a:xfrm>
+            <a:off x="548640" y="2148840"/>
+            <a:ext cx="3474720" cy="3383280"/>
           </a:xfrm>
           <a:prstGeom prst="roundRect">
             <a:avLst>
-              <a:gd name="adj" fmla="val 6000"/>
+              <a:gd name="adj" fmla="val 3784"/>
             </a:avLst>
           </a:prstGeom>
           <a:solidFill>
             <a:srgbClr val="F4FAFB"/>
           </a:solidFill>
-          <a:ln w="19050">
+          <a:ln w="12700">
             <a:solidFill>
-              <a:srgbClr val="1BA39C"/>
+              <a:srgbClr val="DCE8EE"/>
             </a:solidFill>
             <a:prstDash val="solid"/>
           </a:ln>
-        </p:spPr>
-      </p:sp>
-      <p:sp>
-        <p:nvSpPr>
-          <p:cNvPr id="6" name="Shape 4"/>
-          <p:cNvSpPr/>
-          <p:nvPr/>
-        </p:nvSpPr>
-        <p:spPr>
-          <a:xfrm>
-            <a:off x="1463040" y="2487168"/>
-            <a:ext cx="640080" cy="640080"/>
+          <a:effectLst>
+            <a:outerShdw sx="100000" sy="100000" kx="0" ky="0" algn="bl" rotWithShape="0" blurRad="114300" dist="38100" dir="8100000">
+              <a:srgbClr val="0B1F2A">
+                <a:alpha val="16000"/>
+              </a:srgbClr>
+            </a:outerShdw>
+          </a:effectLst>
+        </p:spPr>
+      </p:sp>
+      <p:sp>
+        <p:nvSpPr>
+          <p:cNvPr id="5" name="Shape 3"/>
+          <p:cNvSpPr/>
+          <p:nvPr/>
+        </p:nvSpPr>
+        <p:spPr>
+          <a:xfrm>
+            <a:off x="868680" y="2468880"/>
+            <a:ext cx="868680" cy="868680"/>
           </a:xfrm>
           <a:prstGeom prst="ellipse">
             <a:avLst/>
@@ -5543,7 +6122,7 @@
       </p:sp>
       <p:pic>
         <p:nvPicPr>
-          <p:cNvPr id="7" name="Image 0" descr="preencoded.png">    </p:cNvPr>
+          <p:cNvPr id="6" name="Image 0" descr="preencoded.png">    </p:cNvPr>
           <p:cNvPicPr>
             <a:picLocks noChangeAspect="1"/>
           </p:cNvPicPr>
@@ -5557,8 +6136,8 @@
         </p:blipFill>
         <p:spPr>
           <a:xfrm>
-            <a:off x="1591056" y="2615184"/>
-            <a:ext cx="384048" cy="384048"/>
+            <a:off x="1069848" y="2670048"/>
+            <a:ext cx="466344" cy="466344"/>
           </a:xfrm>
           <a:prstGeom prst="rect">
             <a:avLst/>
@@ -5567,33 +6146,72 @@
       </p:pic>
       <p:sp>
         <p:nvSpPr>
+          <p:cNvPr id="7" name="Text 4"/>
+          <p:cNvSpPr/>
+          <p:nvPr/>
+        </p:nvSpPr>
+        <p:spPr>
+          <a:xfrm>
+            <a:off x="2834640" y="2423160"/>
+            <a:ext cx="1005840" cy="640080"/>
+          </a:xfrm>
+          <a:prstGeom prst="rect">
+            <a:avLst/>
+          </a:prstGeom>
+          <a:noFill/>
+          <a:ln/>
+        </p:spPr>
+        <p:txBody>
+          <a:bodyPr wrap="square" rtlCol="0" anchor="ctr"/>
+          <a:lstStyle/>
+          <a:p>
+            <a:pPr algn="r" indent="0" marL="0">
+              <a:buNone/>
+            </a:pPr>
+            <a:r>
+              <a:rPr lang="en-US" sz="3400" b="1" dirty="0">
+                <a:solidFill>
+                  <a:srgbClr val="CFE0E6"/>
+                </a:solidFill>
+                <a:latin typeface="Calibri" pitchFamily="34" charset="0"/>
+                <a:ea typeface="Calibri" pitchFamily="34" charset="-122"/>
+                <a:cs typeface="Calibri" pitchFamily="34" charset="-120"/>
+              </a:rPr>
+              <a:t>01</a:t>
+            </a:r>
+            <a:endParaRPr lang="en-US" sz="3400" dirty="0"/>
+          </a:p>
+        </p:txBody>
+      </p:sp>
+      <p:sp>
+        <p:nvSpPr>
           <p:cNvPr id="8" name="Text 5"/>
           <p:cNvSpPr/>
           <p:nvPr/>
         </p:nvSpPr>
         <p:spPr>
           <a:xfrm>
-            <a:off x="640080" y="3200400"/>
-            <a:ext cx="2286000" cy="411480"/>
-          </a:xfrm>
-          <a:prstGeom prst="rect">
-            <a:avLst/>
-          </a:prstGeom>
-          <a:noFill/>
-          <a:ln/>
-        </p:spPr>
-        <p:txBody>
-          <a:bodyPr wrap="square" rtlCol="0" anchor="ctr"/>
-          <a:lstStyle/>
-          <a:p>
-            <a:pPr algn="ctr" indent="0" marL="0">
+            <a:off x="868680" y="3520440"/>
+            <a:ext cx="2971800" cy="777240"/>
+          </a:xfrm>
+          <a:prstGeom prst="rect">
+            <a:avLst/>
+          </a:prstGeom>
+          <a:noFill/>
+          <a:ln/>
+        </p:spPr>
+        <p:txBody>
+          <a:bodyPr wrap="square" rtlCol="0" anchor="ctr"/>
+          <a:lstStyle/>
+          <a:p>
+            <a:pPr indent="0" marL="0">
               <a:lnSpc>
                 <a:spcPct val="100000"/>
               </a:lnSpc>
               <a:buNone/>
             </a:pPr>
             <a:r>
-              <a:rPr lang="en-US" sz="1400" b="1" dirty="0">
+              <a:rPr lang="en-US" sz="1700" b="1" dirty="0">
                 <a:solidFill>
                   <a:srgbClr val="17313F"/>
                 </a:solidFill>
@@ -5601,9 +6219,9 @@
                 <a:ea typeface="Calibri" pitchFamily="34" charset="-122"/>
                 <a:cs typeface="Calibri" pitchFamily="34" charset="-120"/>
               </a:rPr>
-              <a:t>Agent Discovers</a:t>
-            </a:r>
-            <a:endParaRPr lang="en-US" sz="1400" dirty="0"/>
+              <a:t>AI Investigation Agent</a:t>
+            </a:r>
+            <a:endParaRPr lang="en-US" sz="1700" dirty="0"/>
           </a:p>
         </p:txBody>
       </p:sp>
@@ -5615,27 +6233,27 @@
         </p:nvSpPr>
         <p:spPr>
           <a:xfrm>
-            <a:off x="658368" y="3639312"/>
-            <a:ext cx="2249424" cy="411480"/>
-          </a:xfrm>
-          <a:prstGeom prst="rect">
-            <a:avLst/>
-          </a:prstGeom>
-          <a:noFill/>
-          <a:ln/>
-        </p:spPr>
-        <p:txBody>
-          <a:bodyPr wrap="square" rtlCol="0" anchor="ctr"/>
-          <a:lstStyle/>
-          <a:p>
-            <a:pPr algn="ctr" indent="0" marL="0">
+            <a:off x="886968" y="4297680"/>
+            <a:ext cx="2971800" cy="1188720"/>
+          </a:xfrm>
+          <a:prstGeom prst="rect">
+            <a:avLst/>
+          </a:prstGeom>
+          <a:noFill/>
+          <a:ln/>
+        </p:spPr>
+        <p:txBody>
+          <a:bodyPr wrap="square" rtlCol="0" anchor="ctr"/>
+          <a:lstStyle/>
+          <a:p>
+            <a:pPr indent="0" marL="0">
               <a:lnSpc>
-                <a:spcPct val="100000"/>
+                <a:spcPct val="122000"/>
               </a:lnSpc>
               <a:buNone/>
             </a:pPr>
             <a:r>
-              <a:rPr lang="en-US" sz="1100" dirty="0">
+              <a:rPr lang="en-US" sz="1250" dirty="0">
                 <a:solidFill>
                   <a:srgbClr val="71838F"/>
                 </a:solidFill>
@@ -5643,15 +6261,69 @@
                 <a:ea typeface="Calibri" pitchFamily="34" charset="-122"/>
                 <a:cs typeface="Calibri" pitchFamily="34" charset="-120"/>
               </a:rPr>
-              <a:t>learns recurring new patterns</a:t>
-            </a:r>
-            <a:endParaRPr lang="en-US" sz="1100" dirty="0"/>
-          </a:p>
-        </p:txBody>
+              <a:t>Auto multi-source evidence (Qichacha / Tianyancha / Dow Jones) cuts each case from an hour to minutes; humans make the final call.</a:t>
+            </a:r>
+            <a:endParaRPr lang="en-US" sz="1250" dirty="0"/>
+          </a:p>
+        </p:txBody>
+      </p:sp>
+      <p:sp>
+        <p:nvSpPr>
+          <p:cNvPr id="10" name="Shape 7"/>
+          <p:cNvSpPr/>
+          <p:nvPr/>
+        </p:nvSpPr>
+        <p:spPr>
+          <a:xfrm>
+            <a:off x="4315968" y="2148840"/>
+            <a:ext cx="3474720" cy="3383280"/>
+          </a:xfrm>
+          <a:prstGeom prst="roundRect">
+            <a:avLst>
+              <a:gd name="adj" fmla="val 3784"/>
+            </a:avLst>
+          </a:prstGeom>
+          <a:solidFill>
+            <a:srgbClr val="F4FAFB"/>
+          </a:solidFill>
+          <a:ln w="12700">
+            <a:solidFill>
+              <a:srgbClr val="DCE8EE"/>
+            </a:solidFill>
+            <a:prstDash val="solid"/>
+          </a:ln>
+          <a:effectLst>
+            <a:outerShdw sx="100000" sy="100000" kx="0" ky="0" algn="bl" rotWithShape="0" blurRad="114300" dist="38100" dir="8100000">
+              <a:srgbClr val="0B1F2A">
+                <a:alpha val="16000"/>
+              </a:srgbClr>
+            </a:outerShdw>
+          </a:effectLst>
+        </p:spPr>
+      </p:sp>
+      <p:sp>
+        <p:nvSpPr>
+          <p:cNvPr id="11" name="Shape 8"/>
+          <p:cNvSpPr/>
+          <p:nvPr/>
+        </p:nvSpPr>
+        <p:spPr>
+          <a:xfrm>
+            <a:off x="4636008" y="2468880"/>
+            <a:ext cx="868680" cy="868680"/>
+          </a:xfrm>
+          <a:prstGeom prst="ellipse">
+            <a:avLst/>
+          </a:prstGeom>
+          <a:solidFill>
+            <a:srgbClr val="1BA39C"/>
+          </a:solidFill>
+          <a:ln/>
+        </p:spPr>
       </p:sp>
       <p:pic>
         <p:nvPicPr>
-          <p:cNvPr id="10" name="Image 1" descr="preencoded.png">    </p:cNvPr>
+          <p:cNvPr id="12" name="Image 1" descr="preencoded.png">    </p:cNvPr>
           <p:cNvPicPr>
             <a:picLocks noChangeAspect="1"/>
           </p:cNvPicPr>
@@ -5665,8 +6337,8 @@
         </p:blipFill>
         <p:spPr>
           <a:xfrm>
-            <a:off x="3054096" y="3063240"/>
-            <a:ext cx="292608" cy="292608"/>
+            <a:off x="4837176" y="2670048"/>
+            <a:ext cx="466344" cy="466344"/>
           </a:xfrm>
           <a:prstGeom prst="rect">
             <a:avLst/>
@@ -5675,54 +6347,184 @@
       </p:pic>
       <p:sp>
         <p:nvSpPr>
-          <p:cNvPr id="11" name="Shape 7"/>
-          <p:cNvSpPr/>
-          <p:nvPr/>
-        </p:nvSpPr>
-        <p:spPr>
-          <a:xfrm>
-            <a:off x="3337560" y="2286000"/>
-            <a:ext cx="2468880" cy="1828800"/>
+          <p:cNvPr id="13" name="Text 9"/>
+          <p:cNvSpPr/>
+          <p:nvPr/>
+        </p:nvSpPr>
+        <p:spPr>
+          <a:xfrm>
+            <a:off x="6601968" y="2423160"/>
+            <a:ext cx="1005840" cy="640080"/>
+          </a:xfrm>
+          <a:prstGeom prst="rect">
+            <a:avLst/>
+          </a:prstGeom>
+          <a:noFill/>
+          <a:ln/>
+        </p:spPr>
+        <p:txBody>
+          <a:bodyPr wrap="square" rtlCol="0" anchor="ctr"/>
+          <a:lstStyle/>
+          <a:p>
+            <a:pPr algn="r" indent="0" marL="0">
+              <a:buNone/>
+            </a:pPr>
+            <a:r>
+              <a:rPr lang="en-US" sz="3400" b="1" dirty="0">
+                <a:solidFill>
+                  <a:srgbClr val="CFE0E6"/>
+                </a:solidFill>
+                <a:latin typeface="Calibri" pitchFamily="34" charset="0"/>
+                <a:ea typeface="Calibri" pitchFamily="34" charset="-122"/>
+                <a:cs typeface="Calibri" pitchFamily="34" charset="-120"/>
+              </a:rPr>
+              <a:t>02</a:t>
+            </a:r>
+            <a:endParaRPr lang="en-US" sz="3400" dirty="0"/>
+          </a:p>
+        </p:txBody>
+      </p:sp>
+      <p:sp>
+        <p:nvSpPr>
+          <p:cNvPr id="14" name="Text 10"/>
+          <p:cNvSpPr/>
+          <p:nvPr/>
+        </p:nvSpPr>
+        <p:spPr>
+          <a:xfrm>
+            <a:off x="4636008" y="3520440"/>
+            <a:ext cx="2971800" cy="777240"/>
+          </a:xfrm>
+          <a:prstGeom prst="rect">
+            <a:avLst/>
+          </a:prstGeom>
+          <a:noFill/>
+          <a:ln/>
+        </p:spPr>
+        <p:txBody>
+          <a:bodyPr wrap="square" rtlCol="0" anchor="ctr"/>
+          <a:lstStyle/>
+          <a:p>
+            <a:pPr indent="0" marL="0">
+              <a:lnSpc>
+                <a:spcPct val="100000"/>
+              </a:lnSpc>
+              <a:buNone/>
+            </a:pPr>
+            <a:r>
+              <a:rPr lang="en-US" sz="1700" b="1" dirty="0">
+                <a:solidFill>
+                  <a:srgbClr val="17313F"/>
+                </a:solidFill>
+                <a:latin typeface="Calibri" pitchFamily="34" charset="0"/>
+                <a:ea typeface="Calibri" pitchFamily="34" charset="-122"/>
+                <a:cs typeface="Calibri" pitchFamily="34" charset="-120"/>
+              </a:rPr>
+              <a:t>Self-Evolution</a:t>
+            </a:r>
+            <a:endParaRPr lang="en-US" sz="1700" dirty="0"/>
+          </a:p>
+        </p:txBody>
+      </p:sp>
+      <p:sp>
+        <p:nvSpPr>
+          <p:cNvPr id="15" name="Text 11"/>
+          <p:cNvSpPr/>
+          <p:nvPr/>
+        </p:nvSpPr>
+        <p:spPr>
+          <a:xfrm>
+            <a:off x="4654296" y="4297680"/>
+            <a:ext cx="2971800" cy="1188720"/>
+          </a:xfrm>
+          <a:prstGeom prst="rect">
+            <a:avLst/>
+          </a:prstGeom>
+          <a:noFill/>
+          <a:ln/>
+        </p:spPr>
+        <p:txBody>
+          <a:bodyPr wrap="square" rtlCol="0" anchor="ctr"/>
+          <a:lstStyle/>
+          <a:p>
+            <a:pPr indent="0" marL="0">
+              <a:lnSpc>
+                <a:spcPct val="122000"/>
+              </a:lnSpc>
+              <a:buNone/>
+            </a:pPr>
+            <a:r>
+              <a:rPr lang="en-US" sz="1250" dirty="0">
+                <a:solidFill>
+                  <a:srgbClr val="71838F"/>
+                </a:solidFill>
+                <a:latin typeface="Calibri" pitchFamily="34" charset="0"/>
+                <a:ea typeface="Calibri" pitchFamily="34" charset="-122"/>
+                <a:cs typeface="Calibri" pitchFamily="34" charset="-120"/>
+              </a:rPr>
+              <a:t>The agent discovers new signals not yet in the rule set — but they enter only as candidates, taking effect after calibration + approval.</a:t>
+            </a:r>
+            <a:endParaRPr lang="en-US" sz="1250" dirty="0"/>
+          </a:p>
+        </p:txBody>
+      </p:sp>
+      <p:sp>
+        <p:nvSpPr>
+          <p:cNvPr id="16" name="Shape 12"/>
+          <p:cNvSpPr/>
+          <p:nvPr/>
+        </p:nvSpPr>
+        <p:spPr>
+          <a:xfrm>
+            <a:off x="8083296" y="2148840"/>
+            <a:ext cx="3474720" cy="3383280"/>
           </a:xfrm>
           <a:prstGeom prst="roundRect">
             <a:avLst>
-              <a:gd name="adj" fmla="val 6000"/>
+              <a:gd name="adj" fmla="val 3784"/>
             </a:avLst>
           </a:prstGeom>
           <a:solidFill>
             <a:srgbClr val="F4FAFB"/>
           </a:solidFill>
-          <a:ln w="19050">
+          <a:ln w="12700">
             <a:solidFill>
-              <a:srgbClr val="C9861A"/>
+              <a:srgbClr val="DCE8EE"/>
             </a:solidFill>
             <a:prstDash val="solid"/>
           </a:ln>
-        </p:spPr>
-      </p:sp>
-      <p:sp>
-        <p:nvSpPr>
-          <p:cNvPr id="12" name="Shape 8"/>
-          <p:cNvSpPr/>
-          <p:nvPr/>
-        </p:nvSpPr>
-        <p:spPr>
-          <a:xfrm>
-            <a:off x="4251960" y="2487168"/>
-            <a:ext cx="640080" cy="640080"/>
+          <a:effectLst>
+            <a:outerShdw sx="100000" sy="100000" kx="0" ky="0" algn="bl" rotWithShape="0" blurRad="114300" dist="38100" dir="8100000">
+              <a:srgbClr val="0B1F2A">
+                <a:alpha val="16000"/>
+              </a:srgbClr>
+            </a:outerShdw>
+          </a:effectLst>
+        </p:spPr>
+      </p:sp>
+      <p:sp>
+        <p:nvSpPr>
+          <p:cNvPr id="17" name="Shape 13"/>
+          <p:cNvSpPr/>
+          <p:nvPr/>
+        </p:nvSpPr>
+        <p:spPr>
+          <a:xfrm>
+            <a:off x="8403336" y="2468880"/>
+            <a:ext cx="868680" cy="868680"/>
           </a:xfrm>
           <a:prstGeom prst="ellipse">
             <a:avLst/>
           </a:prstGeom>
           <a:solidFill>
-            <a:srgbClr val="C9861A"/>
+            <a:srgbClr val="1BA39C"/>
           </a:solidFill>
           <a:ln/>
         </p:spPr>
       </p:sp>
       <p:pic>
         <p:nvPicPr>
-          <p:cNvPr id="13" name="Image 2" descr="preencoded.png">    </p:cNvPr>
+          <p:cNvPr id="18" name="Image 2" descr="preencoded.png">    </p:cNvPr>
           <p:cNvPicPr>
             <a:picLocks noChangeAspect="1"/>
           </p:cNvPicPr>
@@ -5736,8 +6538,8 @@
         </p:blipFill>
         <p:spPr>
           <a:xfrm>
-            <a:off x="4379976" y="2615184"/>
-            <a:ext cx="384048" cy="384048"/>
+            <a:off x="8604504" y="2670048"/>
+            <a:ext cx="466344" cy="466344"/>
           </a:xfrm>
           <a:prstGeom prst="rect">
             <a:avLst/>
@@ -5746,33 +6548,72 @@
       </p:pic>
       <p:sp>
         <p:nvSpPr>
-          <p:cNvPr id="14" name="Text 9"/>
-          <p:cNvSpPr/>
-          <p:nvPr/>
-        </p:nvSpPr>
-        <p:spPr>
-          <a:xfrm>
-            <a:off x="3429000" y="3200400"/>
-            <a:ext cx="2286000" cy="411480"/>
-          </a:xfrm>
-          <a:prstGeom prst="rect">
-            <a:avLst/>
-          </a:prstGeom>
-          <a:noFill/>
-          <a:ln/>
-        </p:spPr>
-        <p:txBody>
-          <a:bodyPr wrap="square" rtlCol="0" anchor="ctr"/>
-          <a:lstStyle/>
-          <a:p>
-            <a:pPr algn="ctr" indent="0" marL="0">
+          <p:cNvPr id="19" name="Text 14"/>
+          <p:cNvSpPr/>
+          <p:nvPr/>
+        </p:nvSpPr>
+        <p:spPr>
+          <a:xfrm>
+            <a:off x="10369296" y="2423160"/>
+            <a:ext cx="1005840" cy="640080"/>
+          </a:xfrm>
+          <a:prstGeom prst="rect">
+            <a:avLst/>
+          </a:prstGeom>
+          <a:noFill/>
+          <a:ln/>
+        </p:spPr>
+        <p:txBody>
+          <a:bodyPr wrap="square" rtlCol="0" anchor="ctr"/>
+          <a:lstStyle/>
+          <a:p>
+            <a:pPr algn="r" indent="0" marL="0">
+              <a:buNone/>
+            </a:pPr>
+            <a:r>
+              <a:rPr lang="en-US" sz="3400" b="1" dirty="0">
+                <a:solidFill>
+                  <a:srgbClr val="CFE0E6"/>
+                </a:solidFill>
+                <a:latin typeface="Calibri" pitchFamily="34" charset="0"/>
+                <a:ea typeface="Calibri" pitchFamily="34" charset="-122"/>
+                <a:cs typeface="Calibri" pitchFamily="34" charset="-120"/>
+              </a:rPr>
+              <a:t>03</a:t>
+            </a:r>
+            <a:endParaRPr lang="en-US" sz="3400" dirty="0"/>
+          </a:p>
+        </p:txBody>
+      </p:sp>
+      <p:sp>
+        <p:nvSpPr>
+          <p:cNvPr id="20" name="Text 15"/>
+          <p:cNvSpPr/>
+          <p:nvPr/>
+        </p:nvSpPr>
+        <p:spPr>
+          <a:xfrm>
+            <a:off x="8403336" y="3520440"/>
+            <a:ext cx="2971800" cy="777240"/>
+          </a:xfrm>
+          <a:prstGeom prst="rect">
+            <a:avLst/>
+          </a:prstGeom>
+          <a:noFill/>
+          <a:ln/>
+        </p:spPr>
+        <p:txBody>
+          <a:bodyPr wrap="square" rtlCol="0" anchor="ctr"/>
+          <a:lstStyle/>
+          <a:p>
+            <a:pPr indent="0" marL="0">
               <a:lnSpc>
                 <a:spcPct val="100000"/>
               </a:lnSpc>
               <a:buNone/>
             </a:pPr>
             <a:r>
-              <a:rPr lang="en-US" sz="1400" b="1" dirty="0">
+              <a:rPr lang="en-US" sz="1700" b="1" dirty="0">
                 <a:solidFill>
                   <a:srgbClr val="17313F"/>
                 </a:solidFill>
@@ -5780,473 +6621,22 @@
                 <a:ea typeface="Calibri" pitchFamily="34" charset="-122"/>
                 <a:cs typeface="Calibri" pitchFamily="34" charset="-120"/>
               </a:rPr>
-              <a:t>Enters Candidacy</a:t>
-            </a:r>
-            <a:endParaRPr lang="en-US" sz="1400" dirty="0"/>
-          </a:p>
-        </p:txBody>
-      </p:sp>
-      <p:sp>
-        <p:nvSpPr>
-          <p:cNvPr id="15" name="Text 10"/>
-          <p:cNvSpPr/>
-          <p:nvPr/>
-        </p:nvSpPr>
-        <p:spPr>
-          <a:xfrm>
-            <a:off x="3447288" y="3639312"/>
-            <a:ext cx="2249424" cy="411480"/>
-          </a:xfrm>
-          <a:prstGeom prst="rect">
-            <a:avLst/>
-          </a:prstGeom>
-          <a:noFill/>
-          <a:ln/>
-        </p:spPr>
-        <p:txBody>
-          <a:bodyPr wrap="square" rtlCol="0" anchor="ctr"/>
-          <a:lstStyle/>
-          <a:p>
-            <a:pPr algn="ctr" indent="0" marL="0">
-              <a:lnSpc>
-                <a:spcPct val="100000"/>
-              </a:lnSpc>
-              <a:buNone/>
-            </a:pPr>
-            <a:r>
-              <a:rPr lang="en-US" sz="1100" dirty="0">
-                <a:solidFill>
-                  <a:srgbClr val="71838F"/>
-                </a:solidFill>
-                <a:latin typeface="Calibri" pitchFamily="34" charset="0"/>
-                <a:ea typeface="Calibri" pitchFamily="34" charset="-122"/>
-                <a:cs typeface="Calibri" pitchFamily="34" charset="-120"/>
-              </a:rPr>
-              <a:t>marked pending, observe first</a:t>
-            </a:r>
-            <a:endParaRPr lang="en-US" sz="1100" dirty="0"/>
-          </a:p>
-        </p:txBody>
-      </p:sp>
-      <p:pic>
-        <p:nvPicPr>
-          <p:cNvPr id="16" name="Image 3" descr="preencoded.png">    </p:cNvPr>
-          <p:cNvPicPr>
-            <a:picLocks noChangeAspect="1"/>
-          </p:cNvPicPr>
-          <p:nvPr/>
-        </p:nvPicPr>
-        <p:blipFill>
-          <a:blip r:embed="rId4"/>
-          <a:stretch>
-            <a:fillRect/>
-          </a:stretch>
-        </p:blipFill>
-        <p:spPr>
-          <a:xfrm>
-            <a:off x="5843016" y="3063240"/>
-            <a:ext cx="292608" cy="292608"/>
-          </a:xfrm>
-          <a:prstGeom prst="rect">
-            <a:avLst/>
-          </a:prstGeom>
-        </p:spPr>
-      </p:pic>
-      <p:sp>
-        <p:nvSpPr>
-          <p:cNvPr id="17" name="Shape 11"/>
-          <p:cNvSpPr/>
-          <p:nvPr/>
-        </p:nvSpPr>
-        <p:spPr>
-          <a:xfrm>
-            <a:off x="6126480" y="2286000"/>
-            <a:ext cx="2468880" cy="1828800"/>
-          </a:xfrm>
-          <a:prstGeom prst="roundRect">
-            <a:avLst>
-              <a:gd name="adj" fmla="val 6000"/>
-            </a:avLst>
-          </a:prstGeom>
-          <a:solidFill>
-            <a:srgbClr val="F4FAFB"/>
-          </a:solidFill>
-          <a:ln w="19050">
-            <a:solidFill>
-              <a:srgbClr val="5D8AA8"/>
-            </a:solidFill>
-            <a:prstDash val="solid"/>
-          </a:ln>
-        </p:spPr>
-      </p:sp>
-      <p:sp>
-        <p:nvSpPr>
-          <p:cNvPr id="18" name="Shape 12"/>
-          <p:cNvSpPr/>
-          <p:nvPr/>
-        </p:nvSpPr>
-        <p:spPr>
-          <a:xfrm>
-            <a:off x="7040880" y="2487168"/>
-            <a:ext cx="640080" cy="640080"/>
-          </a:xfrm>
-          <a:prstGeom prst="ellipse">
-            <a:avLst/>
-          </a:prstGeom>
-          <a:solidFill>
-            <a:srgbClr val="5D8AA8"/>
-          </a:solidFill>
-          <a:ln/>
-        </p:spPr>
-      </p:sp>
-      <p:pic>
-        <p:nvPicPr>
-          <p:cNvPr id="19" name="Image 4" descr="preencoded.png">    </p:cNvPr>
-          <p:cNvPicPr>
-            <a:picLocks noChangeAspect="1"/>
-          </p:cNvPicPr>
-          <p:nvPr/>
-        </p:nvPicPr>
-        <p:blipFill>
-          <a:blip r:embed="rId5"/>
-          <a:stretch>
-            <a:fillRect/>
-          </a:stretch>
-        </p:blipFill>
-        <p:spPr>
-          <a:xfrm>
-            <a:off x="7168896" y="2615184"/>
-            <a:ext cx="384048" cy="384048"/>
-          </a:xfrm>
-          <a:prstGeom prst="rect">
-            <a:avLst/>
-          </a:prstGeom>
-        </p:spPr>
-      </p:pic>
-      <p:sp>
-        <p:nvSpPr>
-          <p:cNvPr id="20" name="Text 13"/>
-          <p:cNvSpPr/>
-          <p:nvPr/>
-        </p:nvSpPr>
-        <p:spPr>
-          <a:xfrm>
-            <a:off x="6217920" y="3200400"/>
-            <a:ext cx="2286000" cy="411480"/>
-          </a:xfrm>
-          <a:prstGeom prst="rect">
-            <a:avLst/>
-          </a:prstGeom>
-          <a:noFill/>
-          <a:ln/>
-        </p:spPr>
-        <p:txBody>
-          <a:bodyPr wrap="square" rtlCol="0" anchor="ctr"/>
-          <a:lstStyle/>
-          <a:p>
-            <a:pPr algn="ctr" indent="0" marL="0">
-              <a:lnSpc>
-                <a:spcPct val="100000"/>
-              </a:lnSpc>
-              <a:buNone/>
-            </a:pPr>
-            <a:r>
-              <a:rPr lang="en-US" sz="1400" b="1" dirty="0">
-                <a:solidFill>
-                  <a:srgbClr val="17313F"/>
-                </a:solidFill>
-                <a:latin typeface="Calibri" pitchFamily="34" charset="0"/>
-                <a:ea typeface="Calibri" pitchFamily="34" charset="-122"/>
-                <a:cs typeface="Calibri" pitchFamily="34" charset="-120"/>
-              </a:rPr>
-              <a:t>Statistical Calibration</a:t>
-            </a:r>
-            <a:endParaRPr lang="en-US" sz="1400" dirty="0"/>
-          </a:p>
-        </p:txBody>
-      </p:sp>
-      <p:sp>
-        <p:nvSpPr>
-          <p:cNvPr id="21" name="Text 14"/>
-          <p:cNvSpPr/>
-          <p:nvPr/>
-        </p:nvSpPr>
-        <p:spPr>
-          <a:xfrm>
-            <a:off x="6236208" y="3639312"/>
-            <a:ext cx="2249424" cy="411480"/>
-          </a:xfrm>
-          <a:prstGeom prst="rect">
-            <a:avLst/>
-          </a:prstGeom>
-          <a:noFill/>
-          <a:ln/>
-        </p:spPr>
-        <p:txBody>
-          <a:bodyPr wrap="square" rtlCol="0" anchor="ctr"/>
-          <a:lstStyle/>
-          <a:p>
-            <a:pPr algn="ctr" indent="0" marL="0">
-              <a:lnSpc>
-                <a:spcPct val="100000"/>
-              </a:lnSpc>
-              <a:buNone/>
-            </a:pPr>
-            <a:r>
-              <a:rPr lang="en-US" sz="1100" dirty="0">
-                <a:solidFill>
-                  <a:srgbClr val="71838F"/>
-                </a:solidFill>
-                <a:latin typeface="Calibri" pitchFamily="34" charset="0"/>
-                <a:ea typeface="Calibri" pitchFamily="34" charset="-122"/>
-                <a:cs typeface="Calibri" pitchFamily="34" charset="-120"/>
-              </a:rPr>
-              <a:t>validated by real hit rate</a:t>
-            </a:r>
-            <a:endParaRPr lang="en-US" sz="1100" dirty="0"/>
-          </a:p>
-        </p:txBody>
-      </p:sp>
-      <p:pic>
-        <p:nvPicPr>
-          <p:cNvPr id="22" name="Image 5" descr="preencoded.png">    </p:cNvPr>
-          <p:cNvPicPr>
-            <a:picLocks noChangeAspect="1"/>
-          </p:cNvPicPr>
-          <p:nvPr/>
-        </p:nvPicPr>
-        <p:blipFill>
-          <a:blip r:embed="rId6"/>
-          <a:stretch>
-            <a:fillRect/>
-          </a:stretch>
-        </p:blipFill>
-        <p:spPr>
-          <a:xfrm>
-            <a:off x="8631936" y="3063240"/>
-            <a:ext cx="292608" cy="292608"/>
-          </a:xfrm>
-          <a:prstGeom prst="rect">
-            <a:avLst/>
-          </a:prstGeom>
-        </p:spPr>
-      </p:pic>
-      <p:sp>
-        <p:nvSpPr>
-          <p:cNvPr id="23" name="Shape 15"/>
-          <p:cNvSpPr/>
-          <p:nvPr/>
-        </p:nvSpPr>
-        <p:spPr>
-          <a:xfrm>
-            <a:off x="8915400" y="2286000"/>
-            <a:ext cx="2468880" cy="1828800"/>
-          </a:xfrm>
-          <a:prstGeom prst="roundRect">
-            <a:avLst>
-              <a:gd name="adj" fmla="val 6000"/>
-            </a:avLst>
-          </a:prstGeom>
-          <a:solidFill>
-            <a:srgbClr val="F4FAFB"/>
-          </a:solidFill>
-          <a:ln w="19050">
-            <a:solidFill>
-              <a:srgbClr val="22875A"/>
-            </a:solidFill>
-            <a:prstDash val="solid"/>
-          </a:ln>
-        </p:spPr>
-      </p:sp>
-      <p:sp>
-        <p:nvSpPr>
-          <p:cNvPr id="24" name="Shape 16"/>
-          <p:cNvSpPr/>
-          <p:nvPr/>
-        </p:nvSpPr>
-        <p:spPr>
-          <a:xfrm>
-            <a:off x="9829800" y="2487168"/>
-            <a:ext cx="640080" cy="640080"/>
-          </a:xfrm>
-          <a:prstGeom prst="ellipse">
-            <a:avLst/>
-          </a:prstGeom>
-          <a:solidFill>
-            <a:srgbClr val="22875A"/>
-          </a:solidFill>
-          <a:ln/>
-        </p:spPr>
-      </p:sp>
-      <p:pic>
-        <p:nvPicPr>
-          <p:cNvPr id="25" name="Image 6" descr="preencoded.png">    </p:cNvPr>
-          <p:cNvPicPr>
-            <a:picLocks noChangeAspect="1"/>
-          </p:cNvPicPr>
-          <p:nvPr/>
-        </p:nvPicPr>
-        <p:blipFill>
-          <a:blip r:embed="rId7"/>
-          <a:stretch>
-            <a:fillRect/>
-          </a:stretch>
-        </p:blipFill>
-        <p:spPr>
-          <a:xfrm>
-            <a:off x="9957816" y="2615184"/>
-            <a:ext cx="384048" cy="384048"/>
-          </a:xfrm>
-          <a:prstGeom prst="rect">
-            <a:avLst/>
-          </a:prstGeom>
-        </p:spPr>
-      </p:pic>
-      <p:sp>
-        <p:nvSpPr>
-          <p:cNvPr id="26" name="Text 17"/>
-          <p:cNvSpPr/>
-          <p:nvPr/>
-        </p:nvSpPr>
-        <p:spPr>
-          <a:xfrm>
-            <a:off x="9006840" y="3200400"/>
-            <a:ext cx="2286000" cy="411480"/>
-          </a:xfrm>
-          <a:prstGeom prst="rect">
-            <a:avLst/>
-          </a:prstGeom>
-          <a:noFill/>
-          <a:ln/>
-        </p:spPr>
-        <p:txBody>
-          <a:bodyPr wrap="square" rtlCol="0" anchor="ctr"/>
-          <a:lstStyle/>
-          <a:p>
-            <a:pPr algn="ctr" indent="0" marL="0">
-              <a:lnSpc>
-                <a:spcPct val="100000"/>
-              </a:lnSpc>
-              <a:buNone/>
-            </a:pPr>
-            <a:r>
-              <a:rPr lang="en-US" sz="1400" b="1" dirty="0">
-                <a:solidFill>
-                  <a:srgbClr val="17313F"/>
-                </a:solidFill>
-                <a:latin typeface="Calibri" pitchFamily="34" charset="0"/>
-                <a:ea typeface="Calibri" pitchFamily="34" charset="-122"/>
-                <a:cs typeface="Calibri" pitchFamily="34" charset="-120"/>
-              </a:rPr>
-              <a:t>Human Approval</a:t>
-            </a:r>
-            <a:endParaRPr lang="en-US" sz="1400" dirty="0"/>
-          </a:p>
-        </p:txBody>
-      </p:sp>
-      <p:sp>
-        <p:nvSpPr>
-          <p:cNvPr id="27" name="Text 18"/>
-          <p:cNvSpPr/>
-          <p:nvPr/>
-        </p:nvSpPr>
-        <p:spPr>
-          <a:xfrm>
-            <a:off x="9025128" y="3639312"/>
-            <a:ext cx="2249424" cy="411480"/>
-          </a:xfrm>
-          <a:prstGeom prst="rect">
-            <a:avLst/>
-          </a:prstGeom>
-          <a:noFill/>
-          <a:ln/>
-        </p:spPr>
-        <p:txBody>
-          <a:bodyPr wrap="square" rtlCol="0" anchor="ctr"/>
-          <a:lstStyle/>
-          <a:p>
-            <a:pPr algn="ctr" indent="0" marL="0">
-              <a:lnSpc>
-                <a:spcPct val="100000"/>
-              </a:lnSpc>
-              <a:buNone/>
-            </a:pPr>
-            <a:r>
-              <a:rPr lang="en-US" sz="1100" dirty="0">
-                <a:solidFill>
-                  <a:srgbClr val="71838F"/>
-                </a:solidFill>
-                <a:latin typeface="Calibri" pitchFamily="34" charset="0"/>
-                <a:ea typeface="Calibri" pitchFamily="34" charset="-122"/>
-                <a:cs typeface="Calibri" pitchFamily="34" charset="-120"/>
-              </a:rPr>
-              <a:t>live only after sign-off</a:t>
-            </a:r>
-            <a:endParaRPr lang="en-US" sz="1100" dirty="0"/>
-          </a:p>
-        </p:txBody>
-      </p:sp>
-      <p:sp>
-        <p:nvSpPr>
-          <p:cNvPr id="28" name="Shape 19"/>
-          <p:cNvSpPr/>
-          <p:nvPr/>
-        </p:nvSpPr>
-        <p:spPr>
-          <a:xfrm>
-            <a:off x="548640" y="4526280"/>
-            <a:ext cx="11091672" cy="1188720"/>
-          </a:xfrm>
-          <a:prstGeom prst="roundRect">
-            <a:avLst>
-              <a:gd name="adj" fmla="val 9231"/>
-            </a:avLst>
-          </a:prstGeom>
-          <a:solidFill>
-            <a:srgbClr val="FFF6E8"/>
-          </a:solidFill>
-          <a:ln w="15240">
-            <a:solidFill>
-              <a:srgbClr val="F0D8A8"/>
-            </a:solidFill>
-            <a:prstDash val="solid"/>
-          </a:ln>
-        </p:spPr>
-      </p:sp>
-      <p:pic>
-        <p:nvPicPr>
-          <p:cNvPr id="29" name="Image 7" descr="preencoded.png">    </p:cNvPr>
-          <p:cNvPicPr>
-            <a:picLocks noChangeAspect="1"/>
-          </p:cNvPicPr>
-          <p:nvPr/>
-        </p:nvPicPr>
-        <p:blipFill>
-          <a:blip r:embed="rId8"/>
-          <a:stretch>
-            <a:fillRect/>
-          </a:stretch>
-        </p:blipFill>
-        <p:spPr>
-          <a:xfrm>
-            <a:off x="868680" y="4864608"/>
-            <a:ext cx="457200" cy="457200"/>
-          </a:xfrm>
-          <a:prstGeom prst="rect">
-            <a:avLst/>
-          </a:prstGeom>
-        </p:spPr>
-      </p:pic>
-      <p:sp>
-        <p:nvSpPr>
-          <p:cNvPr id="30" name="Text 20"/>
-          <p:cNvSpPr/>
-          <p:nvPr/>
-        </p:nvSpPr>
-        <p:spPr>
-          <a:xfrm>
-            <a:off x="1508760" y="4617720"/>
-            <a:ext cx="9921240" cy="1005840"/>
+              <a:t>Signal Ledger + Calibration</a:t>
+            </a:r>
+            <a:endParaRPr lang="en-US" sz="1700" dirty="0"/>
+          </a:p>
+        </p:txBody>
+      </p:sp>
+      <p:sp>
+        <p:nvSpPr>
+          <p:cNvPr id="21" name="Text 16"/>
+          <p:cNvSpPr/>
+          <p:nvPr/>
+        </p:nvSpPr>
+        <p:spPr>
+          <a:xfrm>
+            <a:off x="8421624" y="4297680"/>
+            <a:ext cx="2971800" cy="1188720"/>
           </a:xfrm>
           <a:prstGeom prst="rect">
             <a:avLst/>
@@ -6260,45 +6650,28 @@
           <a:p>
             <a:pPr indent="0" marL="0">
               <a:lnSpc>
-                <a:spcPct val="120000"/>
+                <a:spcPct val="122000"/>
               </a:lnSpc>
               <a:buNone/>
             </a:pPr>
             <a:r>
-              <a:rPr lang="en-US" sz="1350" b="1" dirty="0">
-                <a:solidFill>
-                  <a:srgbClr val="C9861A"/>
-                </a:solidFill>
-                <a:latin typeface="Calibri" pitchFamily="34" charset="0"/>
-                <a:ea typeface="Calibri" pitchFamily="34" charset="-122"/>
-                <a:cs typeface="Calibri" pitchFamily="34" charset="-120"/>
-              </a:rPr>
-              <a:t>Compliance bottom line: </a:t>
-            </a:r>
-            <a:pPr indent="0" marL="0">
-              <a:lnSpc>
-                <a:spcPct val="120000"/>
-              </a:lnSpc>
-              <a:buNone/>
-            </a:pPr>
-            <a:r>
-              <a:rPr lang="en-US" sz="1350" dirty="0">
-                <a:solidFill>
-                  <a:srgbClr val="17313F"/>
-                </a:solidFill>
-                <a:latin typeface="Calibri" pitchFamily="34" charset="0"/>
-                <a:ea typeface="Calibri" pitchFamily="34" charset="-122"/>
-                <a:cs typeface="Calibri" pitchFamily="34" charset="-120"/>
-              </a:rPr>
-              <a:t>self-evolution may only propose hypotheses — never silently change alert tiers. Any change affecting tiering must pass auditable statistical calibration + human approval.</a:t>
-            </a:r>
-            <a:endParaRPr lang="en-US" sz="1350" dirty="0"/>
-          </a:p>
-        </p:txBody>
-      </p:sp>
-      <p:sp>
-        <p:nvSpPr>
-          <p:cNvPr id="31" name="Text 21"/>
+              <a:rPr lang="en-US" sz="1250" dirty="0">
+                <a:solidFill>
+                  <a:srgbClr val="71838F"/>
+                </a:solidFill>
+                <a:latin typeface="Calibri" pitchFamily="34" charset="0"/>
+                <a:ea typeface="Calibri" pitchFamily="34" charset="-122"/>
+                <a:cs typeface="Calibri" pitchFamily="34" charset="-120"/>
+              </a:rPr>
+              <a:t>Each signal is promoted / demoted by its real hit rate, not gut feel; every change is auditable.</a:t>
+            </a:r>
+            <a:endParaRPr lang="en-US" sz="1250" dirty="0"/>
+          </a:p>
+        </p:txBody>
+      </p:sp>
+      <p:sp>
+        <p:nvSpPr>
+          <p:cNvPr id="22" name="Text 17"/>
           <p:cNvSpPr/>
           <p:nvPr/>
         </p:nvSpPr>
@@ -6337,7 +6710,7 @@
       </p:sp>
       <p:sp>
         <p:nvSpPr>
-          <p:cNvPr id="32" name="Text 22"/>
+          <p:cNvPr id="23" name="Text 18"/>
           <p:cNvSpPr/>
           <p:nvPr/>
         </p:nvSpPr>
@@ -6385,6 +6758,1035 @@
 <file path=ppt/slides/slide7.xml><?xml version="1.0" encoding="utf-8"?>
 <p:sld xmlns:a="http://schemas.openxmlformats.org/drawingml/2006/main" xmlns:r="http://schemas.openxmlformats.org/officeDocument/2006/relationships" xmlns:p="http://schemas.openxmlformats.org/presentationml/2006/main">
   <p:cSld name="Slide 7">
+    <p:bg>
+      <p:bgPr>
+        <a:solidFill>
+          <a:srgbClr val="FFFFFF"/>
+        </a:solidFill>
+      </p:bgPr>
+    </p:bg>
+    <p:spTree>
+      <p:nvGrpSpPr>
+        <p:cNvPr id="1" name=""/>
+        <p:cNvGrpSpPr/>
+        <p:nvPr/>
+      </p:nvGrpSpPr>
+      <p:grpSpPr>
+        <a:xfrm>
+          <a:off x="0" y="0"/>
+          <a:ext cx="0" cy="0"/>
+          <a:chOff x="0" y="0"/>
+          <a:chExt cx="0" cy="0"/>
+        </a:xfrm>
+      </p:grpSpPr>
+      <p:sp>
+        <p:nvSpPr>
+          <p:cNvPr id="2" name="Text 0"/>
+          <p:cNvSpPr/>
+          <p:nvPr/>
+        </p:nvSpPr>
+        <p:spPr>
+          <a:xfrm>
+            <a:off x="548640" y="457200"/>
+            <a:ext cx="9144000" cy="274320"/>
+          </a:xfrm>
+          <a:prstGeom prst="rect">
+            <a:avLst/>
+          </a:prstGeom>
+          <a:noFill/>
+          <a:ln/>
+        </p:spPr>
+        <p:txBody>
+          <a:bodyPr wrap="square" rtlCol="0" anchor="ctr"/>
+          <a:lstStyle/>
+          <a:p>
+            <a:pPr indent="0" marL="0">
+              <a:buNone/>
+            </a:pPr>
+            <a:r>
+              <a:rPr lang="en-US" sz="1200" b="1" spc="200" kern="0" dirty="0">
+                <a:solidFill>
+                  <a:srgbClr val="1BA39C"/>
+                </a:solidFill>
+                <a:latin typeface="Calibri" pitchFamily="34" charset="0"/>
+                <a:ea typeface="Calibri" pitchFamily="34" charset="-122"/>
+                <a:cs typeface="Calibri" pitchFamily="34" charset="-120"/>
+              </a:rPr>
+              <a:t>SPOTLIGHT · SELF-EVOLUTION (HERMES AGENT)</a:t>
+            </a:r>
+            <a:endParaRPr lang="en-US" sz="1200" dirty="0"/>
+          </a:p>
+        </p:txBody>
+      </p:sp>
+      <p:sp>
+        <p:nvSpPr>
+          <p:cNvPr id="3" name="Text 1"/>
+          <p:cNvSpPr/>
+          <p:nvPr/>
+        </p:nvSpPr>
+        <p:spPr>
+          <a:xfrm>
+            <a:off x="548640" y="749808"/>
+            <a:ext cx="11064240" cy="822960"/>
+          </a:xfrm>
+          <a:prstGeom prst="rect">
+            <a:avLst/>
+          </a:prstGeom>
+          <a:noFill/>
+          <a:ln/>
+        </p:spPr>
+        <p:txBody>
+          <a:bodyPr wrap="square" rtlCol="0" anchor="ctr"/>
+          <a:lstStyle/>
+          <a:p>
+            <a:pPr indent="0" marL="0">
+              <a:buNone/>
+            </a:pPr>
+            <a:r>
+              <a:rPr lang="en-US" sz="3000" b="1" dirty="0">
+                <a:solidFill>
+                  <a:srgbClr val="17313F"/>
+                </a:solidFill>
+                <a:latin typeface="Calibri" pitchFamily="34" charset="0"/>
+                <a:ea typeface="Calibri" pitchFamily="34" charset="-122"/>
+                <a:cs typeface="Calibri" pitchFamily="34" charset="-120"/>
+              </a:rPr>
+              <a:t>The system discovers new risks — but tiering stays gated</a:t>
+            </a:r>
+            <a:endParaRPr lang="en-US" sz="3000" dirty="0"/>
+          </a:p>
+        </p:txBody>
+      </p:sp>
+      <p:sp>
+        <p:nvSpPr>
+          <p:cNvPr id="4" name="Text 2"/>
+          <p:cNvSpPr/>
+          <p:nvPr/>
+        </p:nvSpPr>
+        <p:spPr>
+          <a:xfrm>
+            <a:off x="548640" y="1600200"/>
+            <a:ext cx="10972800" cy="457200"/>
+          </a:xfrm>
+          <a:prstGeom prst="rect">
+            <a:avLst/>
+          </a:prstGeom>
+          <a:noFill/>
+          <a:ln/>
+        </p:spPr>
+        <p:txBody>
+          <a:bodyPr wrap="square" rtlCol="0" anchor="ctr"/>
+          <a:lstStyle/>
+          <a:p>
+            <a:pPr indent="0" marL="0">
+              <a:buNone/>
+            </a:pPr>
+            <a:r>
+              <a:rPr lang="en-US" sz="1400" dirty="0">
+                <a:solidFill>
+                  <a:srgbClr val="71838F"/>
+                </a:solidFill>
+                <a:latin typeface="Calibri" pitchFamily="34" charset="0"/>
+                <a:ea typeface="Calibri" pitchFamily="34" charset="-122"/>
+                <a:cs typeface="Calibri" pitchFamily="34" charset="-120"/>
+              </a:rPr>
+              <a:t>Signals used to be predefined by Legal from experience; now the agent proposes new hypotheses from accumulated cases.</a:t>
+            </a:r>
+            <a:endParaRPr lang="en-US" sz="1400" dirty="0"/>
+          </a:p>
+        </p:txBody>
+      </p:sp>
+      <p:sp>
+        <p:nvSpPr>
+          <p:cNvPr id="5" name="Shape 3"/>
+          <p:cNvSpPr/>
+          <p:nvPr/>
+        </p:nvSpPr>
+        <p:spPr>
+          <a:xfrm>
+            <a:off x="548640" y="2286000"/>
+            <a:ext cx="2468880" cy="1828800"/>
+          </a:xfrm>
+          <a:prstGeom prst="roundRect">
+            <a:avLst>
+              <a:gd name="adj" fmla="val 6000"/>
+            </a:avLst>
+          </a:prstGeom>
+          <a:solidFill>
+            <a:srgbClr val="F4FAFB"/>
+          </a:solidFill>
+          <a:ln w="19050">
+            <a:solidFill>
+              <a:srgbClr val="1BA39C"/>
+            </a:solidFill>
+            <a:prstDash val="solid"/>
+          </a:ln>
+        </p:spPr>
+      </p:sp>
+      <p:sp>
+        <p:nvSpPr>
+          <p:cNvPr id="6" name="Shape 4"/>
+          <p:cNvSpPr/>
+          <p:nvPr/>
+        </p:nvSpPr>
+        <p:spPr>
+          <a:xfrm>
+            <a:off x="1463040" y="2487168"/>
+            <a:ext cx="640080" cy="640080"/>
+          </a:xfrm>
+          <a:prstGeom prst="ellipse">
+            <a:avLst/>
+          </a:prstGeom>
+          <a:solidFill>
+            <a:srgbClr val="1BA39C"/>
+          </a:solidFill>
+          <a:ln/>
+        </p:spPr>
+      </p:sp>
+      <p:pic>
+        <p:nvPicPr>
+          <p:cNvPr id="7" name="Image 0" descr="preencoded.png">    </p:cNvPr>
+          <p:cNvPicPr>
+            <a:picLocks noChangeAspect="1"/>
+          </p:cNvPicPr>
+          <p:nvPr/>
+        </p:nvPicPr>
+        <p:blipFill>
+          <a:blip r:embed="rId1"/>
+          <a:stretch>
+            <a:fillRect/>
+          </a:stretch>
+        </p:blipFill>
+        <p:spPr>
+          <a:xfrm>
+            <a:off x="1591056" y="2615184"/>
+            <a:ext cx="384048" cy="384048"/>
+          </a:xfrm>
+          <a:prstGeom prst="rect">
+            <a:avLst/>
+          </a:prstGeom>
+        </p:spPr>
+      </p:pic>
+      <p:sp>
+        <p:nvSpPr>
+          <p:cNvPr id="8" name="Text 5"/>
+          <p:cNvSpPr/>
+          <p:nvPr/>
+        </p:nvSpPr>
+        <p:spPr>
+          <a:xfrm>
+            <a:off x="640080" y="3200400"/>
+            <a:ext cx="2286000" cy="411480"/>
+          </a:xfrm>
+          <a:prstGeom prst="rect">
+            <a:avLst/>
+          </a:prstGeom>
+          <a:noFill/>
+          <a:ln/>
+        </p:spPr>
+        <p:txBody>
+          <a:bodyPr wrap="square" rtlCol="0" anchor="ctr"/>
+          <a:lstStyle/>
+          <a:p>
+            <a:pPr algn="ctr" indent="0" marL="0">
+              <a:lnSpc>
+                <a:spcPct val="100000"/>
+              </a:lnSpc>
+              <a:buNone/>
+            </a:pPr>
+            <a:r>
+              <a:rPr lang="en-US" sz="1400" b="1" dirty="0">
+                <a:solidFill>
+                  <a:srgbClr val="17313F"/>
+                </a:solidFill>
+                <a:latin typeface="Calibri" pitchFamily="34" charset="0"/>
+                <a:ea typeface="Calibri" pitchFamily="34" charset="-122"/>
+                <a:cs typeface="Calibri" pitchFamily="34" charset="-120"/>
+              </a:rPr>
+              <a:t>Agent Discovers</a:t>
+            </a:r>
+            <a:endParaRPr lang="en-US" sz="1400" dirty="0"/>
+          </a:p>
+        </p:txBody>
+      </p:sp>
+      <p:sp>
+        <p:nvSpPr>
+          <p:cNvPr id="9" name="Text 6"/>
+          <p:cNvSpPr/>
+          <p:nvPr/>
+        </p:nvSpPr>
+        <p:spPr>
+          <a:xfrm>
+            <a:off x="658368" y="3639312"/>
+            <a:ext cx="2249424" cy="411480"/>
+          </a:xfrm>
+          <a:prstGeom prst="rect">
+            <a:avLst/>
+          </a:prstGeom>
+          <a:noFill/>
+          <a:ln/>
+        </p:spPr>
+        <p:txBody>
+          <a:bodyPr wrap="square" rtlCol="0" anchor="ctr"/>
+          <a:lstStyle/>
+          <a:p>
+            <a:pPr algn="ctr" indent="0" marL="0">
+              <a:lnSpc>
+                <a:spcPct val="100000"/>
+              </a:lnSpc>
+              <a:buNone/>
+            </a:pPr>
+            <a:r>
+              <a:rPr lang="en-US" sz="1100" dirty="0">
+                <a:solidFill>
+                  <a:srgbClr val="71838F"/>
+                </a:solidFill>
+                <a:latin typeface="Calibri" pitchFamily="34" charset="0"/>
+                <a:ea typeface="Calibri" pitchFamily="34" charset="-122"/>
+                <a:cs typeface="Calibri" pitchFamily="34" charset="-120"/>
+              </a:rPr>
+              <a:t>learns recurring new patterns</a:t>
+            </a:r>
+            <a:endParaRPr lang="en-US" sz="1100" dirty="0"/>
+          </a:p>
+        </p:txBody>
+      </p:sp>
+      <p:pic>
+        <p:nvPicPr>
+          <p:cNvPr id="10" name="Image 1" descr="preencoded.png">    </p:cNvPr>
+          <p:cNvPicPr>
+            <a:picLocks noChangeAspect="1"/>
+          </p:cNvPicPr>
+          <p:nvPr/>
+        </p:nvPicPr>
+        <p:blipFill>
+          <a:blip r:embed="rId2"/>
+          <a:stretch>
+            <a:fillRect/>
+          </a:stretch>
+        </p:blipFill>
+        <p:spPr>
+          <a:xfrm>
+            <a:off x="3054096" y="3063240"/>
+            <a:ext cx="292608" cy="292608"/>
+          </a:xfrm>
+          <a:prstGeom prst="rect">
+            <a:avLst/>
+          </a:prstGeom>
+        </p:spPr>
+      </p:pic>
+      <p:sp>
+        <p:nvSpPr>
+          <p:cNvPr id="11" name="Shape 7"/>
+          <p:cNvSpPr/>
+          <p:nvPr/>
+        </p:nvSpPr>
+        <p:spPr>
+          <a:xfrm>
+            <a:off x="3337560" y="2286000"/>
+            <a:ext cx="2468880" cy="1828800"/>
+          </a:xfrm>
+          <a:prstGeom prst="roundRect">
+            <a:avLst>
+              <a:gd name="adj" fmla="val 6000"/>
+            </a:avLst>
+          </a:prstGeom>
+          <a:solidFill>
+            <a:srgbClr val="F4FAFB"/>
+          </a:solidFill>
+          <a:ln w="19050">
+            <a:solidFill>
+              <a:srgbClr val="C9861A"/>
+            </a:solidFill>
+            <a:prstDash val="solid"/>
+          </a:ln>
+        </p:spPr>
+      </p:sp>
+      <p:sp>
+        <p:nvSpPr>
+          <p:cNvPr id="12" name="Shape 8"/>
+          <p:cNvSpPr/>
+          <p:nvPr/>
+        </p:nvSpPr>
+        <p:spPr>
+          <a:xfrm>
+            <a:off x="4251960" y="2487168"/>
+            <a:ext cx="640080" cy="640080"/>
+          </a:xfrm>
+          <a:prstGeom prst="ellipse">
+            <a:avLst/>
+          </a:prstGeom>
+          <a:solidFill>
+            <a:srgbClr val="C9861A"/>
+          </a:solidFill>
+          <a:ln/>
+        </p:spPr>
+      </p:sp>
+      <p:pic>
+        <p:nvPicPr>
+          <p:cNvPr id="13" name="Image 2" descr="preencoded.png">    </p:cNvPr>
+          <p:cNvPicPr>
+            <a:picLocks noChangeAspect="1"/>
+          </p:cNvPicPr>
+          <p:nvPr/>
+        </p:nvPicPr>
+        <p:blipFill>
+          <a:blip r:embed="rId3"/>
+          <a:stretch>
+            <a:fillRect/>
+          </a:stretch>
+        </p:blipFill>
+        <p:spPr>
+          <a:xfrm>
+            <a:off x="4379976" y="2615184"/>
+            <a:ext cx="384048" cy="384048"/>
+          </a:xfrm>
+          <a:prstGeom prst="rect">
+            <a:avLst/>
+          </a:prstGeom>
+        </p:spPr>
+      </p:pic>
+      <p:sp>
+        <p:nvSpPr>
+          <p:cNvPr id="14" name="Text 9"/>
+          <p:cNvSpPr/>
+          <p:nvPr/>
+        </p:nvSpPr>
+        <p:spPr>
+          <a:xfrm>
+            <a:off x="3429000" y="3200400"/>
+            <a:ext cx="2286000" cy="411480"/>
+          </a:xfrm>
+          <a:prstGeom prst="rect">
+            <a:avLst/>
+          </a:prstGeom>
+          <a:noFill/>
+          <a:ln/>
+        </p:spPr>
+        <p:txBody>
+          <a:bodyPr wrap="square" rtlCol="0" anchor="ctr"/>
+          <a:lstStyle/>
+          <a:p>
+            <a:pPr algn="ctr" indent="0" marL="0">
+              <a:lnSpc>
+                <a:spcPct val="100000"/>
+              </a:lnSpc>
+              <a:buNone/>
+            </a:pPr>
+            <a:r>
+              <a:rPr lang="en-US" sz="1400" b="1" dirty="0">
+                <a:solidFill>
+                  <a:srgbClr val="17313F"/>
+                </a:solidFill>
+                <a:latin typeface="Calibri" pitchFamily="34" charset="0"/>
+                <a:ea typeface="Calibri" pitchFamily="34" charset="-122"/>
+                <a:cs typeface="Calibri" pitchFamily="34" charset="-120"/>
+              </a:rPr>
+              <a:t>Enters Candidacy</a:t>
+            </a:r>
+            <a:endParaRPr lang="en-US" sz="1400" dirty="0"/>
+          </a:p>
+        </p:txBody>
+      </p:sp>
+      <p:sp>
+        <p:nvSpPr>
+          <p:cNvPr id="15" name="Text 10"/>
+          <p:cNvSpPr/>
+          <p:nvPr/>
+        </p:nvSpPr>
+        <p:spPr>
+          <a:xfrm>
+            <a:off x="3447288" y="3639312"/>
+            <a:ext cx="2249424" cy="411480"/>
+          </a:xfrm>
+          <a:prstGeom prst="rect">
+            <a:avLst/>
+          </a:prstGeom>
+          <a:noFill/>
+          <a:ln/>
+        </p:spPr>
+        <p:txBody>
+          <a:bodyPr wrap="square" rtlCol="0" anchor="ctr"/>
+          <a:lstStyle/>
+          <a:p>
+            <a:pPr algn="ctr" indent="0" marL="0">
+              <a:lnSpc>
+                <a:spcPct val="100000"/>
+              </a:lnSpc>
+              <a:buNone/>
+            </a:pPr>
+            <a:r>
+              <a:rPr lang="en-US" sz="1100" dirty="0">
+                <a:solidFill>
+                  <a:srgbClr val="71838F"/>
+                </a:solidFill>
+                <a:latin typeface="Calibri" pitchFamily="34" charset="0"/>
+                <a:ea typeface="Calibri" pitchFamily="34" charset="-122"/>
+                <a:cs typeface="Calibri" pitchFamily="34" charset="-120"/>
+              </a:rPr>
+              <a:t>marked pending, observe first</a:t>
+            </a:r>
+            <a:endParaRPr lang="en-US" sz="1100" dirty="0"/>
+          </a:p>
+        </p:txBody>
+      </p:sp>
+      <p:pic>
+        <p:nvPicPr>
+          <p:cNvPr id="16" name="Image 3" descr="preencoded.png">    </p:cNvPr>
+          <p:cNvPicPr>
+            <a:picLocks noChangeAspect="1"/>
+          </p:cNvPicPr>
+          <p:nvPr/>
+        </p:nvPicPr>
+        <p:blipFill>
+          <a:blip r:embed="rId4"/>
+          <a:stretch>
+            <a:fillRect/>
+          </a:stretch>
+        </p:blipFill>
+        <p:spPr>
+          <a:xfrm>
+            <a:off x="5843016" y="3063240"/>
+            <a:ext cx="292608" cy="292608"/>
+          </a:xfrm>
+          <a:prstGeom prst="rect">
+            <a:avLst/>
+          </a:prstGeom>
+        </p:spPr>
+      </p:pic>
+      <p:sp>
+        <p:nvSpPr>
+          <p:cNvPr id="17" name="Shape 11"/>
+          <p:cNvSpPr/>
+          <p:nvPr/>
+        </p:nvSpPr>
+        <p:spPr>
+          <a:xfrm>
+            <a:off x="6126480" y="2286000"/>
+            <a:ext cx="2468880" cy="1828800"/>
+          </a:xfrm>
+          <a:prstGeom prst="roundRect">
+            <a:avLst>
+              <a:gd name="adj" fmla="val 6000"/>
+            </a:avLst>
+          </a:prstGeom>
+          <a:solidFill>
+            <a:srgbClr val="F4FAFB"/>
+          </a:solidFill>
+          <a:ln w="19050">
+            <a:solidFill>
+              <a:srgbClr val="5D8AA8"/>
+            </a:solidFill>
+            <a:prstDash val="solid"/>
+          </a:ln>
+        </p:spPr>
+      </p:sp>
+      <p:sp>
+        <p:nvSpPr>
+          <p:cNvPr id="18" name="Shape 12"/>
+          <p:cNvSpPr/>
+          <p:nvPr/>
+        </p:nvSpPr>
+        <p:spPr>
+          <a:xfrm>
+            <a:off x="7040880" y="2487168"/>
+            <a:ext cx="640080" cy="640080"/>
+          </a:xfrm>
+          <a:prstGeom prst="ellipse">
+            <a:avLst/>
+          </a:prstGeom>
+          <a:solidFill>
+            <a:srgbClr val="5D8AA8"/>
+          </a:solidFill>
+          <a:ln/>
+        </p:spPr>
+      </p:sp>
+      <p:pic>
+        <p:nvPicPr>
+          <p:cNvPr id="19" name="Image 4" descr="preencoded.png">    </p:cNvPr>
+          <p:cNvPicPr>
+            <a:picLocks noChangeAspect="1"/>
+          </p:cNvPicPr>
+          <p:nvPr/>
+        </p:nvPicPr>
+        <p:blipFill>
+          <a:blip r:embed="rId5"/>
+          <a:stretch>
+            <a:fillRect/>
+          </a:stretch>
+        </p:blipFill>
+        <p:spPr>
+          <a:xfrm>
+            <a:off x="7168896" y="2615184"/>
+            <a:ext cx="384048" cy="384048"/>
+          </a:xfrm>
+          <a:prstGeom prst="rect">
+            <a:avLst/>
+          </a:prstGeom>
+        </p:spPr>
+      </p:pic>
+      <p:sp>
+        <p:nvSpPr>
+          <p:cNvPr id="20" name="Text 13"/>
+          <p:cNvSpPr/>
+          <p:nvPr/>
+        </p:nvSpPr>
+        <p:spPr>
+          <a:xfrm>
+            <a:off x="6217920" y="3200400"/>
+            <a:ext cx="2286000" cy="411480"/>
+          </a:xfrm>
+          <a:prstGeom prst="rect">
+            <a:avLst/>
+          </a:prstGeom>
+          <a:noFill/>
+          <a:ln/>
+        </p:spPr>
+        <p:txBody>
+          <a:bodyPr wrap="square" rtlCol="0" anchor="ctr"/>
+          <a:lstStyle/>
+          <a:p>
+            <a:pPr algn="ctr" indent="0" marL="0">
+              <a:lnSpc>
+                <a:spcPct val="100000"/>
+              </a:lnSpc>
+              <a:buNone/>
+            </a:pPr>
+            <a:r>
+              <a:rPr lang="en-US" sz="1400" b="1" dirty="0">
+                <a:solidFill>
+                  <a:srgbClr val="17313F"/>
+                </a:solidFill>
+                <a:latin typeface="Calibri" pitchFamily="34" charset="0"/>
+                <a:ea typeface="Calibri" pitchFamily="34" charset="-122"/>
+                <a:cs typeface="Calibri" pitchFamily="34" charset="-120"/>
+              </a:rPr>
+              <a:t>Statistical Calibration</a:t>
+            </a:r>
+            <a:endParaRPr lang="en-US" sz="1400" dirty="0"/>
+          </a:p>
+        </p:txBody>
+      </p:sp>
+      <p:sp>
+        <p:nvSpPr>
+          <p:cNvPr id="21" name="Text 14"/>
+          <p:cNvSpPr/>
+          <p:nvPr/>
+        </p:nvSpPr>
+        <p:spPr>
+          <a:xfrm>
+            <a:off x="6236208" y="3639312"/>
+            <a:ext cx="2249424" cy="411480"/>
+          </a:xfrm>
+          <a:prstGeom prst="rect">
+            <a:avLst/>
+          </a:prstGeom>
+          <a:noFill/>
+          <a:ln/>
+        </p:spPr>
+        <p:txBody>
+          <a:bodyPr wrap="square" rtlCol="0" anchor="ctr"/>
+          <a:lstStyle/>
+          <a:p>
+            <a:pPr algn="ctr" indent="0" marL="0">
+              <a:lnSpc>
+                <a:spcPct val="100000"/>
+              </a:lnSpc>
+              <a:buNone/>
+            </a:pPr>
+            <a:r>
+              <a:rPr lang="en-US" sz="1100" dirty="0">
+                <a:solidFill>
+                  <a:srgbClr val="71838F"/>
+                </a:solidFill>
+                <a:latin typeface="Calibri" pitchFamily="34" charset="0"/>
+                <a:ea typeface="Calibri" pitchFamily="34" charset="-122"/>
+                <a:cs typeface="Calibri" pitchFamily="34" charset="-120"/>
+              </a:rPr>
+              <a:t>validated by real hit rate</a:t>
+            </a:r>
+            <a:endParaRPr lang="en-US" sz="1100" dirty="0"/>
+          </a:p>
+        </p:txBody>
+      </p:sp>
+      <p:pic>
+        <p:nvPicPr>
+          <p:cNvPr id="22" name="Image 5" descr="preencoded.png">    </p:cNvPr>
+          <p:cNvPicPr>
+            <a:picLocks noChangeAspect="1"/>
+          </p:cNvPicPr>
+          <p:nvPr/>
+        </p:nvPicPr>
+        <p:blipFill>
+          <a:blip r:embed="rId6"/>
+          <a:stretch>
+            <a:fillRect/>
+          </a:stretch>
+        </p:blipFill>
+        <p:spPr>
+          <a:xfrm>
+            <a:off x="8631936" y="3063240"/>
+            <a:ext cx="292608" cy="292608"/>
+          </a:xfrm>
+          <a:prstGeom prst="rect">
+            <a:avLst/>
+          </a:prstGeom>
+        </p:spPr>
+      </p:pic>
+      <p:sp>
+        <p:nvSpPr>
+          <p:cNvPr id="23" name="Shape 15"/>
+          <p:cNvSpPr/>
+          <p:nvPr/>
+        </p:nvSpPr>
+        <p:spPr>
+          <a:xfrm>
+            <a:off x="8915400" y="2286000"/>
+            <a:ext cx="2468880" cy="1828800"/>
+          </a:xfrm>
+          <a:prstGeom prst="roundRect">
+            <a:avLst>
+              <a:gd name="adj" fmla="val 6000"/>
+            </a:avLst>
+          </a:prstGeom>
+          <a:solidFill>
+            <a:srgbClr val="F4FAFB"/>
+          </a:solidFill>
+          <a:ln w="19050">
+            <a:solidFill>
+              <a:srgbClr val="22875A"/>
+            </a:solidFill>
+            <a:prstDash val="solid"/>
+          </a:ln>
+        </p:spPr>
+      </p:sp>
+      <p:sp>
+        <p:nvSpPr>
+          <p:cNvPr id="24" name="Shape 16"/>
+          <p:cNvSpPr/>
+          <p:nvPr/>
+        </p:nvSpPr>
+        <p:spPr>
+          <a:xfrm>
+            <a:off x="9829800" y="2487168"/>
+            <a:ext cx="640080" cy="640080"/>
+          </a:xfrm>
+          <a:prstGeom prst="ellipse">
+            <a:avLst/>
+          </a:prstGeom>
+          <a:solidFill>
+            <a:srgbClr val="22875A"/>
+          </a:solidFill>
+          <a:ln/>
+        </p:spPr>
+      </p:sp>
+      <p:pic>
+        <p:nvPicPr>
+          <p:cNvPr id="25" name="Image 6" descr="preencoded.png">    </p:cNvPr>
+          <p:cNvPicPr>
+            <a:picLocks noChangeAspect="1"/>
+          </p:cNvPicPr>
+          <p:nvPr/>
+        </p:nvPicPr>
+        <p:blipFill>
+          <a:blip r:embed="rId7"/>
+          <a:stretch>
+            <a:fillRect/>
+          </a:stretch>
+        </p:blipFill>
+        <p:spPr>
+          <a:xfrm>
+            <a:off x="9957816" y="2615184"/>
+            <a:ext cx="384048" cy="384048"/>
+          </a:xfrm>
+          <a:prstGeom prst="rect">
+            <a:avLst/>
+          </a:prstGeom>
+        </p:spPr>
+      </p:pic>
+      <p:sp>
+        <p:nvSpPr>
+          <p:cNvPr id="26" name="Text 17"/>
+          <p:cNvSpPr/>
+          <p:nvPr/>
+        </p:nvSpPr>
+        <p:spPr>
+          <a:xfrm>
+            <a:off x="9006840" y="3200400"/>
+            <a:ext cx="2286000" cy="411480"/>
+          </a:xfrm>
+          <a:prstGeom prst="rect">
+            <a:avLst/>
+          </a:prstGeom>
+          <a:noFill/>
+          <a:ln/>
+        </p:spPr>
+        <p:txBody>
+          <a:bodyPr wrap="square" rtlCol="0" anchor="ctr"/>
+          <a:lstStyle/>
+          <a:p>
+            <a:pPr algn="ctr" indent="0" marL="0">
+              <a:lnSpc>
+                <a:spcPct val="100000"/>
+              </a:lnSpc>
+              <a:buNone/>
+            </a:pPr>
+            <a:r>
+              <a:rPr lang="en-US" sz="1400" b="1" dirty="0">
+                <a:solidFill>
+                  <a:srgbClr val="17313F"/>
+                </a:solidFill>
+                <a:latin typeface="Calibri" pitchFamily="34" charset="0"/>
+                <a:ea typeface="Calibri" pitchFamily="34" charset="-122"/>
+                <a:cs typeface="Calibri" pitchFamily="34" charset="-120"/>
+              </a:rPr>
+              <a:t>Human Approval</a:t>
+            </a:r>
+            <a:endParaRPr lang="en-US" sz="1400" dirty="0"/>
+          </a:p>
+        </p:txBody>
+      </p:sp>
+      <p:sp>
+        <p:nvSpPr>
+          <p:cNvPr id="27" name="Text 18"/>
+          <p:cNvSpPr/>
+          <p:nvPr/>
+        </p:nvSpPr>
+        <p:spPr>
+          <a:xfrm>
+            <a:off x="9025128" y="3639312"/>
+            <a:ext cx="2249424" cy="411480"/>
+          </a:xfrm>
+          <a:prstGeom prst="rect">
+            <a:avLst/>
+          </a:prstGeom>
+          <a:noFill/>
+          <a:ln/>
+        </p:spPr>
+        <p:txBody>
+          <a:bodyPr wrap="square" rtlCol="0" anchor="ctr"/>
+          <a:lstStyle/>
+          <a:p>
+            <a:pPr algn="ctr" indent="0" marL="0">
+              <a:lnSpc>
+                <a:spcPct val="100000"/>
+              </a:lnSpc>
+              <a:buNone/>
+            </a:pPr>
+            <a:r>
+              <a:rPr lang="en-US" sz="1100" dirty="0">
+                <a:solidFill>
+                  <a:srgbClr val="71838F"/>
+                </a:solidFill>
+                <a:latin typeface="Calibri" pitchFamily="34" charset="0"/>
+                <a:ea typeface="Calibri" pitchFamily="34" charset="-122"/>
+                <a:cs typeface="Calibri" pitchFamily="34" charset="-120"/>
+              </a:rPr>
+              <a:t>live only after sign-off</a:t>
+            </a:r>
+            <a:endParaRPr lang="en-US" sz="1100" dirty="0"/>
+          </a:p>
+        </p:txBody>
+      </p:sp>
+      <p:sp>
+        <p:nvSpPr>
+          <p:cNvPr id="28" name="Shape 19"/>
+          <p:cNvSpPr/>
+          <p:nvPr/>
+        </p:nvSpPr>
+        <p:spPr>
+          <a:xfrm>
+            <a:off x="548640" y="4526280"/>
+            <a:ext cx="11091672" cy="1188720"/>
+          </a:xfrm>
+          <a:prstGeom prst="roundRect">
+            <a:avLst>
+              <a:gd name="adj" fmla="val 9231"/>
+            </a:avLst>
+          </a:prstGeom>
+          <a:solidFill>
+            <a:srgbClr val="FFF6E8"/>
+          </a:solidFill>
+          <a:ln w="15240">
+            <a:solidFill>
+              <a:srgbClr val="F0D8A8"/>
+            </a:solidFill>
+            <a:prstDash val="solid"/>
+          </a:ln>
+        </p:spPr>
+      </p:sp>
+      <p:pic>
+        <p:nvPicPr>
+          <p:cNvPr id="29" name="Image 7" descr="preencoded.png">    </p:cNvPr>
+          <p:cNvPicPr>
+            <a:picLocks noChangeAspect="1"/>
+          </p:cNvPicPr>
+          <p:nvPr/>
+        </p:nvPicPr>
+        <p:blipFill>
+          <a:blip r:embed="rId8"/>
+          <a:stretch>
+            <a:fillRect/>
+          </a:stretch>
+        </p:blipFill>
+        <p:spPr>
+          <a:xfrm>
+            <a:off x="868680" y="4864608"/>
+            <a:ext cx="457200" cy="457200"/>
+          </a:xfrm>
+          <a:prstGeom prst="rect">
+            <a:avLst/>
+          </a:prstGeom>
+        </p:spPr>
+      </p:pic>
+      <p:sp>
+        <p:nvSpPr>
+          <p:cNvPr id="30" name="Text 20"/>
+          <p:cNvSpPr/>
+          <p:nvPr/>
+        </p:nvSpPr>
+        <p:spPr>
+          <a:xfrm>
+            <a:off x="1508760" y="4617720"/>
+            <a:ext cx="9921240" cy="1005840"/>
+          </a:xfrm>
+          <a:prstGeom prst="rect">
+            <a:avLst/>
+          </a:prstGeom>
+          <a:noFill/>
+          <a:ln/>
+        </p:spPr>
+        <p:txBody>
+          <a:bodyPr wrap="square" rtlCol="0" anchor="ctr"/>
+          <a:lstStyle/>
+          <a:p>
+            <a:pPr indent="0" marL="0">
+              <a:lnSpc>
+                <a:spcPct val="120000"/>
+              </a:lnSpc>
+              <a:buNone/>
+            </a:pPr>
+            <a:r>
+              <a:rPr lang="en-US" sz="1350" b="1" dirty="0">
+                <a:solidFill>
+                  <a:srgbClr val="C9861A"/>
+                </a:solidFill>
+                <a:latin typeface="Calibri" pitchFamily="34" charset="0"/>
+                <a:ea typeface="Calibri" pitchFamily="34" charset="-122"/>
+                <a:cs typeface="Calibri" pitchFamily="34" charset="-120"/>
+              </a:rPr>
+              <a:t>Compliance bottom line: </a:t>
+            </a:r>
+            <a:pPr indent="0" marL="0">
+              <a:lnSpc>
+                <a:spcPct val="120000"/>
+              </a:lnSpc>
+              <a:buNone/>
+            </a:pPr>
+            <a:r>
+              <a:rPr lang="en-US" sz="1350" dirty="0">
+                <a:solidFill>
+                  <a:srgbClr val="17313F"/>
+                </a:solidFill>
+                <a:latin typeface="Calibri" pitchFamily="34" charset="0"/>
+                <a:ea typeface="Calibri" pitchFamily="34" charset="-122"/>
+                <a:cs typeface="Calibri" pitchFamily="34" charset="-120"/>
+              </a:rPr>
+              <a:t>self-evolution may only propose hypotheses — never silently change alert tiers. Any change affecting tiering must pass auditable statistical calibration + human approval.</a:t>
+            </a:r>
+            <a:endParaRPr lang="en-US" sz="1350" dirty="0"/>
+          </a:p>
+        </p:txBody>
+      </p:sp>
+      <p:sp>
+        <p:nvSpPr>
+          <p:cNvPr id="31" name="Text 21"/>
+          <p:cNvSpPr/>
+          <p:nvPr/>
+        </p:nvSpPr>
+        <p:spPr>
+          <a:xfrm>
+            <a:off x="11368735" y="6400800"/>
+            <a:ext cx="457200" cy="274320"/>
+          </a:xfrm>
+          <a:prstGeom prst="rect">
+            <a:avLst/>
+          </a:prstGeom>
+          <a:noFill/>
+          <a:ln/>
+        </p:spPr>
+        <p:txBody>
+          <a:bodyPr wrap="square" rtlCol="0" anchor="ctr"/>
+          <a:lstStyle/>
+          <a:p>
+            <a:pPr algn="r" indent="0" marL="0">
+              <a:buNone/>
+            </a:pPr>
+            <a:r>
+              <a:rPr lang="en-US" sz="1000" dirty="0">
+                <a:solidFill>
+                  <a:srgbClr val="71838F"/>
+                </a:solidFill>
+                <a:latin typeface="Calibri" pitchFamily="34" charset="0"/>
+                <a:ea typeface="Calibri" pitchFamily="34" charset="-122"/>
+                <a:cs typeface="Calibri" pitchFamily="34" charset="-120"/>
+              </a:rPr>
+              <a:t>07</a:t>
+            </a:r>
+            <a:endParaRPr lang="en-US" sz="1000" dirty="0"/>
+          </a:p>
+        </p:txBody>
+      </p:sp>
+      <p:sp>
+        <p:nvSpPr>
+          <p:cNvPr id="32" name="Text 22"/>
+          <p:cNvSpPr/>
+          <p:nvPr/>
+        </p:nvSpPr>
+        <p:spPr>
+          <a:xfrm>
+            <a:off x="548640" y="6400800"/>
+            <a:ext cx="5486400" cy="274320"/>
+          </a:xfrm>
+          <a:prstGeom prst="rect">
+            <a:avLst/>
+          </a:prstGeom>
+          <a:noFill/>
+          <a:ln/>
+        </p:spPr>
+        <p:txBody>
+          <a:bodyPr wrap="square" rtlCol="0" anchor="ctr"/>
+          <a:lstStyle/>
+          <a:p>
+            <a:pPr indent="0" marL="0">
+              <a:buNone/>
+            </a:pPr>
+            <a:r>
+              <a:rPr lang="en-US" sz="900" dirty="0">
+                <a:solidFill>
+                  <a:srgbClr val="71838F"/>
+                </a:solidFill>
+                <a:latin typeface="Calibri" pitchFamily="34" charset="0"/>
+                <a:ea typeface="Calibri" pitchFamily="34" charset="-122"/>
+                <a:cs typeface="Calibri" pitchFamily="34" charset="-120"/>
+              </a:rPr>
+              <a:t>AML Payment Risk Identification System</a:t>
+            </a:r>
+            <a:endParaRPr lang="en-US" sz="900" dirty="0"/>
+          </a:p>
+        </p:txBody>
+      </p:sp>
+    </p:spTree>
+  </p:cSld>
+  <p:clrMapOvr>
+    <a:masterClrMapping/>
+  </p:clrMapOvr>
+</p:sld>
+</file>
+
+<file path=ppt/slides/slide8.xml><?xml version="1.0" encoding="utf-8"?>
+<p:sld xmlns:a="http://schemas.openxmlformats.org/drawingml/2006/main" xmlns:r="http://schemas.openxmlformats.org/officeDocument/2006/relationships" xmlns:p="http://schemas.openxmlformats.org/presentationml/2006/main">
+  <p:cSld name="Slide 8">
     <p:bg>
       <p:bgPr>
         <a:solidFill>

</xml_diff>

<commit_message>
Redo flow slide as a true flowchart (diamonds + arrows)
Replace the card-strip with a proper flowchart: process boxes
(Payments In → Detect+Tier → AI Investigation → Evolve & Learn),
two decision diamonds (Tier level? / Money laundering?), connector
arrows with branch labels (T1/T2, T3 → batch rank; Yes/No → recorded),
and a dashed feedback loop back into Detect+Tier.

Co-Authored-By: Claude Opus 4.8 (1M context) <noreply@anthropic.com>
</commit_message>
<xml_diff>
--- a/ppt/AML-System-Walkthrough-Legal-EN.pptx
+++ b/ppt/AML-System-Walkthrough-Legal-EN.pptx
@@ -4761,12 +4761,12 @@
         </p:nvSpPr>
         <p:spPr>
           <a:xfrm>
-            <a:off x="548640" y="2286000"/>
-            <a:ext cx="1965960" cy="2331720"/>
+            <a:off x="457200" y="2148840"/>
+            <a:ext cx="1554480" cy="914400"/>
           </a:xfrm>
           <a:prstGeom prst="roundRect">
             <a:avLst>
-              <a:gd name="adj" fmla="val 5581"/>
+              <a:gd name="adj" fmla="val 10000"/>
             </a:avLst>
           </a:prstGeom>
           <a:solidFill>
@@ -4789,97 +4789,14 @@
       </p:sp>
       <p:sp>
         <p:nvSpPr>
-          <p:cNvPr id="5" name="Shape 3"/>
-          <p:cNvSpPr/>
-          <p:nvPr/>
-        </p:nvSpPr>
-        <p:spPr>
-          <a:xfrm>
-            <a:off x="1143000" y="2542032"/>
-            <a:ext cx="777240" cy="777240"/>
-          </a:xfrm>
-          <a:prstGeom prst="ellipse">
-            <a:avLst/>
-          </a:prstGeom>
-          <a:solidFill>
-            <a:srgbClr val="1BA39C"/>
-          </a:solidFill>
-          <a:ln/>
-        </p:spPr>
-      </p:sp>
-      <p:pic>
-        <p:nvPicPr>
-          <p:cNvPr id="6" name="Image 0" descr="preencoded.png">    </p:cNvPr>
-          <p:cNvPicPr>
-            <a:picLocks noChangeAspect="1"/>
-          </p:cNvPicPr>
-          <p:nvPr/>
-        </p:nvPicPr>
-        <p:blipFill>
-          <a:blip r:embed="rId1"/>
-          <a:stretch>
-            <a:fillRect/>
-          </a:stretch>
-        </p:blipFill>
-        <p:spPr>
-          <a:xfrm>
-            <a:off x="1335024" y="2734056"/>
-            <a:ext cx="393192" cy="393192"/>
-          </a:xfrm>
-          <a:prstGeom prst="rect">
-            <a:avLst/>
-          </a:prstGeom>
-        </p:spPr>
-      </p:pic>
-      <p:sp>
-        <p:nvSpPr>
-          <p:cNvPr id="7" name="Text 4"/>
-          <p:cNvSpPr/>
-          <p:nvPr/>
-        </p:nvSpPr>
-        <p:spPr>
-          <a:xfrm>
-            <a:off x="640080" y="3456432"/>
-            <a:ext cx="1783080" cy="365760"/>
-          </a:xfrm>
-          <a:prstGeom prst="rect">
-            <a:avLst/>
-          </a:prstGeom>
-          <a:noFill/>
-          <a:ln/>
-        </p:spPr>
-        <p:txBody>
-          <a:bodyPr wrap="square" rtlCol="0" anchor="ctr"/>
-          <a:lstStyle/>
-          <a:p>
-            <a:pPr algn="ctr" indent="0" marL="0">
-              <a:buNone/>
-            </a:pPr>
-            <a:r>
-              <a:rPr lang="en-US" sz="1400" b="1" dirty="0">
-                <a:solidFill>
-                  <a:srgbClr val="17313F"/>
-                </a:solidFill>
-                <a:latin typeface="Calibri" pitchFamily="34" charset="0"/>
-                <a:ea typeface="Calibri" pitchFamily="34" charset="-122"/>
-                <a:cs typeface="Calibri" pitchFamily="34" charset="-120"/>
-              </a:rPr>
-              <a:t>1. Payments In</a:t>
-            </a:r>
-            <a:endParaRPr lang="en-US" sz="1400" dirty="0"/>
-          </a:p>
-        </p:txBody>
-      </p:sp>
-      <p:sp>
-        <p:nvSpPr>
-          <p:cNvPr id="8" name="Text 5"/>
-          <p:cNvSpPr/>
-          <p:nvPr/>
-        </p:nvSpPr>
-        <p:spPr>
-          <a:xfrm>
-            <a:off x="640080" y="3858768"/>
-            <a:ext cx="1783080" cy="640080"/>
+          <p:cNvPr id="5" name="Text 3"/>
+          <p:cNvSpPr/>
+          <p:nvPr/>
+        </p:nvSpPr>
+        <p:spPr>
+          <a:xfrm>
+            <a:off x="512064" y="2148840"/>
+            <a:ext cx="1444752" cy="914400"/>
           </a:xfrm>
           <a:prstGeom prst="rect">
             <a:avLst/>
@@ -4898,17 +4815,17 @@
               <a:buNone/>
             </a:pPr>
             <a:r>
-              <a:rPr lang="en-US" sz="1050" dirty="0">
-                <a:solidFill>
-                  <a:srgbClr val="71838F"/>
-                </a:solidFill>
-                <a:latin typeface="Calibri" pitchFamily="34" charset="0"/>
-                <a:ea typeface="Calibri" pitchFamily="34" charset="-122"/>
-                <a:cs typeface="Calibri" pitchFamily="34" charset="-120"/>
-              </a:rPr>
-              <a:t>~10K/day</a:t>
-            </a:r>
-            <a:endParaRPr lang="en-US" sz="1050" dirty="0"/>
+              <a:rPr lang="en-US" sz="1350" b="1" dirty="0">
+                <a:solidFill>
+                  <a:srgbClr val="17313F"/>
+                </a:solidFill>
+                <a:latin typeface="Calibri" pitchFamily="34" charset="0"/>
+                <a:ea typeface="Calibri" pitchFamily="34" charset="-122"/>
+                <a:cs typeface="Calibri" pitchFamily="34" charset="-120"/>
+              </a:rPr>
+              <a:t>Payments In</a:t>
+            </a:r>
+            <a:endParaRPr lang="en-US" sz="1350" dirty="0"/>
           </a:p>
           <a:p>
             <a:pPr algn="ctr" indent="0" marL="0">
@@ -4926,50 +4843,50 @@
                 <a:ea typeface="Calibri" pitchFamily="34" charset="-122"/>
                 <a:cs typeface="Calibri" pitchFamily="34" charset="-120"/>
               </a:rPr>
-              <a:t>Ariba · LGAP · S4</a:t>
-            </a:r>
-            <a:endParaRPr lang="en-US" sz="1050" dirty="0"/>
-          </a:p>
-        </p:txBody>
-      </p:sp>
-      <p:pic>
-        <p:nvPicPr>
-          <p:cNvPr id="9" name="Image 1" descr="preencoded.png">    </p:cNvPr>
-          <p:cNvPicPr>
-            <a:picLocks noChangeAspect="1"/>
-          </p:cNvPicPr>
-          <p:nvPr/>
-        </p:nvPicPr>
-        <p:blipFill>
-          <a:blip r:embed="rId2"/>
-          <a:stretch>
-            <a:fillRect/>
-          </a:stretch>
-        </p:blipFill>
-        <p:spPr>
-          <a:xfrm>
-            <a:off x="2551176" y="3323844"/>
-            <a:ext cx="256032" cy="256032"/>
-          </a:xfrm>
-          <a:prstGeom prst="rect">
-            <a:avLst/>
-          </a:prstGeom>
-        </p:spPr>
-      </p:pic>
-      <p:sp>
-        <p:nvSpPr>
-          <p:cNvPr id="10" name="Shape 6"/>
-          <p:cNvSpPr/>
-          <p:nvPr/>
-        </p:nvSpPr>
-        <p:spPr>
-          <a:xfrm>
-            <a:off x="2830068" y="2286000"/>
-            <a:ext cx="1965960" cy="2331720"/>
+              <a:t>~10K / day</a:t>
+            </a:r>
+            <a:endParaRPr lang="en-US" sz="1350" dirty="0"/>
+          </a:p>
+        </p:txBody>
+      </p:sp>
+      <p:sp>
+        <p:nvSpPr>
+          <p:cNvPr id="6" name="Shape 4"/>
+          <p:cNvSpPr/>
+          <p:nvPr/>
+        </p:nvSpPr>
+        <p:spPr>
+          <a:xfrm>
+            <a:off x="2011680" y="2606040"/>
+            <a:ext cx="274320" cy="0"/>
+          </a:xfrm>
+          <a:prstGeom prst="line">
+            <a:avLst/>
+          </a:prstGeom>
+          <a:noFill/>
+          <a:ln w="22225">
+            <a:solidFill>
+              <a:srgbClr val="9FB6C0"/>
+            </a:solidFill>
+            <a:prstDash val="solid"/>
+            <a:tailEnd type="triangle"/>
+          </a:ln>
+        </p:spPr>
+      </p:sp>
+      <p:sp>
+        <p:nvSpPr>
+          <p:cNvPr id="7" name="Shape 5"/>
+          <p:cNvSpPr/>
+          <p:nvPr/>
+        </p:nvSpPr>
+        <p:spPr>
+          <a:xfrm>
+            <a:off x="2286000" y="2148840"/>
+            <a:ext cx="1691640" cy="914400"/>
           </a:xfrm>
           <a:prstGeom prst="roundRect">
             <a:avLst>
-              <a:gd name="adj" fmla="val 5581"/>
+              <a:gd name="adj" fmla="val 10000"/>
             </a:avLst>
           </a:prstGeom>
           <a:solidFill>
@@ -4992,97 +4909,14 @@
       </p:sp>
       <p:sp>
         <p:nvSpPr>
-          <p:cNvPr id="11" name="Shape 7"/>
-          <p:cNvSpPr/>
-          <p:nvPr/>
-        </p:nvSpPr>
-        <p:spPr>
-          <a:xfrm>
-            <a:off x="3424428" y="2542032"/>
-            <a:ext cx="777240" cy="777240"/>
-          </a:xfrm>
-          <a:prstGeom prst="ellipse">
-            <a:avLst/>
-          </a:prstGeom>
-          <a:solidFill>
-            <a:srgbClr val="1BA39C"/>
-          </a:solidFill>
-          <a:ln/>
-        </p:spPr>
-      </p:sp>
-      <p:pic>
-        <p:nvPicPr>
-          <p:cNvPr id="12" name="Image 2" descr="preencoded.png">    </p:cNvPr>
-          <p:cNvPicPr>
-            <a:picLocks noChangeAspect="1"/>
-          </p:cNvPicPr>
-          <p:nvPr/>
-        </p:nvPicPr>
-        <p:blipFill>
-          <a:blip r:embed="rId3"/>
-          <a:stretch>
-            <a:fillRect/>
-          </a:stretch>
-        </p:blipFill>
-        <p:spPr>
-          <a:xfrm>
-            <a:off x="3616452" y="2734056"/>
-            <a:ext cx="393192" cy="393192"/>
-          </a:xfrm>
-          <a:prstGeom prst="rect">
-            <a:avLst/>
-          </a:prstGeom>
-        </p:spPr>
-      </p:pic>
-      <p:sp>
-        <p:nvSpPr>
-          <p:cNvPr id="13" name="Text 8"/>
-          <p:cNvSpPr/>
-          <p:nvPr/>
-        </p:nvSpPr>
-        <p:spPr>
-          <a:xfrm>
-            <a:off x="2921508" y="3456432"/>
-            <a:ext cx="1783080" cy="365760"/>
-          </a:xfrm>
-          <a:prstGeom prst="rect">
-            <a:avLst/>
-          </a:prstGeom>
-          <a:noFill/>
-          <a:ln/>
-        </p:spPr>
-        <p:txBody>
-          <a:bodyPr wrap="square" rtlCol="0" anchor="ctr"/>
-          <a:lstStyle/>
-          <a:p>
-            <a:pPr algn="ctr" indent="0" marL="0">
-              <a:buNone/>
-            </a:pPr>
-            <a:r>
-              <a:rPr lang="en-US" sz="1400" b="1" dirty="0">
-                <a:solidFill>
-                  <a:srgbClr val="17313F"/>
-                </a:solidFill>
-                <a:latin typeface="Calibri" pitchFamily="34" charset="0"/>
-                <a:ea typeface="Calibri" pitchFamily="34" charset="-122"/>
-                <a:cs typeface="Calibri" pitchFamily="34" charset="-120"/>
-              </a:rPr>
-              <a:t>2. Detect + Tier</a:t>
-            </a:r>
-            <a:endParaRPr lang="en-US" sz="1400" dirty="0"/>
-          </a:p>
-        </p:txBody>
-      </p:sp>
-      <p:sp>
-        <p:nvSpPr>
-          <p:cNvPr id="14" name="Text 9"/>
-          <p:cNvSpPr/>
-          <p:nvPr/>
-        </p:nvSpPr>
-        <p:spPr>
-          <a:xfrm>
-            <a:off x="2921508" y="3858768"/>
-            <a:ext cx="1783080" cy="640080"/>
+          <p:cNvPr id="8" name="Text 6"/>
+          <p:cNvSpPr/>
+          <p:nvPr/>
+        </p:nvSpPr>
+        <p:spPr>
+          <a:xfrm>
+            <a:off x="2340864" y="2148840"/>
+            <a:ext cx="1581912" cy="914400"/>
           </a:xfrm>
           <a:prstGeom prst="rect">
             <a:avLst/>
@@ -5101,17 +4935,17 @@
               <a:buNone/>
             </a:pPr>
             <a:r>
-              <a:rPr lang="en-US" sz="1050" dirty="0">
-                <a:solidFill>
-                  <a:srgbClr val="71838F"/>
-                </a:solidFill>
-                <a:latin typeface="Calibri" pitchFamily="34" charset="0"/>
-                <a:ea typeface="Calibri" pitchFamily="34" charset="-122"/>
-                <a:cs typeface="Calibri" pitchFamily="34" charset="-120"/>
-              </a:rPr>
-              <a:t>Dual entry →</a:t>
-            </a:r>
-            <a:endParaRPr lang="en-US" sz="1050" dirty="0"/>
+              <a:rPr lang="en-US" sz="1350" b="1" dirty="0">
+                <a:solidFill>
+                  <a:srgbClr val="17313F"/>
+                </a:solidFill>
+                <a:latin typeface="Calibri" pitchFamily="34" charset="0"/>
+                <a:ea typeface="Calibri" pitchFamily="34" charset="-122"/>
+                <a:cs typeface="Calibri" pitchFamily="34" charset="-120"/>
+              </a:rPr>
+              <a:t>Detect + Tier</a:t>
+            </a:r>
+            <a:endParaRPr lang="en-US" sz="1350" dirty="0"/>
           </a:p>
           <a:p>
             <a:pPr algn="ctr" indent="0" marL="0">
@@ -5129,50 +4963,194 @@
                 <a:ea typeface="Calibri" pitchFamily="34" charset="-122"/>
                 <a:cs typeface="Calibri" pitchFamily="34" charset="-120"/>
               </a:rPr>
-              <a:t>T1 / T2 / T3</a:t>
-            </a:r>
-            <a:endParaRPr lang="en-US" sz="1050" dirty="0"/>
-          </a:p>
-        </p:txBody>
-      </p:sp>
-      <p:pic>
-        <p:nvPicPr>
-          <p:cNvPr id="15" name="Image 3" descr="preencoded.png">    </p:cNvPr>
-          <p:cNvPicPr>
-            <a:picLocks noChangeAspect="1"/>
-          </p:cNvPicPr>
-          <p:nvPr/>
-        </p:nvPicPr>
-        <p:blipFill>
-          <a:blip r:embed="rId4"/>
-          <a:stretch>
-            <a:fillRect/>
-          </a:stretch>
-        </p:blipFill>
-        <p:spPr>
-          <a:xfrm>
-            <a:off x="4832604" y="3323844"/>
-            <a:ext cx="256032" cy="256032"/>
-          </a:xfrm>
-          <a:prstGeom prst="rect">
-            <a:avLst/>
-          </a:prstGeom>
-        </p:spPr>
-      </p:pic>
-      <p:sp>
-        <p:nvSpPr>
-          <p:cNvPr id="16" name="Shape 10"/>
-          <p:cNvSpPr/>
-          <p:nvPr/>
-        </p:nvSpPr>
-        <p:spPr>
-          <a:xfrm>
-            <a:off x="5111496" y="2286000"/>
-            <a:ext cx="1965960" cy="2331720"/>
+              <a:t>dual entry</a:t>
+            </a:r>
+            <a:endParaRPr lang="en-US" sz="1350" dirty="0"/>
+          </a:p>
+        </p:txBody>
+      </p:sp>
+      <p:sp>
+        <p:nvSpPr>
+          <p:cNvPr id="9" name="Shape 7"/>
+          <p:cNvSpPr/>
+          <p:nvPr/>
+        </p:nvSpPr>
+        <p:spPr>
+          <a:xfrm>
+            <a:off x="3977640" y="2606040"/>
+            <a:ext cx="246888" cy="0"/>
+          </a:xfrm>
+          <a:prstGeom prst="line">
+            <a:avLst/>
+          </a:prstGeom>
+          <a:noFill/>
+          <a:ln w="22225">
+            <a:solidFill>
+              <a:srgbClr val="9FB6C0"/>
+            </a:solidFill>
+            <a:prstDash val="solid"/>
+            <a:tailEnd type="triangle"/>
+          </a:ln>
+        </p:spPr>
+      </p:sp>
+      <p:sp>
+        <p:nvSpPr>
+          <p:cNvPr id="10" name="Shape 8"/>
+          <p:cNvSpPr/>
+          <p:nvPr/>
+        </p:nvSpPr>
+        <p:spPr>
+          <a:xfrm>
+            <a:off x="4274820" y="1988820"/>
+            <a:ext cx="1417320" cy="1234440"/>
+          </a:xfrm>
+          <a:prstGeom prst="diamond">
+            <a:avLst/>
+          </a:prstGeom>
+          <a:solidFill>
+            <a:srgbClr val="FFF6E8"/>
+          </a:solidFill>
+          <a:ln w="19050">
+            <a:solidFill>
+              <a:srgbClr val="C9861A"/>
+            </a:solidFill>
+            <a:prstDash val="solid"/>
+          </a:ln>
+        </p:spPr>
+      </p:sp>
+      <p:sp>
+        <p:nvSpPr>
+          <p:cNvPr id="11" name="Text 9"/>
+          <p:cNvSpPr/>
+          <p:nvPr/>
+        </p:nvSpPr>
+        <p:spPr>
+          <a:xfrm>
+            <a:off x="4274820" y="1988820"/>
+            <a:ext cx="1417320" cy="1234440"/>
+          </a:xfrm>
+          <a:prstGeom prst="rect">
+            <a:avLst/>
+          </a:prstGeom>
+          <a:noFill/>
+          <a:ln/>
+        </p:spPr>
+        <p:txBody>
+          <a:bodyPr wrap="square" rtlCol="0" anchor="ctr"/>
+          <a:lstStyle/>
+          <a:p>
+            <a:pPr algn="ctr" indent="0" marL="0">
+              <a:buNone/>
+            </a:pPr>
+            <a:r>
+              <a:rPr lang="en-US" sz="1150" b="1" dirty="0">
+                <a:solidFill>
+                  <a:srgbClr val="8A6115"/>
+                </a:solidFill>
+                <a:latin typeface="Calibri" pitchFamily="34" charset="0"/>
+                <a:ea typeface="Calibri" pitchFamily="34" charset="-122"/>
+                <a:cs typeface="Calibri" pitchFamily="34" charset="-120"/>
+              </a:rPr>
+              <a:t>Tier</a:t>
+            </a:r>
+            <a:endParaRPr lang="en-US" sz="1150" dirty="0"/>
+          </a:p>
+          <a:p>
+            <a:pPr algn="ctr" indent="0" marL="0">
+              <a:buNone/>
+            </a:pPr>
+            <a:r>
+              <a:rPr lang="en-US" sz="1150" b="1" dirty="0">
+                <a:solidFill>
+                  <a:srgbClr val="8A6115"/>
+                </a:solidFill>
+                <a:latin typeface="Calibri" pitchFamily="34" charset="0"/>
+                <a:ea typeface="Calibri" pitchFamily="34" charset="-122"/>
+                <a:cs typeface="Calibri" pitchFamily="34" charset="-120"/>
+              </a:rPr>
+              <a:t>level?</a:t>
+            </a:r>
+            <a:endParaRPr lang="en-US" sz="1150" dirty="0"/>
+          </a:p>
+        </p:txBody>
+      </p:sp>
+      <p:sp>
+        <p:nvSpPr>
+          <p:cNvPr id="12" name="Shape 10"/>
+          <p:cNvSpPr/>
+          <p:nvPr/>
+        </p:nvSpPr>
+        <p:spPr>
+          <a:xfrm>
+            <a:off x="5696712" y="2606040"/>
+            <a:ext cx="292608" cy="0"/>
+          </a:xfrm>
+          <a:prstGeom prst="line">
+            <a:avLst/>
+          </a:prstGeom>
+          <a:noFill/>
+          <a:ln w="22225">
+            <a:solidFill>
+              <a:srgbClr val="9FB6C0"/>
+            </a:solidFill>
+            <a:prstDash val="solid"/>
+            <a:tailEnd type="triangle"/>
+          </a:ln>
+        </p:spPr>
+      </p:sp>
+      <p:sp>
+        <p:nvSpPr>
+          <p:cNvPr id="13" name="Text 11"/>
+          <p:cNvSpPr/>
+          <p:nvPr/>
+        </p:nvSpPr>
+        <p:spPr>
+          <a:xfrm>
+            <a:off x="5440680" y="1828800"/>
+            <a:ext cx="822960" cy="256032"/>
+          </a:xfrm>
+          <a:prstGeom prst="rect">
+            <a:avLst/>
+          </a:prstGeom>
+          <a:noFill/>
+          <a:ln/>
+        </p:spPr>
+        <p:txBody>
+          <a:bodyPr wrap="square" rtlCol="0" anchor="ctr"/>
+          <a:lstStyle/>
+          <a:p>
+            <a:pPr algn="ctr" indent="0" marL="0">
+              <a:buNone/>
+            </a:pPr>
+            <a:r>
+              <a:rPr lang="en-US" sz="950" b="1" dirty="0">
+                <a:solidFill>
+                  <a:srgbClr val="D84B4B"/>
+                </a:solidFill>
+                <a:latin typeface="Calibri" pitchFamily="34" charset="0"/>
+                <a:ea typeface="Calibri" pitchFamily="34" charset="-122"/>
+                <a:cs typeface="Calibri" pitchFamily="34" charset="-120"/>
+              </a:rPr>
+              <a:t>T1 / T2</a:t>
+            </a:r>
+            <a:endParaRPr lang="en-US" sz="950" dirty="0"/>
+          </a:p>
+        </p:txBody>
+      </p:sp>
+      <p:sp>
+        <p:nvSpPr>
+          <p:cNvPr id="14" name="Shape 12"/>
+          <p:cNvSpPr/>
+          <p:nvPr/>
+        </p:nvSpPr>
+        <p:spPr>
+          <a:xfrm>
+            <a:off x="5989320" y="2148840"/>
+            <a:ext cx="1691640" cy="914400"/>
           </a:xfrm>
           <a:prstGeom prst="roundRect">
             <a:avLst>
-              <a:gd name="adj" fmla="val 5581"/>
+              <a:gd name="adj" fmla="val 10000"/>
             </a:avLst>
           </a:prstGeom>
           <a:solidFill>
@@ -5195,97 +5173,14 @@
       </p:sp>
       <p:sp>
         <p:nvSpPr>
-          <p:cNvPr id="17" name="Shape 11"/>
-          <p:cNvSpPr/>
-          <p:nvPr/>
-        </p:nvSpPr>
-        <p:spPr>
-          <a:xfrm>
-            <a:off x="5705856" y="2542032"/>
-            <a:ext cx="777240" cy="777240"/>
-          </a:xfrm>
-          <a:prstGeom prst="ellipse">
-            <a:avLst/>
-          </a:prstGeom>
-          <a:solidFill>
-            <a:srgbClr val="1BA39C"/>
-          </a:solidFill>
-          <a:ln/>
-        </p:spPr>
-      </p:sp>
-      <p:pic>
-        <p:nvPicPr>
-          <p:cNvPr id="18" name="Image 4" descr="preencoded.png">    </p:cNvPr>
-          <p:cNvPicPr>
-            <a:picLocks noChangeAspect="1"/>
-          </p:cNvPicPr>
-          <p:nvPr/>
-        </p:nvPicPr>
-        <p:blipFill>
-          <a:blip r:embed="rId5"/>
-          <a:stretch>
-            <a:fillRect/>
-          </a:stretch>
-        </p:blipFill>
-        <p:spPr>
-          <a:xfrm>
-            <a:off x="5897880" y="2734056"/>
-            <a:ext cx="393192" cy="393192"/>
-          </a:xfrm>
-          <a:prstGeom prst="rect">
-            <a:avLst/>
-          </a:prstGeom>
-        </p:spPr>
-      </p:pic>
-      <p:sp>
-        <p:nvSpPr>
-          <p:cNvPr id="19" name="Text 12"/>
-          <p:cNvSpPr/>
-          <p:nvPr/>
-        </p:nvSpPr>
-        <p:spPr>
-          <a:xfrm>
-            <a:off x="5202936" y="3456432"/>
-            <a:ext cx="1783080" cy="365760"/>
-          </a:xfrm>
-          <a:prstGeom prst="rect">
-            <a:avLst/>
-          </a:prstGeom>
-          <a:noFill/>
-          <a:ln/>
-        </p:spPr>
-        <p:txBody>
-          <a:bodyPr wrap="square" rtlCol="0" anchor="ctr"/>
-          <a:lstStyle/>
-          <a:p>
-            <a:pPr algn="ctr" indent="0" marL="0">
-              <a:buNone/>
-            </a:pPr>
-            <a:r>
-              <a:rPr lang="en-US" sz="1400" b="1" dirty="0">
-                <a:solidFill>
-                  <a:srgbClr val="17313F"/>
-                </a:solidFill>
-                <a:latin typeface="Calibri" pitchFamily="34" charset="0"/>
-                <a:ea typeface="Calibri" pitchFamily="34" charset="-122"/>
-                <a:cs typeface="Calibri" pitchFamily="34" charset="-120"/>
-              </a:rPr>
-              <a:t>3. Investigate</a:t>
-            </a:r>
-            <a:endParaRPr lang="en-US" sz="1400" dirty="0"/>
-          </a:p>
-        </p:txBody>
-      </p:sp>
-      <p:sp>
-        <p:nvSpPr>
-          <p:cNvPr id="20" name="Text 13"/>
-          <p:cNvSpPr/>
-          <p:nvPr/>
-        </p:nvSpPr>
-        <p:spPr>
-          <a:xfrm>
-            <a:off x="5202936" y="3858768"/>
-            <a:ext cx="1783080" cy="640080"/>
+          <p:cNvPr id="15" name="Text 13"/>
+          <p:cNvSpPr/>
+          <p:nvPr/>
+        </p:nvSpPr>
+        <p:spPr>
+          <a:xfrm>
+            <a:off x="6044184" y="2148840"/>
+            <a:ext cx="1581912" cy="914400"/>
           </a:xfrm>
           <a:prstGeom prst="rect">
             <a:avLst/>
@@ -5304,17 +5199,17 @@
               <a:buNone/>
             </a:pPr>
             <a:r>
-              <a:rPr lang="en-US" sz="1050" dirty="0">
-                <a:solidFill>
-                  <a:srgbClr val="71838F"/>
-                </a:solidFill>
-                <a:latin typeface="Calibri" pitchFamily="34" charset="0"/>
-                <a:ea typeface="Calibri" pitchFamily="34" charset="-122"/>
-                <a:cs typeface="Calibri" pitchFamily="34" charset="-120"/>
-              </a:rPr>
-              <a:t>AI multi-source</a:t>
-            </a:r>
-            <a:endParaRPr lang="en-US" sz="1050" dirty="0"/>
+              <a:rPr lang="en-US" sz="1350" b="1" dirty="0">
+                <a:solidFill>
+                  <a:srgbClr val="17313F"/>
+                </a:solidFill>
+                <a:latin typeface="Calibri" pitchFamily="34" charset="0"/>
+                <a:ea typeface="Calibri" pitchFamily="34" charset="-122"/>
+                <a:cs typeface="Calibri" pitchFamily="34" charset="-120"/>
+              </a:rPr>
+              <a:t>AI Investigation</a:t>
+            </a:r>
+            <a:endParaRPr lang="en-US" sz="1350" dirty="0"/>
           </a:p>
           <a:p>
             <a:pPr algn="ctr" indent="0" marL="0">
@@ -5334,48 +5229,153 @@
               </a:rPr>
               <a:t>evidence pack</a:t>
             </a:r>
-            <a:endParaRPr lang="en-US" sz="1050" dirty="0"/>
-          </a:p>
-        </p:txBody>
-      </p:sp>
-      <p:pic>
-        <p:nvPicPr>
-          <p:cNvPr id="21" name="Image 5" descr="preencoded.png">    </p:cNvPr>
-          <p:cNvPicPr>
-            <a:picLocks noChangeAspect="1"/>
-          </p:cNvPicPr>
-          <p:nvPr/>
-        </p:nvPicPr>
-        <p:blipFill>
-          <a:blip r:embed="rId6"/>
-          <a:stretch>
-            <a:fillRect/>
-          </a:stretch>
-        </p:blipFill>
-        <p:spPr>
-          <a:xfrm>
-            <a:off x="7114032" y="3323844"/>
-            <a:ext cx="256032" cy="256032"/>
-          </a:xfrm>
-          <a:prstGeom prst="rect">
-            <a:avLst/>
-          </a:prstGeom>
-        </p:spPr>
-      </p:pic>
-      <p:sp>
-        <p:nvSpPr>
-          <p:cNvPr id="22" name="Shape 14"/>
-          <p:cNvSpPr/>
-          <p:nvPr/>
-        </p:nvSpPr>
-        <p:spPr>
-          <a:xfrm>
-            <a:off x="7392924" y="2286000"/>
-            <a:ext cx="1965960" cy="2331720"/>
+            <a:endParaRPr lang="en-US" sz="1350" dirty="0"/>
+          </a:p>
+        </p:txBody>
+      </p:sp>
+      <p:sp>
+        <p:nvSpPr>
+          <p:cNvPr id="16" name="Shape 14"/>
+          <p:cNvSpPr/>
+          <p:nvPr/>
+        </p:nvSpPr>
+        <p:spPr>
+          <a:xfrm>
+            <a:off x="7680960" y="2606040"/>
+            <a:ext cx="246888" cy="0"/>
+          </a:xfrm>
+          <a:prstGeom prst="line">
+            <a:avLst/>
+          </a:prstGeom>
+          <a:noFill/>
+          <a:ln w="22225">
+            <a:solidFill>
+              <a:srgbClr val="9FB6C0"/>
+            </a:solidFill>
+            <a:prstDash val="solid"/>
+            <a:tailEnd type="triangle"/>
+          </a:ln>
+        </p:spPr>
+      </p:sp>
+      <p:sp>
+        <p:nvSpPr>
+          <p:cNvPr id="17" name="Shape 15"/>
+          <p:cNvSpPr/>
+          <p:nvPr/>
+        </p:nvSpPr>
+        <p:spPr>
+          <a:xfrm>
+            <a:off x="8023860" y="1988820"/>
+            <a:ext cx="1417320" cy="1234440"/>
+          </a:xfrm>
+          <a:prstGeom prst="diamond">
+            <a:avLst/>
+          </a:prstGeom>
+          <a:solidFill>
+            <a:srgbClr val="FFF6E8"/>
+          </a:solidFill>
+          <a:ln w="19050">
+            <a:solidFill>
+              <a:srgbClr val="C9861A"/>
+            </a:solidFill>
+            <a:prstDash val="solid"/>
+          </a:ln>
+        </p:spPr>
+      </p:sp>
+      <p:sp>
+        <p:nvSpPr>
+          <p:cNvPr id="18" name="Text 16"/>
+          <p:cNvSpPr/>
+          <p:nvPr/>
+        </p:nvSpPr>
+        <p:spPr>
+          <a:xfrm>
+            <a:off x="8023860" y="1988820"/>
+            <a:ext cx="1417320" cy="1234440"/>
+          </a:xfrm>
+          <a:prstGeom prst="rect">
+            <a:avLst/>
+          </a:prstGeom>
+          <a:noFill/>
+          <a:ln/>
+        </p:spPr>
+        <p:txBody>
+          <a:bodyPr wrap="square" rtlCol="0" anchor="ctr"/>
+          <a:lstStyle/>
+          <a:p>
+            <a:pPr algn="ctr" indent="0" marL="0">
+              <a:buNone/>
+            </a:pPr>
+            <a:r>
+              <a:rPr lang="en-US" sz="1150" b="1" dirty="0">
+                <a:solidFill>
+                  <a:srgbClr val="8A6115"/>
+                </a:solidFill>
+                <a:latin typeface="Calibri" pitchFamily="34" charset="0"/>
+                <a:ea typeface="Calibri" pitchFamily="34" charset="-122"/>
+                <a:cs typeface="Calibri" pitchFamily="34" charset="-120"/>
+              </a:rPr>
+              <a:t>Money</a:t>
+            </a:r>
+            <a:endParaRPr lang="en-US" sz="1150" dirty="0"/>
+          </a:p>
+          <a:p>
+            <a:pPr algn="ctr" indent="0" marL="0">
+              <a:buNone/>
+            </a:pPr>
+            <a:r>
+              <a:rPr lang="en-US" sz="1150" b="1" dirty="0">
+                <a:solidFill>
+                  <a:srgbClr val="8A6115"/>
+                </a:solidFill>
+                <a:latin typeface="Calibri" pitchFamily="34" charset="0"/>
+                <a:ea typeface="Calibri" pitchFamily="34" charset="-122"/>
+                <a:cs typeface="Calibri" pitchFamily="34" charset="-120"/>
+              </a:rPr>
+              <a:t>laundering?</a:t>
+            </a:r>
+            <a:endParaRPr lang="en-US" sz="1150" dirty="0"/>
+          </a:p>
+        </p:txBody>
+      </p:sp>
+      <p:sp>
+        <p:nvSpPr>
+          <p:cNvPr id="19" name="Shape 17"/>
+          <p:cNvSpPr/>
+          <p:nvPr/>
+        </p:nvSpPr>
+        <p:spPr>
+          <a:xfrm>
+            <a:off x="9445752" y="2606040"/>
+            <a:ext cx="265176" cy="0"/>
+          </a:xfrm>
+          <a:prstGeom prst="line">
+            <a:avLst/>
+          </a:prstGeom>
+          <a:noFill/>
+          <a:ln w="22225">
+            <a:solidFill>
+              <a:srgbClr val="9FB6C0"/>
+            </a:solidFill>
+            <a:prstDash val="solid"/>
+            <a:tailEnd type="triangle"/>
+          </a:ln>
+        </p:spPr>
+      </p:sp>
+      <p:sp>
+        <p:nvSpPr>
+          <p:cNvPr id="20" name="Shape 18"/>
+          <p:cNvSpPr/>
+          <p:nvPr/>
+        </p:nvSpPr>
+        <p:spPr>
+          <a:xfrm>
+            <a:off x="9710928" y="2148840"/>
+            <a:ext cx="1783080" cy="914400"/>
           </a:xfrm>
           <a:prstGeom prst="roundRect">
             <a:avLst>
-              <a:gd name="adj" fmla="val 5581"/>
+              <a:gd name="adj" fmla="val 10000"/>
             </a:avLst>
           </a:prstGeom>
           <a:solidFill>
@@ -5398,97 +5398,14 @@
       </p:sp>
       <p:sp>
         <p:nvSpPr>
-          <p:cNvPr id="23" name="Shape 15"/>
-          <p:cNvSpPr/>
-          <p:nvPr/>
-        </p:nvSpPr>
-        <p:spPr>
-          <a:xfrm>
-            <a:off x="7987284" y="2542032"/>
-            <a:ext cx="777240" cy="777240"/>
-          </a:xfrm>
-          <a:prstGeom prst="ellipse">
-            <a:avLst/>
-          </a:prstGeom>
-          <a:solidFill>
-            <a:srgbClr val="1BA39C"/>
-          </a:solidFill>
-          <a:ln/>
-        </p:spPr>
-      </p:sp>
-      <p:pic>
-        <p:nvPicPr>
-          <p:cNvPr id="24" name="Image 6" descr="preencoded.png">    </p:cNvPr>
-          <p:cNvPicPr>
-            <a:picLocks noChangeAspect="1"/>
-          </p:cNvPicPr>
-          <p:nvPr/>
-        </p:nvPicPr>
-        <p:blipFill>
-          <a:blip r:embed="rId7"/>
-          <a:stretch>
-            <a:fillRect/>
-          </a:stretch>
-        </p:blipFill>
-        <p:spPr>
-          <a:xfrm>
-            <a:off x="8179308" y="2734056"/>
-            <a:ext cx="393192" cy="393192"/>
-          </a:xfrm>
-          <a:prstGeom prst="rect">
-            <a:avLst/>
-          </a:prstGeom>
-        </p:spPr>
-      </p:pic>
-      <p:sp>
-        <p:nvSpPr>
-          <p:cNvPr id="25" name="Text 16"/>
-          <p:cNvSpPr/>
-          <p:nvPr/>
-        </p:nvSpPr>
-        <p:spPr>
-          <a:xfrm>
-            <a:off x="7484364" y="3456432"/>
-            <a:ext cx="1783080" cy="365760"/>
-          </a:xfrm>
-          <a:prstGeom prst="rect">
-            <a:avLst/>
-          </a:prstGeom>
-          <a:noFill/>
-          <a:ln/>
-        </p:spPr>
-        <p:txBody>
-          <a:bodyPr wrap="square" rtlCol="0" anchor="ctr"/>
-          <a:lstStyle/>
-          <a:p>
-            <a:pPr algn="ctr" indent="0" marL="0">
-              <a:buNone/>
-            </a:pPr>
-            <a:r>
-              <a:rPr lang="en-US" sz="1400" b="1" dirty="0">
-                <a:solidFill>
-                  <a:srgbClr val="17313F"/>
-                </a:solidFill>
-                <a:latin typeface="Calibri" pitchFamily="34" charset="0"/>
-                <a:ea typeface="Calibri" pitchFamily="34" charset="-122"/>
-                <a:cs typeface="Calibri" pitchFamily="34" charset="-120"/>
-              </a:rPr>
-              <a:t>4. Confirm</a:t>
-            </a:r>
-            <a:endParaRPr lang="en-US" sz="1400" dirty="0"/>
-          </a:p>
-        </p:txBody>
-      </p:sp>
-      <p:sp>
-        <p:nvSpPr>
-          <p:cNvPr id="26" name="Text 17"/>
-          <p:cNvSpPr/>
-          <p:nvPr/>
-        </p:nvSpPr>
-        <p:spPr>
-          <a:xfrm>
-            <a:off x="7484364" y="3858768"/>
-            <a:ext cx="1783080" cy="640080"/>
+          <p:cNvPr id="21" name="Text 19"/>
+          <p:cNvSpPr/>
+          <p:nvPr/>
+        </p:nvSpPr>
+        <p:spPr>
+          <a:xfrm>
+            <a:off x="9765792" y="2148840"/>
+            <a:ext cx="1673352" cy="914400"/>
           </a:xfrm>
           <a:prstGeom prst="rect">
             <a:avLst/>
@@ -5507,17 +5424,17 @@
               <a:buNone/>
             </a:pPr>
             <a:r>
-              <a:rPr lang="en-US" sz="1050" dirty="0">
-                <a:solidFill>
-                  <a:srgbClr val="71838F"/>
-                </a:solidFill>
-                <a:latin typeface="Calibri" pitchFamily="34" charset="0"/>
-                <a:ea typeface="Calibri" pitchFamily="34" charset="-122"/>
-                <a:cs typeface="Calibri" pitchFamily="34" charset="-120"/>
-              </a:rPr>
-              <a:t>Legal reviews</a:t>
-            </a:r>
-            <a:endParaRPr lang="en-US" sz="1050" dirty="0"/>
+              <a:rPr lang="en-US" sz="1350" b="1" dirty="0">
+                <a:solidFill>
+                  <a:srgbClr val="17313F"/>
+                </a:solidFill>
+                <a:latin typeface="Calibri" pitchFamily="34" charset="0"/>
+                <a:ea typeface="Calibri" pitchFamily="34" charset="-122"/>
+                <a:cs typeface="Calibri" pitchFamily="34" charset="-120"/>
+              </a:rPr>
+              <a:t>Evolve &amp; Learn</a:t>
+            </a:r>
+            <a:endParaRPr lang="en-US" sz="1350" dirty="0"/>
           </a:p>
           <a:p>
             <a:pPr algn="ctr" indent="0" marL="0">
@@ -5535,50 +5452,89 @@
                 <a:ea typeface="Calibri" pitchFamily="34" charset="-122"/>
                 <a:cs typeface="Calibri" pitchFamily="34" charset="-120"/>
               </a:rPr>
-              <a:t>&amp; decides</a:t>
-            </a:r>
-            <a:endParaRPr lang="en-US" sz="1050" dirty="0"/>
-          </a:p>
-        </p:txBody>
-      </p:sp>
-      <p:pic>
-        <p:nvPicPr>
-          <p:cNvPr id="27" name="Image 7" descr="preencoded.png">    </p:cNvPr>
-          <p:cNvPicPr>
-            <a:picLocks noChangeAspect="1"/>
-          </p:cNvPicPr>
-          <p:nvPr/>
-        </p:nvPicPr>
-        <p:blipFill>
-          <a:blip r:embed="rId8"/>
-          <a:stretch>
-            <a:fillRect/>
-          </a:stretch>
-        </p:blipFill>
-        <p:spPr>
-          <a:xfrm>
-            <a:off x="9395460" y="3323844"/>
-            <a:ext cx="256032" cy="256032"/>
-          </a:xfrm>
-          <a:prstGeom prst="rect">
-            <a:avLst/>
-          </a:prstGeom>
-        </p:spPr>
-      </p:pic>
-      <p:sp>
-        <p:nvSpPr>
-          <p:cNvPr id="28" name="Shape 18"/>
-          <p:cNvSpPr/>
-          <p:nvPr/>
-        </p:nvSpPr>
-        <p:spPr>
-          <a:xfrm>
-            <a:off x="9674352" y="2286000"/>
-            <a:ext cx="1965960" cy="2331720"/>
+              <a:t>calibrate · discover</a:t>
+            </a:r>
+            <a:endParaRPr lang="en-US" sz="1350" dirty="0"/>
+          </a:p>
+        </p:txBody>
+      </p:sp>
+      <p:sp>
+        <p:nvSpPr>
+          <p:cNvPr id="22" name="Shape 20"/>
+          <p:cNvSpPr/>
+          <p:nvPr/>
+        </p:nvSpPr>
+        <p:spPr>
+          <a:xfrm>
+            <a:off x="4983480" y="3227832"/>
+            <a:ext cx="0" cy="978408"/>
+          </a:xfrm>
+          <a:prstGeom prst="line">
+            <a:avLst/>
+          </a:prstGeom>
+          <a:noFill/>
+          <a:ln w="22225">
+            <a:solidFill>
+              <a:srgbClr val="9FB6C0"/>
+            </a:solidFill>
+            <a:prstDash val="solid"/>
+            <a:tailEnd type="triangle"/>
+          </a:ln>
+        </p:spPr>
+      </p:sp>
+      <p:sp>
+        <p:nvSpPr>
+          <p:cNvPr id="23" name="Text 21"/>
+          <p:cNvSpPr/>
+          <p:nvPr/>
+        </p:nvSpPr>
+        <p:spPr>
+          <a:xfrm>
+            <a:off x="5074920" y="3246120"/>
+            <a:ext cx="548640" cy="274320"/>
+          </a:xfrm>
+          <a:prstGeom prst="rect">
+            <a:avLst/>
+          </a:prstGeom>
+          <a:noFill/>
+          <a:ln/>
+        </p:spPr>
+        <p:txBody>
+          <a:bodyPr wrap="square" rtlCol="0" anchor="ctr"/>
+          <a:lstStyle/>
+          <a:p>
+            <a:pPr indent="0" marL="0">
+              <a:buNone/>
+            </a:pPr>
+            <a:r>
+              <a:rPr lang="en-US" sz="950" b="1" dirty="0">
+                <a:solidFill>
+                  <a:srgbClr val="5D8AA8"/>
+                </a:solidFill>
+                <a:latin typeface="Calibri" pitchFamily="34" charset="0"/>
+                <a:ea typeface="Calibri" pitchFamily="34" charset="-122"/>
+                <a:cs typeface="Calibri" pitchFamily="34" charset="-120"/>
+              </a:rPr>
+              <a:t>T3</a:t>
+            </a:r>
+            <a:endParaRPr lang="en-US" sz="950" dirty="0"/>
+          </a:p>
+        </p:txBody>
+      </p:sp>
+      <p:sp>
+        <p:nvSpPr>
+          <p:cNvPr id="24" name="Shape 22"/>
+          <p:cNvSpPr/>
+          <p:nvPr/>
+        </p:nvSpPr>
+        <p:spPr>
+          <a:xfrm>
+            <a:off x="4023360" y="4206240"/>
+            <a:ext cx="1920240" cy="777240"/>
           </a:xfrm>
           <a:prstGeom prst="roundRect">
             <a:avLst>
-              <a:gd name="adj" fmla="val 5581"/>
+              <a:gd name="adj" fmla="val 11765"/>
             </a:avLst>
           </a:prstGeom>
           <a:solidFill>
@@ -5590,69 +5546,18 @@
             </a:solidFill>
             <a:prstDash val="solid"/>
           </a:ln>
-          <a:effectLst>
-            <a:outerShdw sx="100000" sy="100000" kx="0" ky="0" algn="bl" rotWithShape="0" blurRad="114300" dist="38100" dir="8100000">
-              <a:srgbClr val="0B1F2A">
-                <a:alpha val="16000"/>
-              </a:srgbClr>
-            </a:outerShdw>
-          </a:effectLst>
-        </p:spPr>
-      </p:sp>
-      <p:sp>
-        <p:nvSpPr>
-          <p:cNvPr id="29" name="Shape 19"/>
-          <p:cNvSpPr/>
-          <p:nvPr/>
-        </p:nvSpPr>
-        <p:spPr>
-          <a:xfrm>
-            <a:off x="10268712" y="2542032"/>
-            <a:ext cx="777240" cy="777240"/>
-          </a:xfrm>
-          <a:prstGeom prst="ellipse">
-            <a:avLst/>
-          </a:prstGeom>
-          <a:solidFill>
-            <a:srgbClr val="1BA39C"/>
-          </a:solidFill>
-          <a:ln/>
-        </p:spPr>
-      </p:sp>
-      <p:pic>
-        <p:nvPicPr>
-          <p:cNvPr id="30" name="Image 8" descr="preencoded.png">    </p:cNvPr>
-          <p:cNvPicPr>
-            <a:picLocks noChangeAspect="1"/>
-          </p:cNvPicPr>
-          <p:nvPr/>
-        </p:nvPicPr>
-        <p:blipFill>
-          <a:blip r:embed="rId9"/>
-          <a:stretch>
-            <a:fillRect/>
-          </a:stretch>
-        </p:blipFill>
-        <p:spPr>
-          <a:xfrm>
-            <a:off x="10460736" y="2734056"/>
-            <a:ext cx="393192" cy="393192"/>
-          </a:xfrm>
-          <a:prstGeom prst="rect">
-            <a:avLst/>
-          </a:prstGeom>
-        </p:spPr>
-      </p:pic>
-      <p:sp>
-        <p:nvSpPr>
-          <p:cNvPr id="31" name="Text 20"/>
-          <p:cNvSpPr/>
-          <p:nvPr/>
-        </p:nvSpPr>
-        <p:spPr>
-          <a:xfrm>
-            <a:off x="9765792" y="3456432"/>
-            <a:ext cx="1783080" cy="365760"/>
+        </p:spPr>
+      </p:sp>
+      <p:sp>
+        <p:nvSpPr>
+          <p:cNvPr id="25" name="Text 23"/>
+          <p:cNvSpPr/>
+          <p:nvPr/>
+        </p:nvSpPr>
+        <p:spPr>
+          <a:xfrm>
+            <a:off x="4069080" y="4206240"/>
+            <a:ext cx="1828800" cy="777240"/>
           </a:xfrm>
           <a:prstGeom prst="rect">
             <a:avLst/>
@@ -5668,7 +5573,7 @@
               <a:buNone/>
             </a:pPr>
             <a:r>
-              <a:rPr lang="en-US" sz="1400" b="1" dirty="0">
+              <a:rPr lang="en-US" sz="1100" dirty="0">
                 <a:solidFill>
                   <a:srgbClr val="17313F"/>
                 </a:solidFill>
@@ -5676,94 +5581,180 @@
                 <a:ea typeface="Calibri" pitchFamily="34" charset="-122"/>
                 <a:cs typeface="Calibri" pitchFamily="34" charset="-120"/>
               </a:rPr>
-              <a:t>5. Evolve</a:t>
-            </a:r>
-            <a:endParaRPr lang="en-US" sz="1400" dirty="0"/>
-          </a:p>
-        </p:txBody>
-      </p:sp>
-      <p:sp>
-        <p:nvSpPr>
-          <p:cNvPr id="32" name="Text 21"/>
-          <p:cNvSpPr/>
-          <p:nvPr/>
-        </p:nvSpPr>
-        <p:spPr>
-          <a:xfrm>
-            <a:off x="9765792" y="3858768"/>
-            <a:ext cx="1783080" cy="640080"/>
-          </a:xfrm>
-          <a:prstGeom prst="rect">
-            <a:avLst/>
-          </a:prstGeom>
-          <a:noFill/>
-          <a:ln/>
-        </p:spPr>
-        <p:txBody>
-          <a:bodyPr wrap="square" rtlCol="0" anchor="ctr"/>
-          <a:lstStyle/>
-          <a:p>
-            <a:pPr algn="ctr" indent="0" marL="0">
-              <a:lnSpc>
-                <a:spcPct val="105000"/>
-              </a:lnSpc>
-              <a:buNone/>
-            </a:pPr>
-            <a:r>
-              <a:rPr lang="en-US" sz="1050" dirty="0">
-                <a:solidFill>
-                  <a:srgbClr val="71838F"/>
-                </a:solidFill>
-                <a:latin typeface="Calibri" pitchFamily="34" charset="0"/>
-                <a:ea typeface="Calibri" pitchFamily="34" charset="-122"/>
-                <a:cs typeface="Calibri" pitchFamily="34" charset="-120"/>
-              </a:rPr>
-              <a:t>Calibrate PPV ·</a:t>
-            </a:r>
-            <a:endParaRPr lang="en-US" sz="1050" dirty="0"/>
-          </a:p>
-          <a:p>
-            <a:pPr algn="ctr" indent="0" marL="0">
-              <a:lnSpc>
-                <a:spcPct val="105000"/>
-              </a:lnSpc>
-              <a:buNone/>
-            </a:pPr>
-            <a:r>
-              <a:rPr lang="en-US" sz="1050" dirty="0">
-                <a:solidFill>
-                  <a:srgbClr val="71838F"/>
-                </a:solidFill>
-                <a:latin typeface="Calibri" pitchFamily="34" charset="0"/>
-                <a:ea typeface="Calibri" pitchFamily="34" charset="-122"/>
-                <a:cs typeface="Calibri" pitchFamily="34" charset="-120"/>
-              </a:rPr>
-              <a:t>discover new signals</a:t>
-            </a:r>
-            <a:endParaRPr lang="en-US" sz="1050" dirty="0"/>
-          </a:p>
-        </p:txBody>
-      </p:sp>
-      <p:sp>
-        <p:nvSpPr>
-          <p:cNvPr id="33" name="Shape 22"/>
-          <p:cNvSpPr/>
-          <p:nvPr/>
-        </p:nvSpPr>
-        <p:spPr>
-          <a:xfrm>
-            <a:off x="548640" y="5074920"/>
-            <a:ext cx="11091672" cy="868680"/>
+              <a:t>Batch score &amp; rank</a:t>
+            </a:r>
+            <a:endParaRPr lang="en-US" sz="1100" dirty="0"/>
+          </a:p>
+        </p:txBody>
+      </p:sp>
+      <p:sp>
+        <p:nvSpPr>
+          <p:cNvPr id="26" name="Shape 24"/>
+          <p:cNvSpPr/>
+          <p:nvPr/>
+        </p:nvSpPr>
+        <p:spPr>
+          <a:xfrm>
+            <a:off x="8732520" y="3227832"/>
+            <a:ext cx="0" cy="978408"/>
+          </a:xfrm>
+          <a:prstGeom prst="line">
+            <a:avLst/>
+          </a:prstGeom>
+          <a:noFill/>
+          <a:ln w="22225">
+            <a:solidFill>
+              <a:srgbClr val="9FB6C0"/>
+            </a:solidFill>
+            <a:prstDash val="solid"/>
+            <a:tailEnd type="triangle"/>
+          </a:ln>
+        </p:spPr>
+      </p:sp>
+      <p:sp>
+        <p:nvSpPr>
+          <p:cNvPr id="27" name="Text 25"/>
+          <p:cNvSpPr/>
+          <p:nvPr/>
+        </p:nvSpPr>
+        <p:spPr>
+          <a:xfrm>
+            <a:off x="8823960" y="3246120"/>
+            <a:ext cx="914400" cy="274320"/>
+          </a:xfrm>
+          <a:prstGeom prst="rect">
+            <a:avLst/>
+          </a:prstGeom>
+          <a:noFill/>
+          <a:ln/>
+        </p:spPr>
+        <p:txBody>
+          <a:bodyPr wrap="square" rtlCol="0" anchor="ctr"/>
+          <a:lstStyle/>
+          <a:p>
+            <a:pPr indent="0" marL="0">
+              <a:buNone/>
+            </a:pPr>
+            <a:r>
+              <a:rPr lang="en-US" sz="950" b="1" dirty="0">
+                <a:solidFill>
+                  <a:srgbClr val="22875A"/>
+                </a:solidFill>
+                <a:latin typeface="Calibri" pitchFamily="34" charset="0"/>
+                <a:ea typeface="Calibri" pitchFamily="34" charset="-122"/>
+                <a:cs typeface="Calibri" pitchFamily="34" charset="-120"/>
+              </a:rPr>
+              <a:t>Yes / No</a:t>
+            </a:r>
+            <a:endParaRPr lang="en-US" sz="950" dirty="0"/>
+          </a:p>
+        </p:txBody>
+      </p:sp>
+      <p:sp>
+        <p:nvSpPr>
+          <p:cNvPr id="28" name="Shape 26"/>
+          <p:cNvSpPr/>
+          <p:nvPr/>
+        </p:nvSpPr>
+        <p:spPr>
+          <a:xfrm>
+            <a:off x="7772400" y="4206240"/>
+            <a:ext cx="1920240" cy="777240"/>
           </a:xfrm>
           <a:prstGeom prst="roundRect">
             <a:avLst>
-              <a:gd name="adj" fmla="val 12632"/>
+              <a:gd name="adj" fmla="val 11765"/>
             </a:avLst>
           </a:prstGeom>
           <a:solidFill>
             <a:srgbClr val="F4FAFB"/>
           </a:solidFill>
-          <a:ln w="15240">
+          <a:ln w="12700">
+            <a:solidFill>
+              <a:srgbClr val="DCE8EE"/>
+            </a:solidFill>
+            <a:prstDash val="solid"/>
+          </a:ln>
+        </p:spPr>
+      </p:sp>
+      <p:sp>
+        <p:nvSpPr>
+          <p:cNvPr id="29" name="Text 27"/>
+          <p:cNvSpPr/>
+          <p:nvPr/>
+        </p:nvSpPr>
+        <p:spPr>
+          <a:xfrm>
+            <a:off x="7818120" y="4206240"/>
+            <a:ext cx="1828800" cy="777240"/>
+          </a:xfrm>
+          <a:prstGeom prst="rect">
+            <a:avLst/>
+          </a:prstGeom>
+          <a:noFill/>
+          <a:ln/>
+        </p:spPr>
+        <p:txBody>
+          <a:bodyPr wrap="square" rtlCol="0" anchor="ctr"/>
+          <a:lstStyle/>
+          <a:p>
+            <a:pPr algn="ctr" indent="0" marL="0">
+              <a:lnSpc>
+                <a:spcPct val="100000"/>
+              </a:lnSpc>
+              <a:buNone/>
+            </a:pPr>
+            <a:r>
+              <a:rPr lang="en-US" sz="1050" dirty="0">
+                <a:solidFill>
+                  <a:srgbClr val="17313F"/>
+                </a:solidFill>
+                <a:latin typeface="Calibri" pitchFamily="34" charset="0"/>
+                <a:ea typeface="Calibri" pitchFamily="34" charset="-122"/>
+                <a:cs typeface="Calibri" pitchFamily="34" charset="-120"/>
+              </a:rPr>
+              <a:t>Decision recorded</a:t>
+            </a:r>
+            <a:endParaRPr lang="en-US" sz="1050" dirty="0"/>
+          </a:p>
+          <a:p>
+            <a:pPr algn="ctr" indent="0" marL="0">
+              <a:lnSpc>
+                <a:spcPct val="100000"/>
+              </a:lnSpc>
+              <a:buNone/>
+            </a:pPr>
+            <a:r>
+              <a:rPr lang="en-US" sz="1050" dirty="0">
+                <a:solidFill>
+                  <a:srgbClr val="17313F"/>
+                </a:solidFill>
+                <a:latin typeface="Calibri" pitchFamily="34" charset="0"/>
+                <a:ea typeface="Calibri" pitchFamily="34" charset="-122"/>
+                <a:cs typeface="Calibri" pitchFamily="34" charset="-120"/>
+              </a:rPr>
+              <a:t>→ feeds learning</a:t>
+            </a:r>
+            <a:endParaRPr lang="en-US" sz="1050" dirty="0"/>
+          </a:p>
+        </p:txBody>
+      </p:sp>
+      <p:sp>
+        <p:nvSpPr>
+          <p:cNvPr id="30" name="Shape 28"/>
+          <p:cNvSpPr/>
+          <p:nvPr/>
+        </p:nvSpPr>
+        <p:spPr>
+          <a:xfrm>
+            <a:off x="10602468" y="3063240"/>
+            <a:ext cx="0" cy="2971800"/>
+          </a:xfrm>
+          <a:prstGeom prst="line">
+            <a:avLst/>
+          </a:prstGeom>
+          <a:noFill/>
+          <a:ln w="20320">
             <a:solidFill>
               <a:srgbClr val="1BA39C"/>
             </a:solidFill>
@@ -5771,64 +5762,63 @@
           </a:ln>
         </p:spPr>
       </p:sp>
-      <p:pic>
-        <p:nvPicPr>
-          <p:cNvPr id="34" name="Image 9" descr="preencoded.png">    </p:cNvPr>
-          <p:cNvPicPr>
-            <a:picLocks noChangeAspect="1"/>
-          </p:cNvPicPr>
-          <p:nvPr/>
-        </p:nvPicPr>
-        <p:blipFill>
-          <a:blip r:embed="rId10"/>
-          <a:stretch>
-            <a:fillRect/>
-          </a:stretch>
-        </p:blipFill>
-        <p:spPr>
-          <a:xfrm flipH="1">
-            <a:off x="841248" y="5358384"/>
-            <a:ext cx="310896" cy="310896"/>
-          </a:xfrm>
-          <a:prstGeom prst="rect">
-            <a:avLst/>
-          </a:prstGeom>
-        </p:spPr>
-      </p:pic>
-      <p:pic>
-        <p:nvPicPr>
-          <p:cNvPr id="35" name="Image 10" descr="preencoded.png">    </p:cNvPr>
-          <p:cNvPicPr>
-            <a:picLocks noChangeAspect="1"/>
-          </p:cNvPicPr>
-          <p:nvPr/>
-        </p:nvPicPr>
-        <p:blipFill>
-          <a:blip r:embed="rId11"/>
-          <a:stretch>
-            <a:fillRect/>
-          </a:stretch>
-        </p:blipFill>
-        <p:spPr>
-          <a:xfrm>
-            <a:off x="1298448" y="5349240"/>
-            <a:ext cx="329184" cy="329184"/>
-          </a:xfrm>
-          <a:prstGeom prst="rect">
-            <a:avLst/>
-          </a:prstGeom>
-        </p:spPr>
-      </p:pic>
-      <p:sp>
-        <p:nvSpPr>
-          <p:cNvPr id="36" name="Text 23"/>
-          <p:cNvSpPr/>
-          <p:nvPr/>
-        </p:nvSpPr>
-        <p:spPr>
-          <a:xfrm>
-            <a:off x="1783080" y="5120640"/>
-            <a:ext cx="9692640" cy="777240"/>
+      <p:sp>
+        <p:nvSpPr>
+          <p:cNvPr id="31" name="Shape 29"/>
+          <p:cNvSpPr/>
+          <p:nvPr/>
+        </p:nvSpPr>
+        <p:spPr>
+          <a:xfrm>
+            <a:off x="3131820" y="6035040"/>
+            <a:ext cx="7470648" cy="0"/>
+          </a:xfrm>
+          <a:prstGeom prst="line">
+            <a:avLst/>
+          </a:prstGeom>
+          <a:noFill/>
+          <a:ln w="20320">
+            <a:solidFill>
+              <a:srgbClr val="1BA39C"/>
+            </a:solidFill>
+            <a:prstDash val="dash"/>
+          </a:ln>
+        </p:spPr>
+      </p:sp>
+      <p:sp>
+        <p:nvSpPr>
+          <p:cNvPr id="32" name="Shape 30"/>
+          <p:cNvSpPr/>
+          <p:nvPr/>
+        </p:nvSpPr>
+        <p:spPr>
+          <a:xfrm>
+            <a:off x="3131820" y="3063240"/>
+            <a:ext cx="0" cy="2971800"/>
+          </a:xfrm>
+          <a:prstGeom prst="line">
+            <a:avLst/>
+          </a:prstGeom>
+          <a:noFill/>
+          <a:ln w="20320">
+            <a:solidFill>
+              <a:srgbClr val="1BA39C"/>
+            </a:solidFill>
+            <a:prstDash val="dash"/>
+            <a:headEnd type="triangle"/>
+          </a:ln>
+        </p:spPr>
+      </p:sp>
+      <p:sp>
+        <p:nvSpPr>
+          <p:cNvPr id="33" name="Text 31"/>
+          <p:cNvSpPr/>
+          <p:nvPr/>
+        </p:nvSpPr>
+        <p:spPr>
+          <a:xfrm>
+            <a:off x="3383280" y="5440680"/>
+            <a:ext cx="7680960" cy="457200"/>
           </a:xfrm>
           <a:prstGeom prst="rect">
             <a:avLst/>
@@ -5842,12 +5832,12 @@
           <a:p>
             <a:pPr indent="0" marL="0">
               <a:lnSpc>
-                <a:spcPct val="110000"/>
+                <a:spcPct val="105000"/>
               </a:lnSpc>
               <a:buNone/>
             </a:pPr>
             <a:r>
-              <a:rPr lang="en-US" sz="1300" b="1" dirty="0">
+              <a:rPr lang="en-US" sz="1150" b="1" dirty="0">
                 <a:solidFill>
                   <a:srgbClr val="1BA39C"/>
                 </a:solidFill>
@@ -5855,16 +5845,16 @@
                 <a:ea typeface="Calibri" pitchFamily="34" charset="-122"/>
                 <a:cs typeface="Calibri" pitchFamily="34" charset="-120"/>
               </a:rPr>
-              <a:t>Continuous loop: </a:t>
+              <a:t>Feedback loop  </a:t>
             </a:r>
             <a:pPr indent="0" marL="0">
               <a:lnSpc>
-                <a:spcPct val="110000"/>
+                <a:spcPct val="105000"/>
               </a:lnSpc>
               <a:buNone/>
             </a:pPr>
             <a:r>
-              <a:rPr lang="en-US" sz="1300" dirty="0">
+              <a:rPr lang="en-US" sz="1150" dirty="0">
                 <a:solidFill>
                   <a:srgbClr val="17313F"/>
                 </a:solidFill>
@@ -5872,15 +5862,15 @@
                 <a:ea typeface="Calibri" pitchFamily="34" charset="-122"/>
                 <a:cs typeface="Calibri" pitchFamily="34" charset="-120"/>
               </a:rPr>
-              <a:t>every confirmation recalibrates tiering and promotes validated new signals — all gated by statistical calibration + human approval.</a:t>
-            </a:r>
-            <a:endParaRPr lang="en-US" sz="1300" dirty="0"/>
-          </a:p>
-        </p:txBody>
-      </p:sp>
-      <p:sp>
-        <p:nvSpPr>
-          <p:cNvPr id="37" name="Text 24"/>
+              <a:t>— validated signals &amp; recalibrated PPV adjust tiering, gated by calibration + human approval.</a:t>
+            </a:r>
+            <a:endParaRPr lang="en-US" sz="1150" dirty="0"/>
+          </a:p>
+        </p:txBody>
+      </p:sp>
+      <p:sp>
+        <p:nvSpPr>
+          <p:cNvPr id="34" name="Text 32"/>
           <p:cNvSpPr/>
           <p:nvPr/>
         </p:nvSpPr>
@@ -5919,7 +5909,7 @@
       </p:sp>
       <p:sp>
         <p:nvSpPr>
-          <p:cNvPr id="38" name="Text 25"/>
+          <p:cNvPr id="35" name="Text 33"/>
           <p:cNvSpPr/>
           <p:nvPr/>
         </p:nvSpPr>

</xml_diff>

<commit_message>
Add third decision diamond to flow slide
Flowchart now has three decision diamonds: Tier level? / Money
laundering? / Sample >= N & PPV ok?. The new gate sits under Evolve &
Learn — No → Keep observing; Yes → promote new signal / adjust tier
via the dashed feedback loop back into Detect + Tier (approval-gated).

Co-Authored-By: Claude Opus 4.8 (1M context) <noreply@anthropic.com>
</commit_message>
<xml_diff>
--- a/ppt/AML-System-Walkthrough-Legal-EN.pptx
+++ b/ppt/AML-System-Walkthrough-Legal-EN.pptx
@@ -4761,7 +4761,7 @@
         </p:nvSpPr>
         <p:spPr>
           <a:xfrm>
-            <a:off x="457200" y="2148840"/>
+            <a:off x="457200" y="1828800"/>
             <a:ext cx="1554480" cy="914400"/>
           </a:xfrm>
           <a:prstGeom prst="roundRect">
@@ -4795,8 +4795,8 @@
         </p:nvSpPr>
         <p:spPr>
           <a:xfrm>
-            <a:off x="512064" y="2148840"/>
-            <a:ext cx="1444752" cy="914400"/>
+            <a:off x="502920" y="1828800"/>
+            <a:ext cx="1463040" cy="914400"/>
           </a:xfrm>
           <a:prstGeom prst="rect">
             <a:avLst/>
@@ -4815,7 +4815,7 @@
               <a:buNone/>
             </a:pPr>
             <a:r>
-              <a:rPr lang="en-US" sz="1350" b="1" dirty="0">
+              <a:rPr lang="en-US" sz="1300" b="1" dirty="0">
                 <a:solidFill>
                   <a:srgbClr val="17313F"/>
                 </a:solidFill>
@@ -4825,7 +4825,7 @@
               </a:rPr>
               <a:t>Payments In</a:t>
             </a:r>
-            <a:endParaRPr lang="en-US" sz="1350" dirty="0"/>
+            <a:endParaRPr lang="en-US" sz="1300" dirty="0"/>
           </a:p>
           <a:p>
             <a:pPr algn="ctr" indent="0" marL="0">
@@ -4845,7 +4845,7 @@
               </a:rPr>
               <a:t>~10K / day</a:t>
             </a:r>
-            <a:endParaRPr lang="en-US" sz="1350" dirty="0"/>
+            <a:endParaRPr lang="en-US" sz="1300" dirty="0"/>
           </a:p>
         </p:txBody>
       </p:sp>
@@ -4857,7 +4857,7 @@
         </p:nvSpPr>
         <p:spPr>
           <a:xfrm>
-            <a:off x="2011680" y="2606040"/>
+            <a:off x="2011680" y="2286000"/>
             <a:ext cx="274320" cy="0"/>
           </a:xfrm>
           <a:prstGeom prst="line">
@@ -4881,7 +4881,7 @@
         </p:nvSpPr>
         <p:spPr>
           <a:xfrm>
-            <a:off x="2286000" y="2148840"/>
+            <a:off x="2286000" y="1828800"/>
             <a:ext cx="1691640" cy="914400"/>
           </a:xfrm>
           <a:prstGeom prst="roundRect">
@@ -4915,8 +4915,8 @@
         </p:nvSpPr>
         <p:spPr>
           <a:xfrm>
-            <a:off x="2340864" y="2148840"/>
-            <a:ext cx="1581912" cy="914400"/>
+            <a:off x="2331720" y="1828800"/>
+            <a:ext cx="1600200" cy="914400"/>
           </a:xfrm>
           <a:prstGeom prst="rect">
             <a:avLst/>
@@ -4935,7 +4935,7 @@
               <a:buNone/>
             </a:pPr>
             <a:r>
-              <a:rPr lang="en-US" sz="1350" b="1" dirty="0">
+              <a:rPr lang="en-US" sz="1300" b="1" dirty="0">
                 <a:solidFill>
                   <a:srgbClr val="17313F"/>
                 </a:solidFill>
@@ -4945,7 +4945,7 @@
               </a:rPr>
               <a:t>Detect + Tier</a:t>
             </a:r>
-            <a:endParaRPr lang="en-US" sz="1350" dirty="0"/>
+            <a:endParaRPr lang="en-US" sz="1300" dirty="0"/>
           </a:p>
           <a:p>
             <a:pPr algn="ctr" indent="0" marL="0">
@@ -4965,7 +4965,7 @@
               </a:rPr>
               <a:t>dual entry</a:t>
             </a:r>
-            <a:endParaRPr lang="en-US" sz="1350" dirty="0"/>
+            <a:endParaRPr lang="en-US" sz="1300" dirty="0"/>
           </a:p>
         </p:txBody>
       </p:sp>
@@ -4977,7 +4977,7 @@
         </p:nvSpPr>
         <p:spPr>
           <a:xfrm>
-            <a:off x="3977640" y="2606040"/>
+            <a:off x="3977640" y="2286000"/>
             <a:ext cx="246888" cy="0"/>
           </a:xfrm>
           <a:prstGeom prst="line">
@@ -5001,8 +5001,8 @@
         </p:nvSpPr>
         <p:spPr>
           <a:xfrm>
-            <a:off x="4274820" y="1988820"/>
-            <a:ext cx="1417320" cy="1234440"/>
+            <a:off x="4251960" y="1682496"/>
+            <a:ext cx="1463040" cy="1207008"/>
           </a:xfrm>
           <a:prstGeom prst="diamond">
             <a:avLst/>
@@ -5026,8 +5026,8 @@
         </p:nvSpPr>
         <p:spPr>
           <a:xfrm>
-            <a:off x="4274820" y="1988820"/>
-            <a:ext cx="1417320" cy="1234440"/>
+            <a:off x="4251960" y="1682496"/>
+            <a:ext cx="1463040" cy="1207008"/>
           </a:xfrm>
           <a:prstGeom prst="rect">
             <a:avLst/>
@@ -5043,7 +5043,7 @@
               <a:buNone/>
             </a:pPr>
             <a:r>
-              <a:rPr lang="en-US" sz="1150" b="1" dirty="0">
+              <a:rPr lang="en-US" sz="1100" b="1" dirty="0">
                 <a:solidFill>
                   <a:srgbClr val="8A6115"/>
                 </a:solidFill>
@@ -5053,14 +5053,14 @@
               </a:rPr>
               <a:t>Tier</a:t>
             </a:r>
-            <a:endParaRPr lang="en-US" sz="1150" dirty="0"/>
+            <a:endParaRPr lang="en-US" sz="1100" dirty="0"/>
           </a:p>
           <a:p>
             <a:pPr algn="ctr" indent="0" marL="0">
               <a:buNone/>
             </a:pPr>
             <a:r>
-              <a:rPr lang="en-US" sz="1150" b="1" dirty="0">
+              <a:rPr lang="en-US" sz="1100" b="1" dirty="0">
                 <a:solidFill>
                   <a:srgbClr val="8A6115"/>
                 </a:solidFill>
@@ -5070,7 +5070,7 @@
               </a:rPr>
               <a:t>level?</a:t>
             </a:r>
-            <a:endParaRPr lang="en-US" sz="1150" dirty="0"/>
+            <a:endParaRPr lang="en-US" sz="1100" dirty="0"/>
           </a:p>
         </p:txBody>
       </p:sp>
@@ -5082,8 +5082,8 @@
         </p:nvSpPr>
         <p:spPr>
           <a:xfrm>
-            <a:off x="5696712" y="2606040"/>
-            <a:ext cx="292608" cy="0"/>
+            <a:off x="5715000" y="2286000"/>
+            <a:ext cx="274320" cy="0"/>
           </a:xfrm>
           <a:prstGeom prst="line">
             <a:avLst/>
@@ -5106,7 +5106,7 @@
         </p:nvSpPr>
         <p:spPr>
           <a:xfrm>
-            <a:off x="5440680" y="1828800"/>
+            <a:off x="5440680" y="1481328"/>
             <a:ext cx="822960" cy="256032"/>
           </a:xfrm>
           <a:prstGeom prst="rect">
@@ -5145,7 +5145,7 @@
         </p:nvSpPr>
         <p:spPr>
           <a:xfrm>
-            <a:off x="5989320" y="2148840"/>
+            <a:off x="5989320" y="1828800"/>
             <a:ext cx="1691640" cy="914400"/>
           </a:xfrm>
           <a:prstGeom prst="roundRect">
@@ -5179,8 +5179,8 @@
         </p:nvSpPr>
         <p:spPr>
           <a:xfrm>
-            <a:off x="6044184" y="2148840"/>
-            <a:ext cx="1581912" cy="914400"/>
+            <a:off x="6035040" y="1828800"/>
+            <a:ext cx="1600200" cy="914400"/>
           </a:xfrm>
           <a:prstGeom prst="rect">
             <a:avLst/>
@@ -5199,7 +5199,7 @@
               <a:buNone/>
             </a:pPr>
             <a:r>
-              <a:rPr lang="en-US" sz="1350" b="1" dirty="0">
+              <a:rPr lang="en-US" sz="1300" b="1" dirty="0">
                 <a:solidFill>
                   <a:srgbClr val="17313F"/>
                 </a:solidFill>
@@ -5209,7 +5209,7 @@
               </a:rPr>
               <a:t>AI Investigation</a:t>
             </a:r>
-            <a:endParaRPr lang="en-US" sz="1350" dirty="0"/>
+            <a:endParaRPr lang="en-US" sz="1300" dirty="0"/>
           </a:p>
           <a:p>
             <a:pPr algn="ctr" indent="0" marL="0">
@@ -5229,7 +5229,7 @@
               </a:rPr>
               <a:t>evidence pack</a:t>
             </a:r>
-            <a:endParaRPr lang="en-US" sz="1350" dirty="0"/>
+            <a:endParaRPr lang="en-US" sz="1300" dirty="0"/>
           </a:p>
         </p:txBody>
       </p:sp>
@@ -5241,7 +5241,7 @@
         </p:nvSpPr>
         <p:spPr>
           <a:xfrm>
-            <a:off x="7680960" y="2606040"/>
+            <a:off x="7680960" y="2286000"/>
             <a:ext cx="246888" cy="0"/>
           </a:xfrm>
           <a:prstGeom prst="line">
@@ -5265,8 +5265,8 @@
         </p:nvSpPr>
         <p:spPr>
           <a:xfrm>
-            <a:off x="8023860" y="1988820"/>
-            <a:ext cx="1417320" cy="1234440"/>
+            <a:off x="8001000" y="1682496"/>
+            <a:ext cx="1463040" cy="1207008"/>
           </a:xfrm>
           <a:prstGeom prst="diamond">
             <a:avLst/>
@@ -5290,8 +5290,8 @@
         </p:nvSpPr>
         <p:spPr>
           <a:xfrm>
-            <a:off x="8023860" y="1988820"/>
-            <a:ext cx="1417320" cy="1234440"/>
+            <a:off x="8001000" y="1682496"/>
+            <a:ext cx="1463040" cy="1207008"/>
           </a:xfrm>
           <a:prstGeom prst="rect">
             <a:avLst/>
@@ -5307,7 +5307,7 @@
               <a:buNone/>
             </a:pPr>
             <a:r>
-              <a:rPr lang="en-US" sz="1150" b="1" dirty="0">
+              <a:rPr lang="en-US" sz="1100" b="1" dirty="0">
                 <a:solidFill>
                   <a:srgbClr val="8A6115"/>
                 </a:solidFill>
@@ -5317,14 +5317,14 @@
               </a:rPr>
               <a:t>Money</a:t>
             </a:r>
-            <a:endParaRPr lang="en-US" sz="1150" dirty="0"/>
+            <a:endParaRPr lang="en-US" sz="1100" dirty="0"/>
           </a:p>
           <a:p>
             <a:pPr algn="ctr" indent="0" marL="0">
               <a:buNone/>
             </a:pPr>
             <a:r>
-              <a:rPr lang="en-US" sz="1150" b="1" dirty="0">
+              <a:rPr lang="en-US" sz="1100" b="1" dirty="0">
                 <a:solidFill>
                   <a:srgbClr val="8A6115"/>
                 </a:solidFill>
@@ -5334,7 +5334,7 @@
               </a:rPr>
               <a:t>laundering?</a:t>
             </a:r>
-            <a:endParaRPr lang="en-US" sz="1150" dirty="0"/>
+            <a:endParaRPr lang="en-US" sz="1100" dirty="0"/>
           </a:p>
         </p:txBody>
       </p:sp>
@@ -5346,8 +5346,8 @@
         </p:nvSpPr>
         <p:spPr>
           <a:xfrm>
-            <a:off x="9445752" y="2606040"/>
-            <a:ext cx="265176" cy="0"/>
+            <a:off x="9464040" y="2286000"/>
+            <a:ext cx="246888" cy="0"/>
           </a:xfrm>
           <a:prstGeom prst="line">
             <a:avLst/>
@@ -5370,7 +5370,7 @@
         </p:nvSpPr>
         <p:spPr>
           <a:xfrm>
-            <a:off x="9710928" y="2148840"/>
+            <a:off x="9710928" y="1828800"/>
             <a:ext cx="1783080" cy="914400"/>
           </a:xfrm>
           <a:prstGeom prst="roundRect">
@@ -5404,8 +5404,8 @@
         </p:nvSpPr>
         <p:spPr>
           <a:xfrm>
-            <a:off x="9765792" y="2148840"/>
-            <a:ext cx="1673352" cy="914400"/>
+            <a:off x="9756648" y="1828800"/>
+            <a:ext cx="1691640" cy="914400"/>
           </a:xfrm>
           <a:prstGeom prst="rect">
             <a:avLst/>
@@ -5424,7 +5424,7 @@
               <a:buNone/>
             </a:pPr>
             <a:r>
-              <a:rPr lang="en-US" sz="1350" b="1" dirty="0">
+              <a:rPr lang="en-US" sz="1300" b="1" dirty="0">
                 <a:solidFill>
                   <a:srgbClr val="17313F"/>
                 </a:solidFill>
@@ -5434,7 +5434,7 @@
               </a:rPr>
               <a:t>Evolve &amp; Learn</a:t>
             </a:r>
-            <a:endParaRPr lang="en-US" sz="1350" dirty="0"/>
+            <a:endParaRPr lang="en-US" sz="1300" dirty="0"/>
           </a:p>
           <a:p>
             <a:pPr algn="ctr" indent="0" marL="0">
@@ -5454,7 +5454,7 @@
               </a:rPr>
               <a:t>calibrate · discover</a:t>
             </a:r>
-            <a:endParaRPr lang="en-US" sz="1350" dirty="0"/>
+            <a:endParaRPr lang="en-US" sz="1300" dirty="0"/>
           </a:p>
         </p:txBody>
       </p:sp>
@@ -5466,8 +5466,8 @@
         </p:nvSpPr>
         <p:spPr>
           <a:xfrm>
-            <a:off x="4983480" y="3227832"/>
-            <a:ext cx="0" cy="978408"/>
+            <a:off x="4983480" y="2889504"/>
+            <a:ext cx="0" cy="539496"/>
           </a:xfrm>
           <a:prstGeom prst="line">
             <a:avLst/>
@@ -5490,8 +5490,8 @@
         </p:nvSpPr>
         <p:spPr>
           <a:xfrm>
-            <a:off x="5074920" y="3246120"/>
-            <a:ext cx="548640" cy="274320"/>
+            <a:off x="5074920" y="2907792"/>
+            <a:ext cx="548640" cy="256032"/>
           </a:xfrm>
           <a:prstGeom prst="rect">
             <a:avLst/>
@@ -5529,12 +5529,12 @@
         </p:nvSpPr>
         <p:spPr>
           <a:xfrm>
-            <a:off x="4023360" y="4206240"/>
-            <a:ext cx="1920240" cy="777240"/>
+            <a:off x="4069080" y="3429000"/>
+            <a:ext cx="1828800" cy="685800"/>
           </a:xfrm>
           <a:prstGeom prst="roundRect">
             <a:avLst>
-              <a:gd name="adj" fmla="val 11765"/>
+              <a:gd name="adj" fmla="val 13333"/>
             </a:avLst>
           </a:prstGeom>
           <a:solidFill>
@@ -5546,6 +5546,13 @@
             </a:solidFill>
             <a:prstDash val="solid"/>
           </a:ln>
+          <a:effectLst>
+            <a:outerShdw sx="100000" sy="100000" kx="0" ky="0" algn="bl" rotWithShape="0" blurRad="114300" dist="38100" dir="8100000">
+              <a:srgbClr val="0B1F2A">
+                <a:alpha val="16000"/>
+              </a:srgbClr>
+            </a:outerShdw>
+          </a:effectLst>
         </p:spPr>
       </p:sp>
       <p:sp>
@@ -5556,8 +5563,8 @@
         </p:nvSpPr>
         <p:spPr>
           <a:xfrm>
-            <a:off x="4069080" y="4206240"/>
-            <a:ext cx="1828800" cy="777240"/>
+            <a:off x="4114800" y="3429000"/>
+            <a:ext cx="1737360" cy="685800"/>
           </a:xfrm>
           <a:prstGeom prst="rect">
             <a:avLst/>
@@ -5570,10 +5577,13 @@
           <a:lstStyle/>
           <a:p>
             <a:pPr algn="ctr" indent="0" marL="0">
-              <a:buNone/>
-            </a:pPr>
-            <a:r>
-              <a:rPr lang="en-US" sz="1100" dirty="0">
+              <a:lnSpc>
+                <a:spcPct val="105000"/>
+              </a:lnSpc>
+              <a:buNone/>
+            </a:pPr>
+            <a:r>
+              <a:rPr lang="en-US" sz="1300" b="1" dirty="0">
                 <a:solidFill>
                   <a:srgbClr val="17313F"/>
                 </a:solidFill>
@@ -5583,7 +5593,7 @@
               </a:rPr>
               <a:t>Batch score &amp; rank</a:t>
             </a:r>
-            <a:endParaRPr lang="en-US" sz="1100" dirty="0"/>
+            <a:endParaRPr lang="en-US" sz="1300" dirty="0"/>
           </a:p>
         </p:txBody>
       </p:sp>
@@ -5595,8 +5605,8 @@
         </p:nvSpPr>
         <p:spPr>
           <a:xfrm>
-            <a:off x="8732520" y="3227832"/>
-            <a:ext cx="0" cy="978408"/>
+            <a:off x="8732520" y="2889504"/>
+            <a:ext cx="0" cy="539496"/>
           </a:xfrm>
           <a:prstGeom prst="line">
             <a:avLst/>
@@ -5619,8 +5629,8 @@
         </p:nvSpPr>
         <p:spPr>
           <a:xfrm>
-            <a:off x="8823960" y="3246120"/>
-            <a:ext cx="914400" cy="274320"/>
+            <a:off x="8823960" y="2907792"/>
+            <a:ext cx="914400" cy="256032"/>
           </a:xfrm>
           <a:prstGeom prst="rect">
             <a:avLst/>
@@ -5658,12 +5668,12 @@
         </p:nvSpPr>
         <p:spPr>
           <a:xfrm>
-            <a:off x="7772400" y="4206240"/>
-            <a:ext cx="1920240" cy="777240"/>
+            <a:off x="7772400" y="3429000"/>
+            <a:ext cx="1920240" cy="685800"/>
           </a:xfrm>
           <a:prstGeom prst="roundRect">
             <a:avLst>
-              <a:gd name="adj" fmla="val 11765"/>
+              <a:gd name="adj" fmla="val 13333"/>
             </a:avLst>
           </a:prstGeom>
           <a:solidFill>
@@ -5675,6 +5685,13 @@
             </a:solidFill>
             <a:prstDash val="solid"/>
           </a:ln>
+          <a:effectLst>
+            <a:outerShdw sx="100000" sy="100000" kx="0" ky="0" algn="bl" rotWithShape="0" blurRad="114300" dist="38100" dir="8100000">
+              <a:srgbClr val="0B1F2A">
+                <a:alpha val="16000"/>
+              </a:srgbClr>
+            </a:outerShdw>
+          </a:effectLst>
         </p:spPr>
       </p:sp>
       <p:sp>
@@ -5685,8 +5702,8 @@
         </p:nvSpPr>
         <p:spPr>
           <a:xfrm>
-            <a:off x="7818120" y="4206240"/>
-            <a:ext cx="1828800" cy="777240"/>
+            <a:off x="7818120" y="3429000"/>
+            <a:ext cx="1828800" cy="685800"/>
           </a:xfrm>
           <a:prstGeom prst="rect">
             <a:avLst/>
@@ -5700,12 +5717,12 @@
           <a:p>
             <a:pPr algn="ctr" indent="0" marL="0">
               <a:lnSpc>
-                <a:spcPct val="100000"/>
+                <a:spcPct val="105000"/>
               </a:lnSpc>
               <a:buNone/>
             </a:pPr>
             <a:r>
-              <a:rPr lang="en-US" sz="1050" dirty="0">
+              <a:rPr lang="en-US" sz="1300" b="1" dirty="0">
                 <a:solidFill>
                   <a:srgbClr val="17313F"/>
                 </a:solidFill>
@@ -5713,19 +5730,243 @@
                 <a:ea typeface="Calibri" pitchFamily="34" charset="-122"/>
                 <a:cs typeface="Calibri" pitchFamily="34" charset="-120"/>
               </a:rPr>
-              <a:t>Decision recorded</a:t>
-            </a:r>
-            <a:endParaRPr lang="en-US" sz="1050" dirty="0"/>
-          </a:p>
+              <a:t>Decision recorded → learning</a:t>
+            </a:r>
+            <a:endParaRPr lang="en-US" sz="1300" dirty="0"/>
+          </a:p>
+        </p:txBody>
+      </p:sp>
+      <p:sp>
+        <p:nvSpPr>
+          <p:cNvPr id="30" name="Shape 28"/>
+          <p:cNvSpPr/>
+          <p:nvPr/>
+        </p:nvSpPr>
+        <p:spPr>
+          <a:xfrm>
+            <a:off x="10602468" y="2743200"/>
+            <a:ext cx="0" cy="1591056"/>
+          </a:xfrm>
+          <a:prstGeom prst="line">
+            <a:avLst/>
+          </a:prstGeom>
+          <a:noFill/>
+          <a:ln w="22225">
+            <a:solidFill>
+              <a:srgbClr val="9FB6C0"/>
+            </a:solidFill>
+            <a:prstDash val="solid"/>
+            <a:tailEnd type="triangle"/>
+          </a:ln>
+        </p:spPr>
+      </p:sp>
+      <p:sp>
+        <p:nvSpPr>
+          <p:cNvPr id="31" name="Shape 29"/>
+          <p:cNvSpPr/>
+          <p:nvPr/>
+        </p:nvSpPr>
+        <p:spPr>
+          <a:xfrm>
+            <a:off x="9870948" y="4334256"/>
+            <a:ext cx="1463040" cy="1207008"/>
+          </a:xfrm>
+          <a:prstGeom prst="diamond">
+            <a:avLst/>
+          </a:prstGeom>
+          <a:solidFill>
+            <a:srgbClr val="FFF6E8"/>
+          </a:solidFill>
+          <a:ln w="19050">
+            <a:solidFill>
+              <a:srgbClr val="C9861A"/>
+            </a:solidFill>
+            <a:prstDash val="solid"/>
+          </a:ln>
+        </p:spPr>
+      </p:sp>
+      <p:sp>
+        <p:nvSpPr>
+          <p:cNvPr id="32" name="Text 30"/>
+          <p:cNvSpPr/>
+          <p:nvPr/>
+        </p:nvSpPr>
+        <p:spPr>
+          <a:xfrm>
+            <a:off x="9870948" y="4334256"/>
+            <a:ext cx="1463040" cy="1207008"/>
+          </a:xfrm>
+          <a:prstGeom prst="rect">
+            <a:avLst/>
+          </a:prstGeom>
+          <a:noFill/>
+          <a:ln/>
+        </p:spPr>
+        <p:txBody>
+          <a:bodyPr wrap="square" rtlCol="0" anchor="ctr"/>
+          <a:lstStyle/>
+          <a:p>
+            <a:pPr algn="ctr" indent="0" marL="0">
+              <a:buNone/>
+            </a:pPr>
+            <a:r>
+              <a:rPr lang="en-US" sz="1100" b="1" dirty="0">
+                <a:solidFill>
+                  <a:srgbClr val="8A6115"/>
+                </a:solidFill>
+                <a:latin typeface="Calibri" pitchFamily="34" charset="0"/>
+                <a:ea typeface="Calibri" pitchFamily="34" charset="-122"/>
+                <a:cs typeface="Calibri" pitchFamily="34" charset="-120"/>
+              </a:rPr>
+              <a:t>Sample ≥ N</a:t>
+            </a:r>
+            <a:endParaRPr lang="en-US" sz="1100" dirty="0"/>
+          </a:p>
+          <a:p>
+            <a:pPr algn="ctr" indent="0" marL="0">
+              <a:buNone/>
+            </a:pPr>
+            <a:r>
+              <a:rPr lang="en-US" sz="1100" b="1" dirty="0">
+                <a:solidFill>
+                  <a:srgbClr val="8A6115"/>
+                </a:solidFill>
+                <a:latin typeface="Calibri" pitchFamily="34" charset="0"/>
+                <a:ea typeface="Calibri" pitchFamily="34" charset="-122"/>
+                <a:cs typeface="Calibri" pitchFamily="34" charset="-120"/>
+              </a:rPr>
+              <a:t>&amp; PPV ok?</a:t>
+            </a:r>
+            <a:endParaRPr lang="en-US" sz="1100" dirty="0"/>
+          </a:p>
+        </p:txBody>
+      </p:sp>
+      <p:sp>
+        <p:nvSpPr>
+          <p:cNvPr id="33" name="Shape 31"/>
+          <p:cNvSpPr/>
+          <p:nvPr/>
+        </p:nvSpPr>
+        <p:spPr>
+          <a:xfrm>
+            <a:off x="9870948" y="4937760"/>
+            <a:ext cx="-269748" cy="0"/>
+          </a:xfrm>
+          <a:prstGeom prst="line">
+            <a:avLst/>
+          </a:prstGeom>
+          <a:noFill/>
+          <a:ln w="22225">
+            <a:solidFill>
+              <a:srgbClr val="9FB6C0"/>
+            </a:solidFill>
+            <a:prstDash val="solid"/>
+            <a:tailEnd type="triangle"/>
+          </a:ln>
+        </p:spPr>
+      </p:sp>
+      <p:sp>
+        <p:nvSpPr>
+          <p:cNvPr id="34" name="Text 32"/>
+          <p:cNvSpPr/>
+          <p:nvPr/>
+        </p:nvSpPr>
+        <p:spPr>
+          <a:xfrm>
+            <a:off x="9646920" y="4553712"/>
+            <a:ext cx="457200" cy="237744"/>
+          </a:xfrm>
+          <a:prstGeom prst="rect">
+            <a:avLst/>
+          </a:prstGeom>
+          <a:noFill/>
+          <a:ln/>
+        </p:spPr>
+        <p:txBody>
+          <a:bodyPr wrap="square" rtlCol="0" anchor="ctr"/>
+          <a:lstStyle/>
+          <a:p>
+            <a:pPr algn="ctr" indent="0" marL="0">
+              <a:buNone/>
+            </a:pPr>
+            <a:r>
+              <a:rPr lang="en-US" sz="950" b="1" dirty="0">
+                <a:solidFill>
+                  <a:srgbClr val="71838F"/>
+                </a:solidFill>
+                <a:latin typeface="Calibri" pitchFamily="34" charset="0"/>
+                <a:ea typeface="Calibri" pitchFamily="34" charset="-122"/>
+                <a:cs typeface="Calibri" pitchFamily="34" charset="-120"/>
+              </a:rPr>
+              <a:t>No</a:t>
+            </a:r>
+            <a:endParaRPr lang="en-US" sz="950" dirty="0"/>
+          </a:p>
+        </p:txBody>
+      </p:sp>
+      <p:sp>
+        <p:nvSpPr>
+          <p:cNvPr id="35" name="Shape 33"/>
+          <p:cNvSpPr/>
+          <p:nvPr/>
+        </p:nvSpPr>
+        <p:spPr>
+          <a:xfrm>
+            <a:off x="7680960" y="4617720"/>
+            <a:ext cx="1920240" cy="640080"/>
+          </a:xfrm>
+          <a:prstGeom prst="roundRect">
+            <a:avLst>
+              <a:gd name="adj" fmla="val 14286"/>
+            </a:avLst>
+          </a:prstGeom>
+          <a:solidFill>
+            <a:srgbClr val="F4FAFB"/>
+          </a:solidFill>
+          <a:ln w="12700">
+            <a:solidFill>
+              <a:srgbClr val="DCE8EE"/>
+            </a:solidFill>
+            <a:prstDash val="solid"/>
+          </a:ln>
+          <a:effectLst>
+            <a:outerShdw sx="100000" sy="100000" kx="0" ky="0" algn="bl" rotWithShape="0" blurRad="114300" dist="38100" dir="8100000">
+              <a:srgbClr val="0B1F2A">
+                <a:alpha val="16000"/>
+              </a:srgbClr>
+            </a:outerShdw>
+          </a:effectLst>
+        </p:spPr>
+      </p:sp>
+      <p:sp>
+        <p:nvSpPr>
+          <p:cNvPr id="36" name="Text 34"/>
+          <p:cNvSpPr/>
+          <p:nvPr/>
+        </p:nvSpPr>
+        <p:spPr>
+          <a:xfrm>
+            <a:off x="7726680" y="4617720"/>
+            <a:ext cx="1828800" cy="640080"/>
+          </a:xfrm>
+          <a:prstGeom prst="rect">
+            <a:avLst/>
+          </a:prstGeom>
+          <a:noFill/>
+          <a:ln/>
+        </p:spPr>
+        <p:txBody>
+          <a:bodyPr wrap="square" rtlCol="0" anchor="ctr"/>
+          <a:lstStyle/>
           <a:p>
             <a:pPr algn="ctr" indent="0" marL="0">
               <a:lnSpc>
-                <a:spcPct val="100000"/>
+                <a:spcPct val="105000"/>
               </a:lnSpc>
               <a:buNone/>
             </a:pPr>
             <a:r>
-              <a:rPr lang="en-US" sz="1050" dirty="0">
+              <a:rPr lang="en-US" sz="1300" b="1" dirty="0">
                 <a:solidFill>
                   <a:srgbClr val="17313F"/>
                 </a:solidFill>
@@ -5733,28 +5974,67 @@
                 <a:ea typeface="Calibri" pitchFamily="34" charset="-122"/>
                 <a:cs typeface="Calibri" pitchFamily="34" charset="-120"/>
               </a:rPr>
-              <a:t>→ feeds learning</a:t>
-            </a:r>
-            <a:endParaRPr lang="en-US" sz="1050" dirty="0"/>
-          </a:p>
-        </p:txBody>
-      </p:sp>
-      <p:sp>
-        <p:nvSpPr>
-          <p:cNvPr id="30" name="Shape 28"/>
-          <p:cNvSpPr/>
-          <p:nvPr/>
-        </p:nvSpPr>
-        <p:spPr>
-          <a:xfrm>
-            <a:off x="10602468" y="3063240"/>
-            <a:ext cx="0" cy="2971800"/>
+              <a:t>Keep observing</a:t>
+            </a:r>
+            <a:endParaRPr lang="en-US" sz="1300" dirty="0"/>
+          </a:p>
+        </p:txBody>
+      </p:sp>
+      <p:sp>
+        <p:nvSpPr>
+          <p:cNvPr id="37" name="Text 35"/>
+          <p:cNvSpPr/>
+          <p:nvPr/>
+        </p:nvSpPr>
+        <p:spPr>
+          <a:xfrm>
+            <a:off x="10698480" y="5394960"/>
+            <a:ext cx="640080" cy="237744"/>
+          </a:xfrm>
+          <a:prstGeom prst="rect">
+            <a:avLst/>
+          </a:prstGeom>
+          <a:noFill/>
+          <a:ln/>
+        </p:spPr>
+        <p:txBody>
+          <a:bodyPr wrap="square" rtlCol="0" anchor="ctr"/>
+          <a:lstStyle/>
+          <a:p>
+            <a:pPr indent="0" marL="0">
+              <a:buNone/>
+            </a:pPr>
+            <a:r>
+              <a:rPr lang="en-US" sz="950" b="1" dirty="0">
+                <a:solidFill>
+                  <a:srgbClr val="22875A"/>
+                </a:solidFill>
+                <a:latin typeface="Calibri" pitchFamily="34" charset="0"/>
+                <a:ea typeface="Calibri" pitchFamily="34" charset="-122"/>
+                <a:cs typeface="Calibri" pitchFamily="34" charset="-120"/>
+              </a:rPr>
+              <a:t>Yes</a:t>
+            </a:r>
+            <a:endParaRPr lang="en-US" sz="950" dirty="0"/>
+          </a:p>
+        </p:txBody>
+      </p:sp>
+      <p:sp>
+        <p:nvSpPr>
+          <p:cNvPr id="38" name="Shape 36"/>
+          <p:cNvSpPr/>
+          <p:nvPr/>
+        </p:nvSpPr>
+        <p:spPr>
+          <a:xfrm>
+            <a:off x="10602468" y="5541264"/>
+            <a:ext cx="0" cy="448056"/>
           </a:xfrm>
           <a:prstGeom prst="line">
             <a:avLst/>
           </a:prstGeom>
           <a:noFill/>
-          <a:ln w="20320">
+          <a:ln w="21590">
             <a:solidFill>
               <a:srgbClr val="1BA39C"/>
             </a:solidFill>
@@ -5764,20 +6044,20 @@
       </p:sp>
       <p:sp>
         <p:nvSpPr>
-          <p:cNvPr id="31" name="Shape 29"/>
-          <p:cNvSpPr/>
-          <p:nvPr/>
-        </p:nvSpPr>
-        <p:spPr>
-          <a:xfrm>
-            <a:off x="3131820" y="6035040"/>
+          <p:cNvPr id="39" name="Shape 37"/>
+          <p:cNvSpPr/>
+          <p:nvPr/>
+        </p:nvSpPr>
+        <p:spPr>
+          <a:xfrm>
+            <a:off x="3131820" y="5989320"/>
             <a:ext cx="7470648" cy="0"/>
           </a:xfrm>
           <a:prstGeom prst="line">
             <a:avLst/>
           </a:prstGeom>
           <a:noFill/>
-          <a:ln w="20320">
+          <a:ln w="21590">
             <a:solidFill>
               <a:srgbClr val="1BA39C"/>
             </a:solidFill>
@@ -5787,20 +6067,20 @@
       </p:sp>
       <p:sp>
         <p:nvSpPr>
-          <p:cNvPr id="32" name="Shape 30"/>
-          <p:cNvSpPr/>
-          <p:nvPr/>
-        </p:nvSpPr>
-        <p:spPr>
-          <a:xfrm>
-            <a:off x="3131820" y="3063240"/>
-            <a:ext cx="0" cy="2971800"/>
+          <p:cNvPr id="40" name="Shape 38"/>
+          <p:cNvSpPr/>
+          <p:nvPr/>
+        </p:nvSpPr>
+        <p:spPr>
+          <a:xfrm>
+            <a:off x="3131820" y="2743200"/>
+            <a:ext cx="0" cy="3246120"/>
           </a:xfrm>
           <a:prstGeom prst="line">
             <a:avLst/>
           </a:prstGeom>
           <a:noFill/>
-          <a:ln w="20320">
+          <a:ln w="21590">
             <a:solidFill>
               <a:srgbClr val="1BA39C"/>
             </a:solidFill>
@@ -5811,14 +6091,14 @@
       </p:sp>
       <p:sp>
         <p:nvSpPr>
-          <p:cNvPr id="33" name="Text 31"/>
-          <p:cNvSpPr/>
-          <p:nvPr/>
-        </p:nvSpPr>
-        <p:spPr>
-          <a:xfrm>
-            <a:off x="3383280" y="5440680"/>
-            <a:ext cx="7680960" cy="457200"/>
+          <p:cNvPr id="41" name="Text 39"/>
+          <p:cNvSpPr/>
+          <p:nvPr/>
+        </p:nvSpPr>
+        <p:spPr>
+          <a:xfrm>
+            <a:off x="3383280" y="5596128"/>
+            <a:ext cx="7863840" cy="365760"/>
           </a:xfrm>
           <a:prstGeom prst="rect">
             <a:avLst/>
@@ -5831,9 +6111,6 @@
           <a:lstStyle/>
           <a:p>
             <a:pPr indent="0" marL="0">
-              <a:lnSpc>
-                <a:spcPct val="105000"/>
-              </a:lnSpc>
               <a:buNone/>
             </a:pPr>
             <a:r>
@@ -5845,12 +6122,9 @@
                 <a:ea typeface="Calibri" pitchFamily="34" charset="-122"/>
                 <a:cs typeface="Calibri" pitchFamily="34" charset="-120"/>
               </a:rPr>
-              <a:t>Feedback loop  </a:t>
+              <a:t>Promote new signal / adjust tier  </a:t>
             </a:r>
             <a:pPr indent="0" marL="0">
-              <a:lnSpc>
-                <a:spcPct val="105000"/>
-              </a:lnSpc>
               <a:buNone/>
             </a:pPr>
             <a:r>
@@ -5862,7 +6136,7 @@
                 <a:ea typeface="Calibri" pitchFamily="34" charset="-122"/>
                 <a:cs typeface="Calibri" pitchFamily="34" charset="-120"/>
               </a:rPr>
-              <a:t>— validated signals &amp; recalibrated PPV adjust tiering, gated by calibration + human approval.</a:t>
+              <a:t>— gated by statistical calibration + human approval.</a:t>
             </a:r>
             <a:endParaRPr lang="en-US" sz="1150" dirty="0"/>
           </a:p>
@@ -5870,7 +6144,7 @@
       </p:sp>
       <p:sp>
         <p:nvSpPr>
-          <p:cNvPr id="34" name="Text 32"/>
+          <p:cNvPr id="42" name="Text 40"/>
           <p:cNvSpPr/>
           <p:nvPr/>
         </p:nvSpPr>
@@ -5909,7 +6183,7 @@
       </p:sp>
       <p:sp>
         <p:nvSpPr>
-          <p:cNvPr id="35" name="Text 33"/>
+          <p:cNvPr id="43" name="Text 41"/>
           <p:cNvSpPr/>
           <p:nvPr/>
         </p:nvSpPr>

</xml_diff>